<commit_message>
Restyle architecture diagram: GitHub flow as proper boxes (slide 4)
GitHub and GitHub Actions were a footer note in plain italic text
while every other piece (Vercel, Browser, the 4 services) had a styled
box. Visually weak compared to the rest.

New layout treats them as first-class nodes:

              [Navigateur]
                   ↓
[GitHub] → [Actions] → [VERCEL]
                          ↓
       [Airtable] [Resend] [Redis] [Sentry]

Vercel stays the dark hub in the center; three flows feed in/out:
- Browser arrives from above
- GitHub → GitHub Actions feeds in from the left
- Services fan out below

Each non-hub node uses a 2-line label (name + role) to keep the
visual rhythm consistent.

Co-Authored-By: Claude Opus 4.7 (1M context) <noreply@anthropic.com>
</commit_message>
<xml_diff>
--- a/docs/pulse-presentation.pptx
+++ b/docs/pulse-presentation.pptx
@@ -5815,8 +5815,8 @@
         </p:nvSpPr>
         <p:spPr>
           <a:xfrm>
-            <a:off x="4434840" y="2377440"/>
-            <a:ext cx="3291840" cy="731520"/>
+            <a:off x="4526280" y="2377440"/>
+            <a:ext cx="3108960" cy="777240"/>
           </a:xfrm>
           <a:prstGeom prst="rect">
             <a:avLst/>
@@ -5840,8 +5840,8 @@
         </p:nvSpPr>
         <p:spPr>
           <a:xfrm>
-            <a:off x="4434840" y="2395728"/>
-            <a:ext cx="3291840" cy="329184"/>
+            <a:off x="4526280" y="2468880"/>
+            <a:ext cx="3108960" cy="349758"/>
           </a:xfrm>
           <a:prstGeom prst="rect">
             <a:avLst/>
@@ -5879,8 +5879,8 @@
         </p:nvSpPr>
         <p:spPr>
           <a:xfrm>
-            <a:off x="4434840" y="2724912"/>
-            <a:ext cx="3291840" cy="329184"/>
+            <a:off x="4526280" y="2766060"/>
+            <a:ext cx="3108960" cy="349758"/>
           </a:xfrm>
           <a:prstGeom prst="rect">
             <a:avLst/>
@@ -5941,8 +5941,260 @@
         </p:nvSpPr>
         <p:spPr>
           <a:xfrm>
-            <a:off x="3977640" y="3611880"/>
-            <a:ext cx="4206240" cy="914400"/>
+            <a:off x="640080" y="3680460"/>
+            <a:ext cx="1508760" cy="777240"/>
+          </a:xfrm>
+          <a:prstGeom prst="rect">
+            <a:avLst/>
+          </a:prstGeom>
+          <a:solidFill>
+            <a:srgbClr val="F7F7F5"/>
+          </a:solidFill>
+          <a:ln w="12700">
+            <a:solidFill>
+              <a:srgbClr val="D8D8D5"/>
+            </a:solidFill>
+            <a:prstDash val="solid"/>
+          </a:ln>
+        </p:spPr>
+      </p:sp>
+      <p:sp>
+        <p:nvSpPr>
+          <p:cNvPr id="10" name="Text 8"/>
+          <p:cNvSpPr/>
+          <p:nvPr/>
+        </p:nvSpPr>
+        <p:spPr>
+          <a:xfrm>
+            <a:off x="640080" y="3771900"/>
+            <a:ext cx="1508760" cy="349758"/>
+          </a:xfrm>
+          <a:prstGeom prst="rect">
+            <a:avLst/>
+          </a:prstGeom>
+          <a:noFill/>
+          <a:ln/>
+        </p:spPr>
+        <p:txBody>
+          <a:bodyPr wrap="square" lIns="0" tIns="0" rIns="0" bIns="0" rtlCol="0" anchor="b"/>
+          <a:lstStyle/>
+          <a:p>
+            <a:pPr algn="ctr" indent="0" marL="0">
+              <a:buNone/>
+            </a:pPr>
+            <a:r>
+              <a:rPr lang="en-US" sz="1300" b="1" dirty="0">
+                <a:solidFill>
+                  <a:srgbClr val="1A1A1A"/>
+                </a:solidFill>
+                <a:latin typeface="Helvetica Neue" pitchFamily="34" charset="0"/>
+                <a:ea typeface="Helvetica Neue" pitchFamily="34" charset="-122"/>
+                <a:cs typeface="Helvetica Neue" pitchFamily="34" charset="-120"/>
+              </a:rPr>
+              <a:t>GitHub</a:t>
+            </a:r>
+            <a:endParaRPr lang="en-US" sz="1300" dirty="0"/>
+          </a:p>
+        </p:txBody>
+      </p:sp>
+      <p:sp>
+        <p:nvSpPr>
+          <p:cNvPr id="11" name="Text 9"/>
+          <p:cNvSpPr/>
+          <p:nvPr/>
+        </p:nvSpPr>
+        <p:spPr>
+          <a:xfrm>
+            <a:off x="640080" y="4069080"/>
+            <a:ext cx="1508760" cy="349758"/>
+          </a:xfrm>
+          <a:prstGeom prst="rect">
+            <a:avLst/>
+          </a:prstGeom>
+          <a:noFill/>
+          <a:ln/>
+        </p:spPr>
+        <p:txBody>
+          <a:bodyPr wrap="square" lIns="0" tIns="0" rIns="0" bIns="0" rtlCol="0" anchor="t"/>
+          <a:lstStyle/>
+          <a:p>
+            <a:pPr algn="ctr" indent="0" marL="0">
+              <a:buNone/>
+            </a:pPr>
+            <a:r>
+              <a:rPr lang="en-US" sz="1000" dirty="0">
+                <a:solidFill>
+                  <a:srgbClr val="5A5A5A"/>
+                </a:solidFill>
+                <a:latin typeface="Helvetica Neue" pitchFamily="34" charset="0"/>
+                <a:ea typeface="Helvetica Neue" pitchFamily="34" charset="-122"/>
+                <a:cs typeface="Helvetica Neue" pitchFamily="34" charset="-120"/>
+              </a:rPr>
+              <a:t>Code + historique</a:t>
+            </a:r>
+            <a:endParaRPr lang="en-US" sz="1000" dirty="0"/>
+          </a:p>
+        </p:txBody>
+      </p:sp>
+      <p:sp>
+        <p:nvSpPr>
+          <p:cNvPr id="12" name="Shape 10"/>
+          <p:cNvSpPr/>
+          <p:nvPr/>
+        </p:nvSpPr>
+        <p:spPr>
+          <a:xfrm>
+            <a:off x="2148840" y="4069080"/>
+            <a:ext cx="320040" cy="0"/>
+          </a:xfrm>
+          <a:prstGeom prst="line">
+            <a:avLst/>
+          </a:prstGeom>
+          <a:noFill/>
+          <a:ln w="12700">
+            <a:solidFill>
+              <a:srgbClr val="5A5A5A"/>
+            </a:solidFill>
+            <a:prstDash val="solid"/>
+          </a:ln>
+        </p:spPr>
+      </p:sp>
+      <p:sp>
+        <p:nvSpPr>
+          <p:cNvPr id="13" name="Shape 11"/>
+          <p:cNvSpPr/>
+          <p:nvPr/>
+        </p:nvSpPr>
+        <p:spPr>
+          <a:xfrm>
+            <a:off x="2468880" y="3680460"/>
+            <a:ext cx="1691640" cy="777240"/>
+          </a:xfrm>
+          <a:prstGeom prst="rect">
+            <a:avLst/>
+          </a:prstGeom>
+          <a:solidFill>
+            <a:srgbClr val="F7F7F5"/>
+          </a:solidFill>
+          <a:ln w="12700">
+            <a:solidFill>
+              <a:srgbClr val="D8D8D5"/>
+            </a:solidFill>
+            <a:prstDash val="solid"/>
+          </a:ln>
+        </p:spPr>
+      </p:sp>
+      <p:sp>
+        <p:nvSpPr>
+          <p:cNvPr id="14" name="Text 12"/>
+          <p:cNvSpPr/>
+          <p:nvPr/>
+        </p:nvSpPr>
+        <p:spPr>
+          <a:xfrm>
+            <a:off x="2468880" y="3771900"/>
+            <a:ext cx="1691640" cy="349758"/>
+          </a:xfrm>
+          <a:prstGeom prst="rect">
+            <a:avLst/>
+          </a:prstGeom>
+          <a:noFill/>
+          <a:ln/>
+        </p:spPr>
+        <p:txBody>
+          <a:bodyPr wrap="square" lIns="0" tIns="0" rIns="0" bIns="0" rtlCol="0" anchor="b"/>
+          <a:lstStyle/>
+          <a:p>
+            <a:pPr algn="ctr" indent="0" marL="0">
+              <a:buNone/>
+            </a:pPr>
+            <a:r>
+              <a:rPr lang="en-US" sz="1300" b="1" dirty="0">
+                <a:solidFill>
+                  <a:srgbClr val="1A1A1A"/>
+                </a:solidFill>
+                <a:latin typeface="Helvetica Neue" pitchFamily="34" charset="0"/>
+                <a:ea typeface="Helvetica Neue" pitchFamily="34" charset="-122"/>
+                <a:cs typeface="Helvetica Neue" pitchFamily="34" charset="-120"/>
+              </a:rPr>
+              <a:t>GitHub Actions</a:t>
+            </a:r>
+            <a:endParaRPr lang="en-US" sz="1300" dirty="0"/>
+          </a:p>
+        </p:txBody>
+      </p:sp>
+      <p:sp>
+        <p:nvSpPr>
+          <p:cNvPr id="15" name="Text 13"/>
+          <p:cNvSpPr/>
+          <p:nvPr/>
+        </p:nvSpPr>
+        <p:spPr>
+          <a:xfrm>
+            <a:off x="2468880" y="4069080"/>
+            <a:ext cx="1691640" cy="349758"/>
+          </a:xfrm>
+          <a:prstGeom prst="rect">
+            <a:avLst/>
+          </a:prstGeom>
+          <a:noFill/>
+          <a:ln/>
+        </p:spPr>
+        <p:txBody>
+          <a:bodyPr wrap="square" lIns="0" tIns="0" rIns="0" bIns="0" rtlCol="0" anchor="t"/>
+          <a:lstStyle/>
+          <a:p>
+            <a:pPr algn="ctr" indent="0" marL="0">
+              <a:buNone/>
+            </a:pPr>
+            <a:r>
+              <a:rPr lang="en-US" sz="1000" dirty="0">
+                <a:solidFill>
+                  <a:srgbClr val="5A5A5A"/>
+                </a:solidFill>
+                <a:latin typeface="Helvetica Neue" pitchFamily="34" charset="0"/>
+                <a:ea typeface="Helvetica Neue" pitchFamily="34" charset="-122"/>
+                <a:cs typeface="Helvetica Neue" pitchFamily="34" charset="-120"/>
+              </a:rPr>
+              <a:t>Vérifications auto</a:t>
+            </a:r>
+            <a:endParaRPr lang="en-US" sz="1000" dirty="0"/>
+          </a:p>
+        </p:txBody>
+      </p:sp>
+      <p:sp>
+        <p:nvSpPr>
+          <p:cNvPr id="16" name="Shape 14"/>
+          <p:cNvSpPr/>
+          <p:nvPr/>
+        </p:nvSpPr>
+        <p:spPr>
+          <a:xfrm>
+            <a:off x="4160520" y="4069080"/>
+            <a:ext cx="365760" cy="0"/>
+          </a:xfrm>
+          <a:prstGeom prst="line">
+            <a:avLst/>
+          </a:prstGeom>
+          <a:noFill/>
+          <a:ln w="12700">
+            <a:solidFill>
+              <a:srgbClr val="5A5A5A"/>
+            </a:solidFill>
+            <a:prstDash val="solid"/>
+          </a:ln>
+        </p:spPr>
+      </p:sp>
+      <p:sp>
+        <p:nvSpPr>
+          <p:cNvPr id="17" name="Shape 15"/>
+          <p:cNvSpPr/>
+          <p:nvPr/>
+        </p:nvSpPr>
+        <p:spPr>
+          <a:xfrm>
+            <a:off x="4526280" y="3611880"/>
+            <a:ext cx="3108960" cy="1005840"/>
           </a:xfrm>
           <a:prstGeom prst="rect">
             <a:avLst/>
@@ -5960,14 +6212,14 @@
       </p:sp>
       <p:sp>
         <p:nvSpPr>
-          <p:cNvPr id="10" name="Text 8"/>
-          <p:cNvSpPr/>
-          <p:nvPr/>
-        </p:nvSpPr>
-        <p:spPr>
-          <a:xfrm>
-            <a:off x="3977640" y="3657600"/>
-            <a:ext cx="4206240" cy="365760"/>
+          <p:cNvPr id="18" name="Text 16"/>
+          <p:cNvSpPr/>
+          <p:nvPr/>
+        </p:nvSpPr>
+        <p:spPr>
+          <a:xfrm>
+            <a:off x="4526280" y="3776472"/>
+            <a:ext cx="3108960" cy="365760"/>
           </a:xfrm>
           <a:prstGeom prst="rect">
             <a:avLst/>
@@ -5983,7 +6235,7 @@
               <a:buNone/>
             </a:pPr>
             <a:r>
-              <a:rPr lang="en-US" sz="1600" b="1" dirty="0">
+              <a:rPr lang="en-US" sz="1700" b="1" dirty="0">
                 <a:solidFill>
                   <a:srgbClr val="FFFFFF"/>
                 </a:solidFill>
@@ -5993,20 +6245,20 @@
               </a:rPr>
               <a:t>Vercel</a:t>
             </a:r>
-            <a:endParaRPr lang="en-US" sz="1600" dirty="0"/>
-          </a:p>
-        </p:txBody>
-      </p:sp>
-      <p:sp>
-        <p:nvSpPr>
-          <p:cNvPr id="11" name="Text 9"/>
-          <p:cNvSpPr/>
-          <p:nvPr/>
-        </p:nvSpPr>
-        <p:spPr>
-          <a:xfrm>
-            <a:off x="3977640" y="4069080"/>
-            <a:ext cx="4206240" cy="365760"/>
+            <a:endParaRPr lang="en-US" sz="1700" dirty="0"/>
+          </a:p>
+        </p:txBody>
+      </p:sp>
+      <p:sp>
+        <p:nvSpPr>
+          <p:cNvPr id="19" name="Text 17"/>
+          <p:cNvSpPr/>
+          <p:nvPr/>
+        </p:nvSpPr>
+        <p:spPr>
+          <a:xfrm>
+            <a:off x="4526280" y="4160520"/>
+            <a:ext cx="3108960" cy="365760"/>
           </a:xfrm>
           <a:prstGeom prst="rect">
             <a:avLst/>
@@ -6038,14 +6290,37 @@
       </p:sp>
       <p:sp>
         <p:nvSpPr>
-          <p:cNvPr id="12" name="Shape 10"/>
-          <p:cNvSpPr/>
-          <p:nvPr/>
-        </p:nvSpPr>
-        <p:spPr>
-          <a:xfrm>
-            <a:off x="1444752" y="5303520"/>
-            <a:ext cx="2194560" cy="868680"/>
+          <p:cNvPr id="20" name="Shape 18"/>
+          <p:cNvSpPr/>
+          <p:nvPr/>
+        </p:nvSpPr>
+        <p:spPr>
+          <a:xfrm>
+            <a:off x="6080760" y="4617720"/>
+            <a:ext cx="0" cy="411480"/>
+          </a:xfrm>
+          <a:prstGeom prst="line">
+            <a:avLst/>
+          </a:prstGeom>
+          <a:noFill/>
+          <a:ln w="12700">
+            <a:solidFill>
+              <a:srgbClr val="5A5A5A"/>
+            </a:solidFill>
+            <a:prstDash val="solid"/>
+          </a:ln>
+        </p:spPr>
+      </p:sp>
+      <p:sp>
+        <p:nvSpPr>
+          <p:cNvPr id="21" name="Shape 19"/>
+          <p:cNvSpPr/>
+          <p:nvPr/>
+        </p:nvSpPr>
+        <p:spPr>
+          <a:xfrm>
+            <a:off x="1444752" y="5120640"/>
+            <a:ext cx="2194560" cy="777240"/>
           </a:xfrm>
           <a:prstGeom prst="rect">
             <a:avLst/>
@@ -6063,23 +6338,23 @@
       </p:sp>
       <p:sp>
         <p:nvSpPr>
-          <p:cNvPr id="13" name="Text 11"/>
-          <p:cNvSpPr/>
-          <p:nvPr/>
-        </p:nvSpPr>
-        <p:spPr>
-          <a:xfrm>
-            <a:off x="1444752" y="5376672"/>
-            <a:ext cx="2194560" cy="320040"/>
-          </a:xfrm>
-          <a:prstGeom prst="rect">
-            <a:avLst/>
-          </a:prstGeom>
-          <a:noFill/>
-          <a:ln/>
-        </p:spPr>
-        <p:txBody>
-          <a:bodyPr wrap="square" lIns="0" tIns="0" rIns="0" bIns="0" rtlCol="0" anchor="ctr"/>
+          <p:cNvPr id="22" name="Text 20"/>
+          <p:cNvSpPr/>
+          <p:nvPr/>
+        </p:nvSpPr>
+        <p:spPr>
+          <a:xfrm>
+            <a:off x="1444752" y="5212080"/>
+            <a:ext cx="2194560" cy="349758"/>
+          </a:xfrm>
+          <a:prstGeom prst="rect">
+            <a:avLst/>
+          </a:prstGeom>
+          <a:noFill/>
+          <a:ln/>
+        </p:spPr>
+        <p:txBody>
+          <a:bodyPr wrap="square" lIns="0" tIns="0" rIns="0" bIns="0" rtlCol="0" anchor="b"/>
           <a:lstStyle/>
           <a:p>
             <a:pPr algn="ctr" indent="0" marL="0">
@@ -6102,23 +6377,23 @@
       </p:sp>
       <p:sp>
         <p:nvSpPr>
-          <p:cNvPr id="14" name="Text 12"/>
-          <p:cNvSpPr/>
-          <p:nvPr/>
-        </p:nvSpPr>
-        <p:spPr>
-          <a:xfrm>
-            <a:off x="1444752" y="5742432"/>
-            <a:ext cx="2194560" cy="320040"/>
-          </a:xfrm>
-          <a:prstGeom prst="rect">
-            <a:avLst/>
-          </a:prstGeom>
-          <a:noFill/>
-          <a:ln/>
-        </p:spPr>
-        <p:txBody>
-          <a:bodyPr wrap="square" lIns="0" tIns="0" rIns="0" bIns="0" rtlCol="0" anchor="ctr"/>
+          <p:cNvPr id="23" name="Text 21"/>
+          <p:cNvSpPr/>
+          <p:nvPr/>
+        </p:nvSpPr>
+        <p:spPr>
+          <a:xfrm>
+            <a:off x="1444752" y="5509260"/>
+            <a:ext cx="2194560" cy="349758"/>
+          </a:xfrm>
+          <a:prstGeom prst="rect">
+            <a:avLst/>
+          </a:prstGeom>
+          <a:noFill/>
+          <a:ln/>
+        </p:spPr>
+        <p:txBody>
+          <a:bodyPr wrap="square" lIns="0" tIns="0" rIns="0" bIns="0" rtlCol="0" anchor="t"/>
           <a:lstStyle/>
           <a:p>
             <a:pPr algn="ctr" indent="0" marL="0">
@@ -6141,14 +6416,14 @@
       </p:sp>
       <p:sp>
         <p:nvSpPr>
-          <p:cNvPr id="15" name="Shape 13"/>
-          <p:cNvSpPr/>
-          <p:nvPr/>
-        </p:nvSpPr>
-        <p:spPr>
-          <a:xfrm>
-            <a:off x="3803904" y="5303520"/>
-            <a:ext cx="2194560" cy="868680"/>
+          <p:cNvPr id="24" name="Shape 22"/>
+          <p:cNvSpPr/>
+          <p:nvPr/>
+        </p:nvSpPr>
+        <p:spPr>
+          <a:xfrm>
+            <a:off x="3803904" y="5120640"/>
+            <a:ext cx="2194560" cy="777240"/>
           </a:xfrm>
           <a:prstGeom prst="rect">
             <a:avLst/>
@@ -6166,23 +6441,23 @@
       </p:sp>
       <p:sp>
         <p:nvSpPr>
-          <p:cNvPr id="16" name="Text 14"/>
-          <p:cNvSpPr/>
-          <p:nvPr/>
-        </p:nvSpPr>
-        <p:spPr>
-          <a:xfrm>
-            <a:off x="3803904" y="5376672"/>
-            <a:ext cx="2194560" cy="320040"/>
-          </a:xfrm>
-          <a:prstGeom prst="rect">
-            <a:avLst/>
-          </a:prstGeom>
-          <a:noFill/>
-          <a:ln/>
-        </p:spPr>
-        <p:txBody>
-          <a:bodyPr wrap="square" lIns="0" tIns="0" rIns="0" bIns="0" rtlCol="0" anchor="ctr"/>
+          <p:cNvPr id="25" name="Text 23"/>
+          <p:cNvSpPr/>
+          <p:nvPr/>
+        </p:nvSpPr>
+        <p:spPr>
+          <a:xfrm>
+            <a:off x="3803904" y="5212080"/>
+            <a:ext cx="2194560" cy="349758"/>
+          </a:xfrm>
+          <a:prstGeom prst="rect">
+            <a:avLst/>
+          </a:prstGeom>
+          <a:noFill/>
+          <a:ln/>
+        </p:spPr>
+        <p:txBody>
+          <a:bodyPr wrap="square" lIns="0" tIns="0" rIns="0" bIns="0" rtlCol="0" anchor="b"/>
           <a:lstStyle/>
           <a:p>
             <a:pPr algn="ctr" indent="0" marL="0">
@@ -6205,23 +6480,23 @@
       </p:sp>
       <p:sp>
         <p:nvSpPr>
-          <p:cNvPr id="17" name="Text 15"/>
-          <p:cNvSpPr/>
-          <p:nvPr/>
-        </p:nvSpPr>
-        <p:spPr>
-          <a:xfrm>
-            <a:off x="3803904" y="5742432"/>
-            <a:ext cx="2194560" cy="320040"/>
-          </a:xfrm>
-          <a:prstGeom prst="rect">
-            <a:avLst/>
-          </a:prstGeom>
-          <a:noFill/>
-          <a:ln/>
-        </p:spPr>
-        <p:txBody>
-          <a:bodyPr wrap="square" lIns="0" tIns="0" rIns="0" bIns="0" rtlCol="0" anchor="ctr"/>
+          <p:cNvPr id="26" name="Text 24"/>
+          <p:cNvSpPr/>
+          <p:nvPr/>
+        </p:nvSpPr>
+        <p:spPr>
+          <a:xfrm>
+            <a:off x="3803904" y="5509260"/>
+            <a:ext cx="2194560" cy="349758"/>
+          </a:xfrm>
+          <a:prstGeom prst="rect">
+            <a:avLst/>
+          </a:prstGeom>
+          <a:noFill/>
+          <a:ln/>
+        </p:spPr>
+        <p:txBody>
+          <a:bodyPr wrap="square" lIns="0" tIns="0" rIns="0" bIns="0" rtlCol="0" anchor="t"/>
           <a:lstStyle/>
           <a:p>
             <a:pPr algn="ctr" indent="0" marL="0">
@@ -6244,14 +6519,14 @@
       </p:sp>
       <p:sp>
         <p:nvSpPr>
-          <p:cNvPr id="18" name="Shape 16"/>
-          <p:cNvSpPr/>
-          <p:nvPr/>
-        </p:nvSpPr>
-        <p:spPr>
-          <a:xfrm>
-            <a:off x="6163056" y="5303520"/>
-            <a:ext cx="2194560" cy="868680"/>
+          <p:cNvPr id="27" name="Shape 25"/>
+          <p:cNvSpPr/>
+          <p:nvPr/>
+        </p:nvSpPr>
+        <p:spPr>
+          <a:xfrm>
+            <a:off x="6163056" y="5120640"/>
+            <a:ext cx="2194560" cy="777240"/>
           </a:xfrm>
           <a:prstGeom prst="rect">
             <a:avLst/>
@@ -6269,23 +6544,23 @@
       </p:sp>
       <p:sp>
         <p:nvSpPr>
-          <p:cNvPr id="19" name="Text 17"/>
-          <p:cNvSpPr/>
-          <p:nvPr/>
-        </p:nvSpPr>
-        <p:spPr>
-          <a:xfrm>
-            <a:off x="6163056" y="5376672"/>
-            <a:ext cx="2194560" cy="320040"/>
-          </a:xfrm>
-          <a:prstGeom prst="rect">
-            <a:avLst/>
-          </a:prstGeom>
-          <a:noFill/>
-          <a:ln/>
-        </p:spPr>
-        <p:txBody>
-          <a:bodyPr wrap="square" lIns="0" tIns="0" rIns="0" bIns="0" rtlCol="0" anchor="ctr"/>
+          <p:cNvPr id="28" name="Text 26"/>
+          <p:cNvSpPr/>
+          <p:nvPr/>
+        </p:nvSpPr>
+        <p:spPr>
+          <a:xfrm>
+            <a:off x="6163056" y="5212080"/>
+            <a:ext cx="2194560" cy="349758"/>
+          </a:xfrm>
+          <a:prstGeom prst="rect">
+            <a:avLst/>
+          </a:prstGeom>
+          <a:noFill/>
+          <a:ln/>
+        </p:spPr>
+        <p:txBody>
+          <a:bodyPr wrap="square" lIns="0" tIns="0" rIns="0" bIns="0" rtlCol="0" anchor="b"/>
           <a:lstStyle/>
           <a:p>
             <a:pPr algn="ctr" indent="0" marL="0">
@@ -6308,23 +6583,23 @@
       </p:sp>
       <p:sp>
         <p:nvSpPr>
-          <p:cNvPr id="20" name="Text 18"/>
-          <p:cNvSpPr/>
-          <p:nvPr/>
-        </p:nvSpPr>
-        <p:spPr>
-          <a:xfrm>
-            <a:off x="6163056" y="5742432"/>
-            <a:ext cx="2194560" cy="320040"/>
-          </a:xfrm>
-          <a:prstGeom prst="rect">
-            <a:avLst/>
-          </a:prstGeom>
-          <a:noFill/>
-          <a:ln/>
-        </p:spPr>
-        <p:txBody>
-          <a:bodyPr wrap="square" lIns="0" tIns="0" rIns="0" bIns="0" rtlCol="0" anchor="ctr"/>
+          <p:cNvPr id="29" name="Text 27"/>
+          <p:cNvSpPr/>
+          <p:nvPr/>
+        </p:nvSpPr>
+        <p:spPr>
+          <a:xfrm>
+            <a:off x="6163056" y="5509260"/>
+            <a:ext cx="2194560" cy="349758"/>
+          </a:xfrm>
+          <a:prstGeom prst="rect">
+            <a:avLst/>
+          </a:prstGeom>
+          <a:noFill/>
+          <a:ln/>
+        </p:spPr>
+        <p:txBody>
+          <a:bodyPr wrap="square" lIns="0" tIns="0" rIns="0" bIns="0" rtlCol="0" anchor="t"/>
           <a:lstStyle/>
           <a:p>
             <a:pPr algn="ctr" indent="0" marL="0">
@@ -6347,14 +6622,14 @@
       </p:sp>
       <p:sp>
         <p:nvSpPr>
-          <p:cNvPr id="21" name="Shape 19"/>
-          <p:cNvSpPr/>
-          <p:nvPr/>
-        </p:nvSpPr>
-        <p:spPr>
-          <a:xfrm>
-            <a:off x="8522208" y="5303520"/>
-            <a:ext cx="2194560" cy="868680"/>
+          <p:cNvPr id="30" name="Shape 28"/>
+          <p:cNvSpPr/>
+          <p:nvPr/>
+        </p:nvSpPr>
+        <p:spPr>
+          <a:xfrm>
+            <a:off x="8522208" y="5120640"/>
+            <a:ext cx="2194560" cy="777240"/>
           </a:xfrm>
           <a:prstGeom prst="rect">
             <a:avLst/>
@@ -6372,23 +6647,23 @@
       </p:sp>
       <p:sp>
         <p:nvSpPr>
-          <p:cNvPr id="22" name="Text 20"/>
-          <p:cNvSpPr/>
-          <p:nvPr/>
-        </p:nvSpPr>
-        <p:spPr>
-          <a:xfrm>
-            <a:off x="8522208" y="5376672"/>
-            <a:ext cx="2194560" cy="320040"/>
-          </a:xfrm>
-          <a:prstGeom prst="rect">
-            <a:avLst/>
-          </a:prstGeom>
-          <a:noFill/>
-          <a:ln/>
-        </p:spPr>
-        <p:txBody>
-          <a:bodyPr wrap="square" lIns="0" tIns="0" rIns="0" bIns="0" rtlCol="0" anchor="ctr"/>
+          <p:cNvPr id="31" name="Text 29"/>
+          <p:cNvSpPr/>
+          <p:nvPr/>
+        </p:nvSpPr>
+        <p:spPr>
+          <a:xfrm>
+            <a:off x="8522208" y="5212080"/>
+            <a:ext cx="2194560" cy="349758"/>
+          </a:xfrm>
+          <a:prstGeom prst="rect">
+            <a:avLst/>
+          </a:prstGeom>
+          <a:noFill/>
+          <a:ln/>
+        </p:spPr>
+        <p:txBody>
+          <a:bodyPr wrap="square" lIns="0" tIns="0" rIns="0" bIns="0" rtlCol="0" anchor="b"/>
           <a:lstStyle/>
           <a:p>
             <a:pPr algn="ctr" indent="0" marL="0">
@@ -6411,23 +6686,23 @@
       </p:sp>
       <p:sp>
         <p:nvSpPr>
-          <p:cNvPr id="23" name="Text 21"/>
-          <p:cNvSpPr/>
-          <p:nvPr/>
-        </p:nvSpPr>
-        <p:spPr>
-          <a:xfrm>
-            <a:off x="8522208" y="5742432"/>
-            <a:ext cx="2194560" cy="320040"/>
-          </a:xfrm>
-          <a:prstGeom prst="rect">
-            <a:avLst/>
-          </a:prstGeom>
-          <a:noFill/>
-          <a:ln/>
-        </p:spPr>
-        <p:txBody>
-          <a:bodyPr wrap="square" lIns="0" tIns="0" rIns="0" bIns="0" rtlCol="0" anchor="ctr"/>
+          <p:cNvPr id="32" name="Text 30"/>
+          <p:cNvSpPr/>
+          <p:nvPr/>
+        </p:nvSpPr>
+        <p:spPr>
+          <a:xfrm>
+            <a:off x="8522208" y="5509260"/>
+            <a:ext cx="2194560" cy="349758"/>
+          </a:xfrm>
+          <a:prstGeom prst="rect">
+            <a:avLst/>
+          </a:prstGeom>
+          <a:noFill/>
+          <a:ln/>
+        </p:spPr>
+        <p:txBody>
+          <a:bodyPr wrap="square" lIns="0" tIns="0" rIns="0" bIns="0" rtlCol="0" anchor="t"/>
           <a:lstStyle/>
           <a:p>
             <a:pPr algn="ctr" indent="0" marL="0">
@@ -6450,108 +6725,7 @@
       </p:sp>
       <p:sp>
         <p:nvSpPr>
-          <p:cNvPr id="24" name="Shape 22"/>
-          <p:cNvSpPr/>
-          <p:nvPr/>
-        </p:nvSpPr>
-        <p:spPr>
-          <a:xfrm>
-            <a:off x="6080760" y="4572000"/>
-            <a:ext cx="0" cy="640080"/>
-          </a:xfrm>
-          <a:prstGeom prst="line">
-            <a:avLst/>
-          </a:prstGeom>
-          <a:noFill/>
-          <a:ln w="12700">
-            <a:solidFill>
-              <a:srgbClr val="5A5A5A"/>
-            </a:solidFill>
-            <a:prstDash val="solid"/>
-          </a:ln>
-        </p:spPr>
-      </p:sp>
-      <p:sp>
-        <p:nvSpPr>
-          <p:cNvPr id="25" name="Text 23"/>
-          <p:cNvSpPr/>
-          <p:nvPr/>
-        </p:nvSpPr>
-        <p:spPr>
-          <a:xfrm>
-            <a:off x="640080" y="5943600"/>
-            <a:ext cx="5486400" cy="320040"/>
-          </a:xfrm>
-          <a:prstGeom prst="rect">
-            <a:avLst/>
-          </a:prstGeom>
-          <a:noFill/>
-          <a:ln/>
-        </p:spPr>
-        <p:txBody>
-          <a:bodyPr wrap="square" lIns="0" tIns="0" rIns="0" bIns="0" rtlCol="0" anchor="ctr"/>
-          <a:lstStyle/>
-          <a:p>
-            <a:pPr indent="0" marL="0">
-              <a:buNone/>
-            </a:pPr>
-            <a:r>
-              <a:rPr lang="en-US" sz="1100" i="1" dirty="0">
-                <a:solidFill>
-                  <a:srgbClr val="5A5A5A"/>
-                </a:solidFill>
-                <a:latin typeface="Helvetica Neue" pitchFamily="34" charset="0"/>
-                <a:ea typeface="Helvetica Neue" pitchFamily="34" charset="-122"/>
-                <a:cs typeface="Helvetica Neue" pitchFamily="34" charset="-120"/>
-              </a:rPr>
-              <a:t>GitHub  →  GitHub Actions</a:t>
-            </a:r>
-            <a:endParaRPr lang="en-US" sz="1100" dirty="0"/>
-          </a:p>
-        </p:txBody>
-      </p:sp>
-      <p:sp>
-        <p:nvSpPr>
-          <p:cNvPr id="26" name="Text 24"/>
-          <p:cNvSpPr/>
-          <p:nvPr/>
-        </p:nvSpPr>
-        <p:spPr>
-          <a:xfrm>
-            <a:off x="640080" y="6217920"/>
-            <a:ext cx="7315200" cy="320040"/>
-          </a:xfrm>
-          <a:prstGeom prst="rect">
-            <a:avLst/>
-          </a:prstGeom>
-          <a:noFill/>
-          <a:ln/>
-        </p:spPr>
-        <p:txBody>
-          <a:bodyPr wrap="square" lIns="0" tIns="0" rIns="0" bIns="0" rtlCol="0" anchor="ctr"/>
-          <a:lstStyle/>
-          <a:p>
-            <a:pPr indent="0" marL="0">
-              <a:buNone/>
-            </a:pPr>
-            <a:r>
-              <a:rPr lang="en-US" sz="1000" dirty="0">
-                <a:solidFill>
-                  <a:srgbClr val="8A8A8A"/>
-                </a:solidFill>
-                <a:latin typeface="Helvetica Neue" pitchFamily="34" charset="0"/>
-                <a:ea typeface="Helvetica Neue" pitchFamily="34" charset="-122"/>
-                <a:cs typeface="Helvetica Neue" pitchFamily="34" charset="-120"/>
-              </a:rPr>
-              <a:t>Code + historique  →  vérifications auto à chaque commit</a:t>
-            </a:r>
-            <a:endParaRPr lang="en-US" sz="1000" dirty="0"/>
-          </a:p>
-        </p:txBody>
-      </p:sp>
-      <p:sp>
-        <p:nvSpPr>
-          <p:cNvPr id="27" name="Text 25"/>
+          <p:cNvPr id="33" name="Text 31"/>
           <p:cNvSpPr/>
           <p:nvPr/>
         </p:nvSpPr>

</xml_diff>

<commit_message>
Add security slide to the deck (slide 10)
Slide 10 — "Ce qui protège l'app" — covers the four user-visible
security layers in non-tech language:

1. Mots de passe protégés (bcrypt hash, illisibles)
2. Sessions sécurisées (cookie httpOnly, HTTPS, signé)
3. Anti-bombardement (rate limiting per-IP via Upstash Redis)
4. Vérification + reset par email (tokens à expiration courte)

Subsequent slides shifted by one (récap stack → 11, Part 2 break → 12,
setup démo → 13, closing → 14, Q&A → 15). TOTAL bumped to 15.

README "Présentation projet" mirrored: Part 1 grows from 9 → 10 min,
new "6. Sécurité" subsection with the same talking points + a
formatrice aside listing the technical specifics (bcrypt cost 10,
JWT HS256, Zod validation, security headers, dummy bcrypt for timing
equalization).

Co-Authored-By: Claude Opus 4.7 (1M context) <noreply@anthropic.com>
</commit_message>
<xml_diff>
--- a/docs/pulse-presentation.pptx
+++ b/docs/pulse-presentation.pptx
@@ -19,9 +19,10 @@
     <p:sldId id="267" r:id="rId13"/>
     <p:sldId id="268" r:id="rId14"/>
     <p:sldId id="269" r:id="rId15"/>
+    <p:sldId id="270" r:id="rId16"/>
   </p:sldIdLst>
   <p:notesMasterIdLst>
-    <p:notesMasterId r:id="rId16"/>
+    <p:notesMasterId r:id="rId17"/>
   </p:notesMasterIdLst>
   <p:sldSz cx="12192000" cy="6858000"/>
   <p:notesSz cx="6858000" cy="12192000"/>
@@ -979,6 +980,94 @@
             <a:fld id="{F7021451-1387-4CA6-816F-3879F97B5CBC}" type="slidenum">
               <a:rPr lang="en-US"/>
               <a:t>14</a:t>
+            </a:fld>
+            <a:endParaRPr lang="en-US"/>
+          </a:p>
+        </p:txBody>
+      </p:sp>
+    </p:spTree>
+    <p:extLst>
+      <p:ext uri="{BB962C8B-B14F-4D97-AF65-F5344CB8AC3E}">
+        <p14:creationId xmlns:p14="http://schemas.microsoft.com/office/powerpoint/2010/main" val="1024086991"/>
+      </p:ext>
+    </p:extLst>
+  </p:cSld>
+  <p:clrMapOvr>
+    <a:masterClrMapping/>
+  </p:clrMapOvr>
+</p:notes>
+</file>
+
+<file path=ppt/notesSlides/notesSlide15.xml><?xml version="1.0" encoding="utf-8"?>
+<p:notes xmlns:a="http://schemas.openxmlformats.org/drawingml/2006/main" xmlns:r="http://schemas.openxmlformats.org/officeDocument/2006/relationships" xmlns:p="http://schemas.openxmlformats.org/presentationml/2006/main">
+  <p:cSld>
+    <p:spTree>
+      <p:nvGrpSpPr>
+        <p:cNvPr id="1" name=""/>
+        <p:cNvGrpSpPr/>
+        <p:nvPr/>
+      </p:nvGrpSpPr>
+      <p:grpSpPr>
+        <a:xfrm>
+          <a:off x="0" y="0"/>
+          <a:ext cx="0" cy="0"/>
+          <a:chOff x="0" y="0"/>
+          <a:chExt cx="0" cy="0"/>
+        </a:xfrm>
+      </p:grpSpPr>
+      <p:sp>
+        <p:nvSpPr>
+          <p:cNvPr id="2" name="Slide Image Placeholder 1"/>
+          <p:cNvSpPr>
+            <a:spLocks noGrp="1" noRot="1" noChangeAspect="1"/>
+          </p:cNvSpPr>
+          <p:nvPr>
+            <p:ph type="sldImg"/>
+          </p:nvPr>
+        </p:nvSpPr>
+        <p:spPr/>
+      </p:sp>
+      <p:sp>
+        <p:nvSpPr>
+          <p:cNvPr id="3" name="Notes Placeholder 2"/>
+          <p:cNvSpPr>
+            <a:spLocks noGrp="1"/>
+          </p:cNvSpPr>
+          <p:nvPr>
+            <p:ph type="body" idx="1"/>
+          </p:nvPr>
+        </p:nvSpPr>
+        <p:spPr/>
+        <p:txBody>
+          <a:bodyPr/>
+          <a:lstStyle/>
+          <a:p>
+            <a:r>
+              <a:rPr lang="en-US" dirty="0"/>
+              <a:t/>
+            </a:r>
+            <a:endParaRPr lang="en-US" dirty="0"/>
+          </a:p>
+        </p:txBody>
+      </p:sp>
+      <p:sp>
+        <p:nvSpPr>
+          <p:cNvPr id="4" name="Slide Number Placeholder 3"/>
+          <p:cNvSpPr>
+            <a:spLocks noGrp="1"/>
+          </p:cNvSpPr>
+          <p:nvPr>
+            <p:ph type="sldNum" sz="quarter" idx="10"/>
+          </p:nvPr>
+        </p:nvSpPr>
+        <p:spPr/>
+        <p:txBody>
+          <a:bodyPr/>
+          <a:lstStyle/>
+          <a:p>
+            <a:fld id="{F7021451-1387-4CA6-816F-3879F97B5CBC}" type="slidenum">
+              <a:rPr lang="en-US"/>
+              <a:t>15</a:t>
             </a:fld>
             <a:endParaRPr lang="en-US"/>
           </a:p>
@@ -2292,7 +2381,7 @@
                 <a:ea typeface="Helvetica Neue" pitchFamily="34" charset="-122"/>
                 <a:cs typeface="Helvetica Neue" pitchFamily="34" charset="-120"/>
               </a:rPr>
-              <a:t>RÉCAPITULATIF</a:t>
+              <a:t>SÉCURITÉ</a:t>
             </a:r>
             <a:endParaRPr lang="en-US" sz="900" dirty="0"/>
           </a:p>
@@ -2331,7 +2420,7 @@
                 <a:ea typeface="Helvetica Neue" pitchFamily="34" charset="-122"/>
                 <a:cs typeface="Helvetica Neue" pitchFamily="34" charset="-120"/>
               </a:rPr>
-              <a:t>Pour résumer en une phrase</a:t>
+              <a:t>Ce qui protège l'app</a:t>
             </a:r>
             <a:endParaRPr lang="en-US" sz="3600" dirty="0"/>
           </a:p>
@@ -2368,27 +2457,88 @@
         </p:nvSpPr>
         <p:spPr>
           <a:xfrm>
-            <a:off x="640080" y="2560320"/>
-            <a:ext cx="10881360" cy="3200400"/>
-          </a:xfrm>
-          <a:prstGeom prst="rect">
-            <a:avLst/>
-          </a:prstGeom>
-          <a:noFill/>
-          <a:ln/>
-        </p:spPr>
-        <p:txBody>
-          <a:bodyPr wrap="square" lIns="0" tIns="0" rIns="0" bIns="0" rtlCol="0" anchor="ctr"/>
-          <a:lstStyle/>
-          <a:p>
-            <a:pPr indent="0" marL="0">
-              <a:spcAft>
-                <a:spcPts val="600"/>
-              </a:spcAft>
-              <a:buNone/>
-            </a:pPr>
-            <a:r>
-              <a:rPr lang="en-US" sz="2600" b="1" dirty="0">
+            <a:off x="640080" y="2286000"/>
+            <a:ext cx="10881360" cy="640080"/>
+          </a:xfrm>
+          <a:prstGeom prst="rect">
+            <a:avLst/>
+          </a:prstGeom>
+          <a:noFill/>
+          <a:ln/>
+        </p:spPr>
+        <p:txBody>
+          <a:bodyPr wrap="square" lIns="0" tIns="0" rIns="0" bIns="0" rtlCol="0" anchor="ctr"/>
+          <a:lstStyle/>
+          <a:p>
+            <a:pPr indent="0" marL="0">
+              <a:buNone/>
+            </a:pPr>
+            <a:r>
+              <a:rPr lang="en-US" sz="1700" i="1" dirty="0">
+                <a:solidFill>
+                  <a:srgbClr val="5A5A5A"/>
+                </a:solidFill>
+                <a:latin typeface="Helvetica Neue" pitchFamily="34" charset="0"/>
+                <a:ea typeface="Helvetica Neue" pitchFamily="34" charset="-122"/>
+                <a:cs typeface="Helvetica Neue" pitchFamily="34" charset="-120"/>
+              </a:rPr>
+              <a:t>Avec des comptes utilisateurs et des données privées en jeu, plusieurs couches sont indispensables.</a:t>
+            </a:r>
+            <a:endParaRPr lang="en-US" sz="1700" dirty="0"/>
+          </a:p>
+        </p:txBody>
+      </p:sp>
+      <p:sp>
+        <p:nvSpPr>
+          <p:cNvPr id="6" name="Shape 4"/>
+          <p:cNvSpPr/>
+          <p:nvPr/>
+        </p:nvSpPr>
+        <p:spPr>
+          <a:xfrm>
+            <a:off x="640080" y="3246120"/>
+            <a:ext cx="36576" cy="502920"/>
+          </a:xfrm>
+          <a:prstGeom prst="rect">
+            <a:avLst/>
+          </a:prstGeom>
+          <a:solidFill>
+            <a:srgbClr val="1A1A1A"/>
+          </a:solidFill>
+          <a:ln w="12700">
+            <a:solidFill>
+              <a:srgbClr val="1A1A1A"/>
+            </a:solidFill>
+            <a:prstDash val="solid"/>
+          </a:ln>
+        </p:spPr>
+      </p:sp>
+      <p:sp>
+        <p:nvSpPr>
+          <p:cNvPr id="7" name="Text 5"/>
+          <p:cNvSpPr/>
+          <p:nvPr/>
+        </p:nvSpPr>
+        <p:spPr>
+          <a:xfrm>
+            <a:off x="868680" y="3246120"/>
+            <a:ext cx="10652760" cy="548640"/>
+          </a:xfrm>
+          <a:prstGeom prst="rect">
+            <a:avLst/>
+          </a:prstGeom>
+          <a:noFill/>
+          <a:ln/>
+        </p:spPr>
+        <p:txBody>
+          <a:bodyPr wrap="square" lIns="0" tIns="0" rIns="0" bIns="0" rtlCol="0" anchor="ctr"/>
+          <a:lstStyle/>
+          <a:p>
+            <a:pPr indent="0" marL="0">
+              <a:buNone/>
+            </a:pPr>
+            <a:r>
+              <a:rPr lang="en-US" sz="1400" b="1" dirty="0">
                 <a:solidFill>
                   <a:srgbClr val="1A1A1A"/>
                 </a:solidFill>
@@ -2396,16 +2546,13 @@
                 <a:ea typeface="Helvetica Neue" pitchFamily="34" charset="-122"/>
                 <a:cs typeface="Helvetica Neue" pitchFamily="34" charset="-120"/>
               </a:rPr>
-              <a:t>GitHub </a:t>
-            </a:r>
-            <a:pPr indent="0" marL="0">
-              <a:spcAft>
-                <a:spcPts val="600"/>
-              </a:spcAft>
-              <a:buNone/>
-            </a:pPr>
-            <a:r>
-              <a:rPr lang="en-US" sz="2600" dirty="0">
+              <a:t>Mots de passe protégés — </a:t>
+            </a:r>
+            <a:pPr indent="0" marL="0">
+              <a:buNone/>
+            </a:pPr>
+            <a:r>
+              <a:rPr lang="en-US" sz="1400" dirty="0">
                 <a:solidFill>
                   <a:srgbClr val="404040"/>
                 </a:solidFill>
@@ -2413,17 +2560,63 @@
                 <a:ea typeface="Helvetica Neue" pitchFamily="34" charset="-122"/>
                 <a:cs typeface="Helvetica Neue" pitchFamily="34" charset="-120"/>
               </a:rPr>
-              <a:t>stocke le code,
-</a:t>
-            </a:r>
-            <a:pPr indent="0" marL="0">
-              <a:spcAft>
-                <a:spcPts val="600"/>
-              </a:spcAft>
-              <a:buNone/>
-            </a:pPr>
-            <a:r>
-              <a:rPr lang="en-US" sz="2600" b="1" dirty="0">
+              <a:t>chiffrés avec bcrypt, jamais stockés en clair, illisibles même pour moi.</a:t>
+            </a:r>
+            <a:endParaRPr lang="en-US" sz="1400" dirty="0"/>
+          </a:p>
+        </p:txBody>
+      </p:sp>
+      <p:sp>
+        <p:nvSpPr>
+          <p:cNvPr id="8" name="Shape 6"/>
+          <p:cNvSpPr/>
+          <p:nvPr/>
+        </p:nvSpPr>
+        <p:spPr>
+          <a:xfrm>
+            <a:off x="640080" y="3886200"/>
+            <a:ext cx="36576" cy="502920"/>
+          </a:xfrm>
+          <a:prstGeom prst="rect">
+            <a:avLst/>
+          </a:prstGeom>
+          <a:solidFill>
+            <a:srgbClr val="1A1A1A"/>
+          </a:solidFill>
+          <a:ln w="12700">
+            <a:solidFill>
+              <a:srgbClr val="1A1A1A"/>
+            </a:solidFill>
+            <a:prstDash val="solid"/>
+          </a:ln>
+        </p:spPr>
+      </p:sp>
+      <p:sp>
+        <p:nvSpPr>
+          <p:cNvPr id="9" name="Text 7"/>
+          <p:cNvSpPr/>
+          <p:nvPr/>
+        </p:nvSpPr>
+        <p:spPr>
+          <a:xfrm>
+            <a:off x="868680" y="3886200"/>
+            <a:ext cx="10652760" cy="548640"/>
+          </a:xfrm>
+          <a:prstGeom prst="rect">
+            <a:avLst/>
+          </a:prstGeom>
+          <a:noFill/>
+          <a:ln/>
+        </p:spPr>
+        <p:txBody>
+          <a:bodyPr wrap="square" lIns="0" tIns="0" rIns="0" bIns="0" rtlCol="0" anchor="ctr"/>
+          <a:lstStyle/>
+          <a:p>
+            <a:pPr indent="0" marL="0">
+              <a:buNone/>
+            </a:pPr>
+            <a:r>
+              <a:rPr lang="en-US" sz="1400" b="1" dirty="0">
                 <a:solidFill>
                   <a:srgbClr val="1A1A1A"/>
                 </a:solidFill>
@@ -2431,16 +2624,13 @@
                 <a:ea typeface="Helvetica Neue" pitchFamily="34" charset="-122"/>
                 <a:cs typeface="Helvetica Neue" pitchFamily="34" charset="-120"/>
               </a:rPr>
-              <a:t>Vercel </a:t>
-            </a:r>
-            <a:pPr indent="0" marL="0">
-              <a:spcAft>
-                <a:spcPts val="600"/>
-              </a:spcAft>
-              <a:buNone/>
-            </a:pPr>
-            <a:r>
-              <a:rPr lang="en-US" sz="2600" dirty="0">
+              <a:t>Sessions sécurisées — </a:t>
+            </a:r>
+            <a:pPr indent="0" marL="0">
+              <a:buNone/>
+            </a:pPr>
+            <a:r>
+              <a:rPr lang="en-US" sz="1400" dirty="0">
                 <a:solidFill>
                   <a:srgbClr val="404040"/>
                 </a:solidFill>
@@ -2448,17 +2638,63 @@
                 <a:ea typeface="Helvetica Neue" pitchFamily="34" charset="-122"/>
                 <a:cs typeface="Helvetica Neue" pitchFamily="34" charset="-120"/>
               </a:rPr>
-              <a:t>le met en ligne,
-</a:t>
-            </a:r>
-            <a:pPr indent="0" marL="0">
-              <a:spcAft>
-                <a:spcPts val="600"/>
-              </a:spcAft>
-              <a:buNone/>
-            </a:pPr>
-            <a:r>
-              <a:rPr lang="en-US" sz="2600" b="1" dirty="0">
+              <a:t>cookie signé par le serveur, transmis en HTTPS, inaccessible au code de la page.</a:t>
+            </a:r>
+            <a:endParaRPr lang="en-US" sz="1400" dirty="0"/>
+          </a:p>
+        </p:txBody>
+      </p:sp>
+      <p:sp>
+        <p:nvSpPr>
+          <p:cNvPr id="10" name="Shape 8"/>
+          <p:cNvSpPr/>
+          <p:nvPr/>
+        </p:nvSpPr>
+        <p:spPr>
+          <a:xfrm>
+            <a:off x="640080" y="4526280"/>
+            <a:ext cx="36576" cy="502920"/>
+          </a:xfrm>
+          <a:prstGeom prst="rect">
+            <a:avLst/>
+          </a:prstGeom>
+          <a:solidFill>
+            <a:srgbClr val="1A1A1A"/>
+          </a:solidFill>
+          <a:ln w="12700">
+            <a:solidFill>
+              <a:srgbClr val="1A1A1A"/>
+            </a:solidFill>
+            <a:prstDash val="solid"/>
+          </a:ln>
+        </p:spPr>
+      </p:sp>
+      <p:sp>
+        <p:nvSpPr>
+          <p:cNvPr id="11" name="Text 9"/>
+          <p:cNvSpPr/>
+          <p:nvPr/>
+        </p:nvSpPr>
+        <p:spPr>
+          <a:xfrm>
+            <a:off x="868680" y="4526280"/>
+            <a:ext cx="10652760" cy="548640"/>
+          </a:xfrm>
+          <a:prstGeom prst="rect">
+            <a:avLst/>
+          </a:prstGeom>
+          <a:noFill/>
+          <a:ln/>
+        </p:spPr>
+        <p:txBody>
+          <a:bodyPr wrap="square" lIns="0" tIns="0" rIns="0" bIns="0" rtlCol="0" anchor="ctr"/>
+          <a:lstStyle/>
+          <a:p>
+            <a:pPr indent="0" marL="0">
+              <a:buNone/>
+            </a:pPr>
+            <a:r>
+              <a:rPr lang="en-US" sz="1400" b="1" dirty="0">
                 <a:solidFill>
                   <a:srgbClr val="1A1A1A"/>
                 </a:solidFill>
@@ -2466,16 +2702,13 @@
                 <a:ea typeface="Helvetica Neue" pitchFamily="34" charset="-122"/>
                 <a:cs typeface="Helvetica Neue" pitchFamily="34" charset="-120"/>
               </a:rPr>
-              <a:t>Next.js </a:t>
-            </a:r>
-            <a:pPr indent="0" marL="0">
-              <a:spcAft>
-                <a:spcPts val="600"/>
-              </a:spcAft>
-              <a:buNone/>
-            </a:pPr>
-            <a:r>
-              <a:rPr lang="en-US" sz="2600" dirty="0">
+              <a:t>Anti-bombardement — </a:t>
+            </a:r>
+            <a:pPr indent="0" marL="0">
+              <a:buNone/>
+            </a:pPr>
+            <a:r>
+              <a:rPr lang="en-US" sz="1400" dirty="0">
                 <a:solidFill>
                   <a:srgbClr val="404040"/>
                 </a:solidFill>
@@ -2483,17 +2716,63 @@
                 <a:ea typeface="Helvetica Neue" pitchFamily="34" charset="-122"/>
                 <a:cs typeface="Helvetica Neue" pitchFamily="34" charset="-120"/>
               </a:rPr>
-              <a:t>fait tourner les pages,
-</a:t>
-            </a:r>
-            <a:pPr indent="0" marL="0">
-              <a:spcAft>
-                <a:spcPts val="600"/>
-              </a:spcAft>
-              <a:buNone/>
-            </a:pPr>
-            <a:r>
-              <a:rPr lang="en-US" sz="2600" b="1" dirty="0">
+              <a:t>login bloqué après 5 essais en 1 minute. Vote, signup et reset password aussi limités.</a:t>
+            </a:r>
+            <a:endParaRPr lang="en-US" sz="1400" dirty="0"/>
+          </a:p>
+        </p:txBody>
+      </p:sp>
+      <p:sp>
+        <p:nvSpPr>
+          <p:cNvPr id="12" name="Shape 10"/>
+          <p:cNvSpPr/>
+          <p:nvPr/>
+        </p:nvSpPr>
+        <p:spPr>
+          <a:xfrm>
+            <a:off x="640080" y="5166360"/>
+            <a:ext cx="36576" cy="502920"/>
+          </a:xfrm>
+          <a:prstGeom prst="rect">
+            <a:avLst/>
+          </a:prstGeom>
+          <a:solidFill>
+            <a:srgbClr val="1A1A1A"/>
+          </a:solidFill>
+          <a:ln w="12700">
+            <a:solidFill>
+              <a:srgbClr val="1A1A1A"/>
+            </a:solidFill>
+            <a:prstDash val="solid"/>
+          </a:ln>
+        </p:spPr>
+      </p:sp>
+      <p:sp>
+        <p:nvSpPr>
+          <p:cNvPr id="13" name="Text 11"/>
+          <p:cNvSpPr/>
+          <p:nvPr/>
+        </p:nvSpPr>
+        <p:spPr>
+          <a:xfrm>
+            <a:off x="868680" y="5166360"/>
+            <a:ext cx="10652760" cy="548640"/>
+          </a:xfrm>
+          <a:prstGeom prst="rect">
+            <a:avLst/>
+          </a:prstGeom>
+          <a:noFill/>
+          <a:ln/>
+        </p:spPr>
+        <p:txBody>
+          <a:bodyPr wrap="square" lIns="0" tIns="0" rIns="0" bIns="0" rtlCol="0" anchor="ctr"/>
+          <a:lstStyle/>
+          <a:p>
+            <a:pPr indent="0" marL="0">
+              <a:buNone/>
+            </a:pPr>
+            <a:r>
+              <a:rPr lang="en-US" sz="1400" b="1" dirty="0">
                 <a:solidFill>
                   <a:srgbClr val="1A1A1A"/>
                 </a:solidFill>
@@ -2501,16 +2780,13 @@
                 <a:ea typeface="Helvetica Neue" pitchFamily="34" charset="-122"/>
                 <a:cs typeface="Helvetica Neue" pitchFamily="34" charset="-120"/>
               </a:rPr>
-              <a:t>Airtable </a:t>
-            </a:r>
-            <a:pPr indent="0" marL="0">
-              <a:spcAft>
-                <a:spcPts val="600"/>
-              </a:spcAft>
-              <a:buNone/>
-            </a:pPr>
-            <a:r>
-              <a:rPr lang="en-US" sz="2600" dirty="0">
+              <a:t>Vérification + reset par email — </a:t>
+            </a:r>
+            <a:pPr indent="0" marL="0">
+              <a:buNone/>
+            </a:pPr>
+            <a:r>
+              <a:rPr lang="en-US" sz="1400" dirty="0">
                 <a:solidFill>
                   <a:srgbClr val="404040"/>
                 </a:solidFill>
@@ -2518,50 +2794,15 @@
                 <a:ea typeface="Helvetica Neue" pitchFamily="34" charset="-122"/>
                 <a:cs typeface="Helvetica Neue" pitchFamily="34" charset="-120"/>
               </a:rPr>
-              <a:t>stocke les données,
-</a:t>
-            </a:r>
-            <a:pPr indent="0" marL="0">
-              <a:spcAft>
-                <a:spcPts val="600"/>
-              </a:spcAft>
-              <a:buNone/>
-            </a:pPr>
-            <a:r>
-              <a:rPr lang="en-US" sz="2600" b="1" dirty="0">
-                <a:solidFill>
-                  <a:srgbClr val="1A1A1A"/>
-                </a:solidFill>
-                <a:latin typeface="Helvetica Neue" pitchFamily="34" charset="0"/>
-                <a:ea typeface="Helvetica Neue" pitchFamily="34" charset="-122"/>
-                <a:cs typeface="Helvetica Neue" pitchFamily="34" charset="-120"/>
-              </a:rPr>
-              <a:t>Resend / Redis / Sentry </a:t>
-            </a:r>
-            <a:pPr indent="0" marL="0">
-              <a:spcAft>
-                <a:spcPts val="600"/>
-              </a:spcAft>
-              <a:buNone/>
-            </a:pPr>
-            <a:r>
-              <a:rPr lang="en-US" sz="2600" dirty="0">
-                <a:solidFill>
-                  <a:srgbClr val="404040"/>
-                </a:solidFill>
-                <a:latin typeface="Helvetica Neue" pitchFamily="34" charset="0"/>
-                <a:ea typeface="Helvetica Neue" pitchFamily="34" charset="-122"/>
-                <a:cs typeface="Helvetica Neue" pitchFamily="34" charset="-120"/>
-              </a:rPr>
-              <a:t>s'occupent des cas tordus.</a:t>
-            </a:r>
-            <a:endParaRPr lang="en-US" sz="2600" dirty="0"/>
-          </a:p>
-        </p:txBody>
-      </p:sp>
-      <p:sp>
-        <p:nvSpPr>
-          <p:cNvPr id="6" name="Text 4"/>
+              <a:t>pas d'inscription avec une adresse fictive. Liens à expiration courte, à usage unique.</a:t>
+            </a:r>
+            <a:endParaRPr lang="en-US" sz="1400" dirty="0"/>
+          </a:p>
+        </p:txBody>
+      </p:sp>
+      <p:sp>
+        <p:nvSpPr>
+          <p:cNvPr id="14" name="Text 12"/>
           <p:cNvSpPr/>
           <p:nvPr/>
         </p:nvSpPr>
@@ -2592,7 +2833,7 @@
                 <a:ea typeface="Helvetica Neue" pitchFamily="34" charset="-122"/>
                 <a:cs typeface="Helvetica Neue" pitchFamily="34" charset="-120"/>
               </a:rPr>
-              <a:t>Tout ça gratuit, moderne, interconnecté avec quelques clics.</a:t>
+              <a:t>Audit complet du code documenté dans le README — items identifiés, traités, justifiés.</a:t>
             </a:r>
             <a:endParaRPr lang="en-US" sz="1200" dirty="0"/>
           </a:p>
@@ -2600,7 +2841,7 @@
       </p:sp>
       <p:sp>
         <p:nvSpPr>
-          <p:cNvPr id="7" name="Text 5"/>
+          <p:cNvPr id="15" name="Text 13"/>
           <p:cNvSpPr/>
           <p:nvPr/>
         </p:nvSpPr>
@@ -2631,7 +2872,7 @@
                 <a:ea typeface="Helvetica Neue" pitchFamily="34" charset="-122"/>
                 <a:cs typeface="Helvetica Neue" pitchFamily="34" charset="-120"/>
               </a:rPr>
-              <a:t>10 / 14</a:t>
+              <a:t>10 / 15</a:t>
             </a:r>
             <a:endParaRPr lang="en-US" sz="900" dirty="0"/>
           </a:p>
@@ -2648,6 +2889,416 @@
 <file path=ppt/slides/slide11.xml><?xml version="1.0" encoding="utf-8"?>
 <p:sld xmlns:a="http://schemas.openxmlformats.org/drawingml/2006/main" xmlns:r="http://schemas.openxmlformats.org/officeDocument/2006/relationships" xmlns:p="http://schemas.openxmlformats.org/presentationml/2006/main">
   <p:cSld name="Slide 11">
+    <p:bg>
+      <p:bgPr>
+        <a:solidFill>
+          <a:srgbClr val="FFFFFF"/>
+        </a:solidFill>
+      </p:bgPr>
+    </p:bg>
+    <p:spTree>
+      <p:nvGrpSpPr>
+        <p:cNvPr id="1" name=""/>
+        <p:cNvGrpSpPr/>
+        <p:nvPr/>
+      </p:nvGrpSpPr>
+      <p:grpSpPr>
+        <a:xfrm>
+          <a:off x="0" y="0"/>
+          <a:ext cx="0" cy="0"/>
+          <a:chOff x="0" y="0"/>
+          <a:chExt cx="0" cy="0"/>
+        </a:xfrm>
+      </p:grpSpPr>
+      <p:sp>
+        <p:nvSpPr>
+          <p:cNvPr id="2" name="Text 0"/>
+          <p:cNvSpPr/>
+          <p:nvPr/>
+        </p:nvSpPr>
+        <p:spPr>
+          <a:xfrm>
+            <a:off x="640080" y="411480"/>
+            <a:ext cx="7315200" cy="274320"/>
+          </a:xfrm>
+          <a:prstGeom prst="rect">
+            <a:avLst/>
+          </a:prstGeom>
+          <a:noFill/>
+          <a:ln/>
+        </p:spPr>
+        <p:txBody>
+          <a:bodyPr wrap="square" lIns="0" tIns="0" rIns="0" bIns="0" rtlCol="0" anchor="ctr"/>
+          <a:lstStyle/>
+          <a:p>
+            <a:pPr indent="0" marL="0">
+              <a:buNone/>
+            </a:pPr>
+            <a:r>
+              <a:rPr lang="en-US" sz="900" spc="400" kern="0" dirty="0">
+                <a:solidFill>
+                  <a:srgbClr val="8A8A8A"/>
+                </a:solidFill>
+                <a:latin typeface="Helvetica Neue" pitchFamily="34" charset="0"/>
+                <a:ea typeface="Helvetica Neue" pitchFamily="34" charset="-122"/>
+                <a:cs typeface="Helvetica Neue" pitchFamily="34" charset="-120"/>
+              </a:rPr>
+              <a:t>RÉCAPITULATIF</a:t>
+            </a:r>
+            <a:endParaRPr lang="en-US" sz="900" dirty="0"/>
+          </a:p>
+        </p:txBody>
+      </p:sp>
+      <p:sp>
+        <p:nvSpPr>
+          <p:cNvPr id="3" name="Text 1"/>
+          <p:cNvSpPr/>
+          <p:nvPr/>
+        </p:nvSpPr>
+        <p:spPr>
+          <a:xfrm>
+            <a:off x="640080" y="1005840"/>
+            <a:ext cx="10881360" cy="914400"/>
+          </a:xfrm>
+          <a:prstGeom prst="rect">
+            <a:avLst/>
+          </a:prstGeom>
+          <a:noFill/>
+          <a:ln/>
+        </p:spPr>
+        <p:txBody>
+          <a:bodyPr wrap="square" lIns="0" tIns="0" rIns="0" bIns="0" rtlCol="0" anchor="ctr"/>
+          <a:lstStyle/>
+          <a:p>
+            <a:pPr indent="0" marL="0">
+              <a:buNone/>
+            </a:pPr>
+            <a:r>
+              <a:rPr lang="en-US" sz="3600" b="1" dirty="0">
+                <a:solidFill>
+                  <a:srgbClr val="1A1A1A"/>
+                </a:solidFill>
+                <a:latin typeface="Helvetica Neue" pitchFamily="34" charset="0"/>
+                <a:ea typeface="Helvetica Neue" pitchFamily="34" charset="-122"/>
+                <a:cs typeface="Helvetica Neue" pitchFamily="34" charset="-120"/>
+              </a:rPr>
+              <a:t>Pour résumer en une phrase</a:t>
+            </a:r>
+            <a:endParaRPr lang="en-US" sz="3600" dirty="0"/>
+          </a:p>
+        </p:txBody>
+      </p:sp>
+      <p:sp>
+        <p:nvSpPr>
+          <p:cNvPr id="4" name="Shape 2"/>
+          <p:cNvSpPr/>
+          <p:nvPr/>
+        </p:nvSpPr>
+        <p:spPr>
+          <a:xfrm>
+            <a:off x="640080" y="1874520"/>
+            <a:ext cx="548640" cy="0"/>
+          </a:xfrm>
+          <a:prstGeom prst="line">
+            <a:avLst/>
+          </a:prstGeom>
+          <a:noFill/>
+          <a:ln w="19050">
+            <a:solidFill>
+              <a:srgbClr val="1A1A1A"/>
+            </a:solidFill>
+            <a:prstDash val="solid"/>
+          </a:ln>
+        </p:spPr>
+      </p:sp>
+      <p:sp>
+        <p:nvSpPr>
+          <p:cNvPr id="5" name="Text 3"/>
+          <p:cNvSpPr/>
+          <p:nvPr/>
+        </p:nvSpPr>
+        <p:spPr>
+          <a:xfrm>
+            <a:off x="640080" y="2560320"/>
+            <a:ext cx="10881360" cy="3200400"/>
+          </a:xfrm>
+          <a:prstGeom prst="rect">
+            <a:avLst/>
+          </a:prstGeom>
+          <a:noFill/>
+          <a:ln/>
+        </p:spPr>
+        <p:txBody>
+          <a:bodyPr wrap="square" lIns="0" tIns="0" rIns="0" bIns="0" rtlCol="0" anchor="ctr"/>
+          <a:lstStyle/>
+          <a:p>
+            <a:pPr indent="0" marL="0">
+              <a:spcAft>
+                <a:spcPts val="600"/>
+              </a:spcAft>
+              <a:buNone/>
+            </a:pPr>
+            <a:r>
+              <a:rPr lang="en-US" sz="2600" b="1" dirty="0">
+                <a:solidFill>
+                  <a:srgbClr val="1A1A1A"/>
+                </a:solidFill>
+                <a:latin typeface="Helvetica Neue" pitchFamily="34" charset="0"/>
+                <a:ea typeface="Helvetica Neue" pitchFamily="34" charset="-122"/>
+                <a:cs typeface="Helvetica Neue" pitchFamily="34" charset="-120"/>
+              </a:rPr>
+              <a:t>GitHub </a:t>
+            </a:r>
+            <a:pPr indent="0" marL="0">
+              <a:spcAft>
+                <a:spcPts val="600"/>
+              </a:spcAft>
+              <a:buNone/>
+            </a:pPr>
+            <a:r>
+              <a:rPr lang="en-US" sz="2600" dirty="0">
+                <a:solidFill>
+                  <a:srgbClr val="404040"/>
+                </a:solidFill>
+                <a:latin typeface="Helvetica Neue" pitchFamily="34" charset="0"/>
+                <a:ea typeface="Helvetica Neue" pitchFamily="34" charset="-122"/>
+                <a:cs typeface="Helvetica Neue" pitchFamily="34" charset="-120"/>
+              </a:rPr>
+              <a:t>stocke le code,
+</a:t>
+            </a:r>
+            <a:pPr indent="0" marL="0">
+              <a:spcAft>
+                <a:spcPts val="600"/>
+              </a:spcAft>
+              <a:buNone/>
+            </a:pPr>
+            <a:r>
+              <a:rPr lang="en-US" sz="2600" b="1" dirty="0">
+                <a:solidFill>
+                  <a:srgbClr val="1A1A1A"/>
+                </a:solidFill>
+                <a:latin typeface="Helvetica Neue" pitchFamily="34" charset="0"/>
+                <a:ea typeface="Helvetica Neue" pitchFamily="34" charset="-122"/>
+                <a:cs typeface="Helvetica Neue" pitchFamily="34" charset="-120"/>
+              </a:rPr>
+              <a:t>Vercel </a:t>
+            </a:r>
+            <a:pPr indent="0" marL="0">
+              <a:spcAft>
+                <a:spcPts val="600"/>
+              </a:spcAft>
+              <a:buNone/>
+            </a:pPr>
+            <a:r>
+              <a:rPr lang="en-US" sz="2600" dirty="0">
+                <a:solidFill>
+                  <a:srgbClr val="404040"/>
+                </a:solidFill>
+                <a:latin typeface="Helvetica Neue" pitchFamily="34" charset="0"/>
+                <a:ea typeface="Helvetica Neue" pitchFamily="34" charset="-122"/>
+                <a:cs typeface="Helvetica Neue" pitchFamily="34" charset="-120"/>
+              </a:rPr>
+              <a:t>le met en ligne,
+</a:t>
+            </a:r>
+            <a:pPr indent="0" marL="0">
+              <a:spcAft>
+                <a:spcPts val="600"/>
+              </a:spcAft>
+              <a:buNone/>
+            </a:pPr>
+            <a:r>
+              <a:rPr lang="en-US" sz="2600" b="1" dirty="0">
+                <a:solidFill>
+                  <a:srgbClr val="1A1A1A"/>
+                </a:solidFill>
+                <a:latin typeface="Helvetica Neue" pitchFamily="34" charset="0"/>
+                <a:ea typeface="Helvetica Neue" pitchFamily="34" charset="-122"/>
+                <a:cs typeface="Helvetica Neue" pitchFamily="34" charset="-120"/>
+              </a:rPr>
+              <a:t>Next.js </a:t>
+            </a:r>
+            <a:pPr indent="0" marL="0">
+              <a:spcAft>
+                <a:spcPts val="600"/>
+              </a:spcAft>
+              <a:buNone/>
+            </a:pPr>
+            <a:r>
+              <a:rPr lang="en-US" sz="2600" dirty="0">
+                <a:solidFill>
+                  <a:srgbClr val="404040"/>
+                </a:solidFill>
+                <a:latin typeface="Helvetica Neue" pitchFamily="34" charset="0"/>
+                <a:ea typeface="Helvetica Neue" pitchFamily="34" charset="-122"/>
+                <a:cs typeface="Helvetica Neue" pitchFamily="34" charset="-120"/>
+              </a:rPr>
+              <a:t>fait tourner les pages,
+</a:t>
+            </a:r>
+            <a:pPr indent="0" marL="0">
+              <a:spcAft>
+                <a:spcPts val="600"/>
+              </a:spcAft>
+              <a:buNone/>
+            </a:pPr>
+            <a:r>
+              <a:rPr lang="en-US" sz="2600" b="1" dirty="0">
+                <a:solidFill>
+                  <a:srgbClr val="1A1A1A"/>
+                </a:solidFill>
+                <a:latin typeface="Helvetica Neue" pitchFamily="34" charset="0"/>
+                <a:ea typeface="Helvetica Neue" pitchFamily="34" charset="-122"/>
+                <a:cs typeface="Helvetica Neue" pitchFamily="34" charset="-120"/>
+              </a:rPr>
+              <a:t>Airtable </a:t>
+            </a:r>
+            <a:pPr indent="0" marL="0">
+              <a:spcAft>
+                <a:spcPts val="600"/>
+              </a:spcAft>
+              <a:buNone/>
+            </a:pPr>
+            <a:r>
+              <a:rPr lang="en-US" sz="2600" dirty="0">
+                <a:solidFill>
+                  <a:srgbClr val="404040"/>
+                </a:solidFill>
+                <a:latin typeface="Helvetica Neue" pitchFamily="34" charset="0"/>
+                <a:ea typeface="Helvetica Neue" pitchFamily="34" charset="-122"/>
+                <a:cs typeface="Helvetica Neue" pitchFamily="34" charset="-120"/>
+              </a:rPr>
+              <a:t>stocke les données,
+</a:t>
+            </a:r>
+            <a:pPr indent="0" marL="0">
+              <a:spcAft>
+                <a:spcPts val="600"/>
+              </a:spcAft>
+              <a:buNone/>
+            </a:pPr>
+            <a:r>
+              <a:rPr lang="en-US" sz="2600" b="1" dirty="0">
+                <a:solidFill>
+                  <a:srgbClr val="1A1A1A"/>
+                </a:solidFill>
+                <a:latin typeface="Helvetica Neue" pitchFamily="34" charset="0"/>
+                <a:ea typeface="Helvetica Neue" pitchFamily="34" charset="-122"/>
+                <a:cs typeface="Helvetica Neue" pitchFamily="34" charset="-120"/>
+              </a:rPr>
+              <a:t>Resend / Redis / Sentry </a:t>
+            </a:r>
+            <a:pPr indent="0" marL="0">
+              <a:spcAft>
+                <a:spcPts val="600"/>
+              </a:spcAft>
+              <a:buNone/>
+            </a:pPr>
+            <a:r>
+              <a:rPr lang="en-US" sz="2600" dirty="0">
+                <a:solidFill>
+                  <a:srgbClr val="404040"/>
+                </a:solidFill>
+                <a:latin typeface="Helvetica Neue" pitchFamily="34" charset="0"/>
+                <a:ea typeface="Helvetica Neue" pitchFamily="34" charset="-122"/>
+                <a:cs typeface="Helvetica Neue" pitchFamily="34" charset="-120"/>
+              </a:rPr>
+              <a:t>s'occupent des cas tordus.</a:t>
+            </a:r>
+            <a:endParaRPr lang="en-US" sz="2600" dirty="0"/>
+          </a:p>
+        </p:txBody>
+      </p:sp>
+      <p:sp>
+        <p:nvSpPr>
+          <p:cNvPr id="6" name="Text 4"/>
+          <p:cNvSpPr/>
+          <p:nvPr/>
+        </p:nvSpPr>
+        <p:spPr>
+          <a:xfrm>
+            <a:off x="640080" y="5943600"/>
+            <a:ext cx="10881360" cy="365760"/>
+          </a:xfrm>
+          <a:prstGeom prst="rect">
+            <a:avLst/>
+          </a:prstGeom>
+          <a:noFill/>
+          <a:ln/>
+        </p:spPr>
+        <p:txBody>
+          <a:bodyPr wrap="square" lIns="0" tIns="0" rIns="0" bIns="0" rtlCol="0" anchor="ctr"/>
+          <a:lstStyle/>
+          <a:p>
+            <a:pPr indent="0" marL="0">
+              <a:buNone/>
+            </a:pPr>
+            <a:r>
+              <a:rPr lang="en-US" sz="1200" i="1" dirty="0">
+                <a:solidFill>
+                  <a:srgbClr val="8A8A8A"/>
+                </a:solidFill>
+                <a:latin typeface="Helvetica Neue" pitchFamily="34" charset="0"/>
+                <a:ea typeface="Helvetica Neue" pitchFamily="34" charset="-122"/>
+                <a:cs typeface="Helvetica Neue" pitchFamily="34" charset="-120"/>
+              </a:rPr>
+              <a:t>Tout ça gratuit, moderne, interconnecté avec quelques clics.</a:t>
+            </a:r>
+            <a:endParaRPr lang="en-US" sz="1200" dirty="0"/>
+          </a:p>
+        </p:txBody>
+      </p:sp>
+      <p:sp>
+        <p:nvSpPr>
+          <p:cNvPr id="7" name="Text 5"/>
+          <p:cNvSpPr/>
+          <p:nvPr/>
+        </p:nvSpPr>
+        <p:spPr>
+          <a:xfrm>
+            <a:off x="10607040" y="6400800"/>
+            <a:ext cx="914400" cy="274320"/>
+          </a:xfrm>
+          <a:prstGeom prst="rect">
+            <a:avLst/>
+          </a:prstGeom>
+          <a:noFill/>
+          <a:ln/>
+        </p:spPr>
+        <p:txBody>
+          <a:bodyPr wrap="square" lIns="0" tIns="0" rIns="0" bIns="0" rtlCol="0" anchor="ctr"/>
+          <a:lstStyle/>
+          <a:p>
+            <a:pPr algn="r" indent="0" marL="0">
+              <a:buNone/>
+            </a:pPr>
+            <a:r>
+              <a:rPr lang="en-US" sz="900" dirty="0">
+                <a:solidFill>
+                  <a:srgbClr val="8A8A8A"/>
+                </a:solidFill>
+                <a:latin typeface="Helvetica Neue" pitchFamily="34" charset="0"/>
+                <a:ea typeface="Helvetica Neue" pitchFamily="34" charset="-122"/>
+                <a:cs typeface="Helvetica Neue" pitchFamily="34" charset="-120"/>
+              </a:rPr>
+              <a:t>11 / 15</a:t>
+            </a:r>
+            <a:endParaRPr lang="en-US" sz="900" dirty="0"/>
+          </a:p>
+        </p:txBody>
+      </p:sp>
+    </p:spTree>
+  </p:cSld>
+  <p:clrMapOvr>
+    <a:masterClrMapping/>
+  </p:clrMapOvr>
+</p:sld>
+</file>
+
+<file path=ppt/slides/slide12.xml><?xml version="1.0" encoding="utf-8"?>
+<p:sld xmlns:a="http://schemas.openxmlformats.org/drawingml/2006/main" xmlns:r="http://schemas.openxmlformats.org/officeDocument/2006/relationships" xmlns:p="http://schemas.openxmlformats.org/presentationml/2006/main">
+  <p:cSld name="Slide 12">
     <p:bg>
       <p:bgPr>
         <a:solidFill>
@@ -2822,1177 +3473,6 @@
               <a:t>Bob · Alice · Yasmine</a:t>
             </a:r>
             <a:endParaRPr lang="en-US" sz="1100" dirty="0"/>
-          </a:p>
-        </p:txBody>
-      </p:sp>
-    </p:spTree>
-  </p:cSld>
-  <p:clrMapOvr>
-    <a:masterClrMapping/>
-  </p:clrMapOvr>
-</p:sld>
-</file>
-
-<file path=ppt/slides/slide12.xml><?xml version="1.0" encoding="utf-8"?>
-<p:sld xmlns:a="http://schemas.openxmlformats.org/drawingml/2006/main" xmlns:r="http://schemas.openxmlformats.org/officeDocument/2006/relationships" xmlns:p="http://schemas.openxmlformats.org/presentationml/2006/main">
-  <p:cSld name="Slide 12">
-    <p:bg>
-      <p:bgPr>
-        <a:solidFill>
-          <a:srgbClr val="FFFFFF"/>
-        </a:solidFill>
-      </p:bgPr>
-    </p:bg>
-    <p:spTree>
-      <p:nvGrpSpPr>
-        <p:cNvPr id="1" name=""/>
-        <p:cNvGrpSpPr/>
-        <p:nvPr/>
-      </p:nvGrpSpPr>
-      <p:grpSpPr>
-        <a:xfrm>
-          <a:off x="0" y="0"/>
-          <a:ext cx="0" cy="0"/>
-          <a:chOff x="0" y="0"/>
-          <a:chExt cx="0" cy="0"/>
-        </a:xfrm>
-      </p:grpSpPr>
-      <p:sp>
-        <p:nvSpPr>
-          <p:cNvPr id="2" name="Text 0"/>
-          <p:cNvSpPr/>
-          <p:nvPr/>
-        </p:nvSpPr>
-        <p:spPr>
-          <a:xfrm>
-            <a:off x="640080" y="411480"/>
-            <a:ext cx="7315200" cy="274320"/>
-          </a:xfrm>
-          <a:prstGeom prst="rect">
-            <a:avLst/>
-          </a:prstGeom>
-          <a:noFill/>
-          <a:ln/>
-        </p:spPr>
-        <p:txBody>
-          <a:bodyPr wrap="square" lIns="0" tIns="0" rIns="0" bIns="0" rtlCol="0" anchor="ctr"/>
-          <a:lstStyle/>
-          <a:p>
-            <a:pPr indent="0" marL="0">
-              <a:buNone/>
-            </a:pPr>
-            <a:r>
-              <a:rPr lang="en-US" sz="900" spc="400" kern="0" dirty="0">
-                <a:solidFill>
-                  <a:srgbClr val="8A8A8A"/>
-                </a:solidFill>
-                <a:latin typeface="Helvetica Neue" pitchFamily="34" charset="0"/>
-                <a:ea typeface="Helvetica Neue" pitchFamily="34" charset="-122"/>
-                <a:cs typeface="Helvetica Neue" pitchFamily="34" charset="-120"/>
-              </a:rPr>
-              <a:t>DÉMO · CASTING</a:t>
-            </a:r>
-            <a:endParaRPr lang="en-US" sz="900" dirty="0"/>
-          </a:p>
-        </p:txBody>
-      </p:sp>
-      <p:sp>
-        <p:nvSpPr>
-          <p:cNvPr id="3" name="Text 1"/>
-          <p:cNvSpPr/>
-          <p:nvPr/>
-        </p:nvSpPr>
-        <p:spPr>
-          <a:xfrm>
-            <a:off x="640080" y="1005840"/>
-            <a:ext cx="10881360" cy="914400"/>
-          </a:xfrm>
-          <a:prstGeom prst="rect">
-            <a:avLst/>
-          </a:prstGeom>
-          <a:noFill/>
-          <a:ln/>
-        </p:spPr>
-        <p:txBody>
-          <a:bodyPr wrap="square" lIns="0" tIns="0" rIns="0" bIns="0" rtlCol="0" anchor="ctr"/>
-          <a:lstStyle/>
-          <a:p>
-            <a:pPr indent="0" marL="0">
-              <a:buNone/>
-            </a:pPr>
-            <a:r>
-              <a:rPr lang="en-US" sz="3600" b="1" dirty="0">
-                <a:solidFill>
-                  <a:srgbClr val="1A1A1A"/>
-                </a:solidFill>
-                <a:latin typeface="Helvetica Neue" pitchFamily="34" charset="0"/>
-                <a:ea typeface="Helvetica Neue" pitchFamily="34" charset="-122"/>
-                <a:cs typeface="Helvetica Neue" pitchFamily="34" charset="-120"/>
-              </a:rPr>
-              <a:t>3 personas, 3 onglets</a:t>
-            </a:r>
-            <a:endParaRPr lang="en-US" sz="3600" dirty="0"/>
-          </a:p>
-        </p:txBody>
-      </p:sp>
-      <p:sp>
-        <p:nvSpPr>
-          <p:cNvPr id="4" name="Shape 2"/>
-          <p:cNvSpPr/>
-          <p:nvPr/>
-        </p:nvSpPr>
-        <p:spPr>
-          <a:xfrm>
-            <a:off x="640080" y="1874520"/>
-            <a:ext cx="548640" cy="0"/>
-          </a:xfrm>
-          <a:prstGeom prst="line">
-            <a:avLst/>
-          </a:prstGeom>
-          <a:noFill/>
-          <a:ln w="19050">
-            <a:solidFill>
-              <a:srgbClr val="1A1A1A"/>
-            </a:solidFill>
-            <a:prstDash val="solid"/>
-          </a:ln>
-        </p:spPr>
-      </p:sp>
-      <p:sp>
-        <p:nvSpPr>
-          <p:cNvPr id="5" name="Shape 3"/>
-          <p:cNvSpPr/>
-          <p:nvPr/>
-        </p:nvSpPr>
-        <p:spPr>
-          <a:xfrm>
-            <a:off x="731520" y="2743200"/>
-            <a:ext cx="3383280" cy="2926080"/>
-          </a:xfrm>
-          <a:prstGeom prst="rect">
-            <a:avLst/>
-          </a:prstGeom>
-          <a:solidFill>
-            <a:srgbClr val="FFFFFF"/>
-          </a:solidFill>
-          <a:ln w="12700">
-            <a:solidFill>
-              <a:srgbClr val="D8D8D5"/>
-            </a:solidFill>
-            <a:prstDash val="solid"/>
-          </a:ln>
-        </p:spPr>
-      </p:sp>
-      <p:sp>
-        <p:nvSpPr>
-          <p:cNvPr id="6" name="Shape 4"/>
-          <p:cNvSpPr/>
-          <p:nvPr/>
-        </p:nvSpPr>
-        <p:spPr>
-          <a:xfrm>
-            <a:off x="731520" y="2743200"/>
-            <a:ext cx="3383280" cy="54864"/>
-          </a:xfrm>
-          <a:prstGeom prst="rect">
-            <a:avLst/>
-          </a:prstGeom>
-          <a:solidFill>
-            <a:srgbClr val="1A1A1A"/>
-          </a:solidFill>
-          <a:ln w="12700">
-            <a:solidFill>
-              <a:srgbClr val="1A1A1A"/>
-            </a:solidFill>
-            <a:prstDash val="solid"/>
-          </a:ln>
-        </p:spPr>
-      </p:sp>
-      <p:sp>
-        <p:nvSpPr>
-          <p:cNvPr id="7" name="Text 5"/>
-          <p:cNvSpPr/>
-          <p:nvPr/>
-        </p:nvSpPr>
-        <p:spPr>
-          <a:xfrm>
-            <a:off x="960120" y="2944368"/>
-            <a:ext cx="2926080" cy="457200"/>
-          </a:xfrm>
-          <a:prstGeom prst="rect">
-            <a:avLst/>
-          </a:prstGeom>
-          <a:noFill/>
-          <a:ln/>
-        </p:spPr>
-        <p:txBody>
-          <a:bodyPr wrap="square" lIns="0" tIns="0" rIns="0" bIns="0" rtlCol="0" anchor="ctr"/>
-          <a:lstStyle/>
-          <a:p>
-            <a:pPr indent="0" marL="0">
-              <a:buNone/>
-            </a:pPr>
-            <a:r>
-              <a:rPr lang="en-US" sz="2200" b="1" dirty="0">
-                <a:solidFill>
-                  <a:srgbClr val="1A1A1A"/>
-                </a:solidFill>
-                <a:latin typeface="Helvetica Neue" pitchFamily="34" charset="0"/>
-                <a:ea typeface="Helvetica Neue" pitchFamily="34" charset="-122"/>
-                <a:cs typeface="Helvetica Neue" pitchFamily="34" charset="-120"/>
-              </a:rPr>
-              <a:t>Bob</a:t>
-            </a:r>
-            <a:endParaRPr lang="en-US" sz="2200" dirty="0"/>
-          </a:p>
-        </p:txBody>
-      </p:sp>
-      <p:sp>
-        <p:nvSpPr>
-          <p:cNvPr id="8" name="Text 6"/>
-          <p:cNvSpPr/>
-          <p:nvPr/>
-        </p:nvSpPr>
-        <p:spPr>
-          <a:xfrm>
-            <a:off x="960120" y="3383280"/>
-            <a:ext cx="2926080" cy="320040"/>
-          </a:xfrm>
-          <a:prstGeom prst="rect">
-            <a:avLst/>
-          </a:prstGeom>
-          <a:noFill/>
-          <a:ln/>
-        </p:spPr>
-        <p:txBody>
-          <a:bodyPr wrap="square" lIns="0" tIns="0" rIns="0" bIns="0" rtlCol="0" anchor="ctr"/>
-          <a:lstStyle/>
-          <a:p>
-            <a:pPr indent="0" marL="0">
-              <a:buNone/>
-            </a:pPr>
-            <a:r>
-              <a:rPr lang="en-US" sz="1100" b="1" spc="300" kern="0" dirty="0">
-                <a:solidFill>
-                  <a:srgbClr val="8A8A8A"/>
-                </a:solidFill>
-                <a:latin typeface="Helvetica Neue" pitchFamily="34" charset="0"/>
-                <a:ea typeface="Helvetica Neue" pitchFamily="34" charset="-122"/>
-                <a:cs typeface="Helvetica Neue" pitchFamily="34" charset="-120"/>
-              </a:rPr>
-              <a:t>Utilisateur</a:t>
-            </a:r>
-            <a:endParaRPr lang="en-US" sz="1100" dirty="0"/>
-          </a:p>
-        </p:txBody>
-      </p:sp>
-      <p:sp>
-        <p:nvSpPr>
-          <p:cNvPr id="9" name="Shape 7"/>
-          <p:cNvSpPr/>
-          <p:nvPr/>
-        </p:nvSpPr>
-        <p:spPr>
-          <a:xfrm>
-            <a:off x="960120" y="3950208"/>
-            <a:ext cx="109728" cy="109728"/>
-          </a:xfrm>
-          <a:prstGeom prst="ellipse">
-            <a:avLst/>
-          </a:prstGeom>
-          <a:solidFill>
-            <a:srgbClr val="1A1A1A"/>
-          </a:solidFill>
-          <a:ln w="12700">
-            <a:solidFill>
-              <a:srgbClr val="1A1A1A"/>
-            </a:solidFill>
-            <a:prstDash val="solid"/>
-          </a:ln>
-        </p:spPr>
-      </p:sp>
-      <p:sp>
-        <p:nvSpPr>
-          <p:cNvPr id="10" name="Text 8"/>
-          <p:cNvSpPr/>
-          <p:nvPr/>
-        </p:nvSpPr>
-        <p:spPr>
-          <a:xfrm>
-            <a:off x="1188720" y="3840480"/>
-            <a:ext cx="2697480" cy="457200"/>
-          </a:xfrm>
-          <a:prstGeom prst="rect">
-            <a:avLst/>
-          </a:prstGeom>
-          <a:noFill/>
-          <a:ln/>
-        </p:spPr>
-        <p:txBody>
-          <a:bodyPr wrap="square" lIns="0" tIns="0" rIns="0" bIns="0" rtlCol="0" anchor="ctr"/>
-          <a:lstStyle/>
-          <a:p>
-            <a:pPr indent="0" marL="0">
-              <a:buNone/>
-            </a:pPr>
-            <a:r>
-              <a:rPr lang="en-US" sz="1200" dirty="0">
-                <a:solidFill>
-                  <a:srgbClr val="404040"/>
-                </a:solidFill>
-                <a:latin typeface="Helvetica Neue" pitchFamily="34" charset="0"/>
-                <a:ea typeface="Helvetica Neue" pitchFamily="34" charset="-122"/>
-                <a:cs typeface="Helvetica Neue" pitchFamily="34" charset="-120"/>
-              </a:rPr>
-              <a:t>Soumet une idée : “mode sombre”</a:t>
-            </a:r>
-            <a:endParaRPr lang="en-US" sz="1200" dirty="0"/>
-          </a:p>
-        </p:txBody>
-      </p:sp>
-      <p:sp>
-        <p:nvSpPr>
-          <p:cNvPr id="11" name="Shape 9"/>
-          <p:cNvSpPr/>
-          <p:nvPr/>
-        </p:nvSpPr>
-        <p:spPr>
-          <a:xfrm>
-            <a:off x="960120" y="4453128"/>
-            <a:ext cx="109728" cy="109728"/>
-          </a:xfrm>
-          <a:prstGeom prst="ellipse">
-            <a:avLst/>
-          </a:prstGeom>
-          <a:solidFill>
-            <a:srgbClr val="1A1A1A"/>
-          </a:solidFill>
-          <a:ln w="12700">
-            <a:solidFill>
-              <a:srgbClr val="1A1A1A"/>
-            </a:solidFill>
-            <a:prstDash val="solid"/>
-          </a:ln>
-        </p:spPr>
-      </p:sp>
-      <p:sp>
-        <p:nvSpPr>
-          <p:cNvPr id="12" name="Text 10"/>
-          <p:cNvSpPr/>
-          <p:nvPr/>
-        </p:nvSpPr>
-        <p:spPr>
-          <a:xfrm>
-            <a:off x="1188720" y="4343400"/>
-            <a:ext cx="2697480" cy="457200"/>
-          </a:xfrm>
-          <a:prstGeom prst="rect">
-            <a:avLst/>
-          </a:prstGeom>
-          <a:noFill/>
-          <a:ln/>
-        </p:spPr>
-        <p:txBody>
-          <a:bodyPr wrap="square" lIns="0" tIns="0" rIns="0" bIns="0" rtlCol="0" anchor="ctr"/>
-          <a:lstStyle/>
-          <a:p>
-            <a:pPr indent="0" marL="0">
-              <a:buNone/>
-            </a:pPr>
-            <a:r>
-              <a:rPr lang="en-US" sz="1200" dirty="0">
-                <a:solidFill>
-                  <a:srgbClr val="404040"/>
-                </a:solidFill>
-                <a:latin typeface="Helvetica Neue" pitchFamily="34" charset="0"/>
-                <a:ea typeface="Helvetica Neue" pitchFamily="34" charset="-122"/>
-                <a:cs typeface="Helvetica Neue" pitchFamily="34" charset="-120"/>
-              </a:rPr>
-              <a:t>Vote sur un autre feedback</a:t>
-            </a:r>
-            <a:endParaRPr lang="en-US" sz="1200" dirty="0"/>
-          </a:p>
-        </p:txBody>
-      </p:sp>
-      <p:sp>
-        <p:nvSpPr>
-          <p:cNvPr id="13" name="Shape 11"/>
-          <p:cNvSpPr/>
-          <p:nvPr/>
-        </p:nvSpPr>
-        <p:spPr>
-          <a:xfrm>
-            <a:off x="960120" y="4956048"/>
-            <a:ext cx="109728" cy="109728"/>
-          </a:xfrm>
-          <a:prstGeom prst="ellipse">
-            <a:avLst/>
-          </a:prstGeom>
-          <a:solidFill>
-            <a:srgbClr val="1A1A1A"/>
-          </a:solidFill>
-          <a:ln w="12700">
-            <a:solidFill>
-              <a:srgbClr val="1A1A1A"/>
-            </a:solidFill>
-            <a:prstDash val="solid"/>
-          </a:ln>
-        </p:spPr>
-      </p:sp>
-      <p:sp>
-        <p:nvSpPr>
-          <p:cNvPr id="14" name="Text 12"/>
-          <p:cNvSpPr/>
-          <p:nvPr/>
-        </p:nvSpPr>
-        <p:spPr>
-          <a:xfrm>
-            <a:off x="1188720" y="4846320"/>
-            <a:ext cx="2697480" cy="457200"/>
-          </a:xfrm>
-          <a:prstGeom prst="rect">
-            <a:avLst/>
-          </a:prstGeom>
-          <a:noFill/>
-          <a:ln/>
-        </p:spPr>
-        <p:txBody>
-          <a:bodyPr wrap="square" lIns="0" tIns="0" rIns="0" bIns="0" rtlCol="0" anchor="ctr"/>
-          <a:lstStyle/>
-          <a:p>
-            <a:pPr indent="0" marL="0">
-              <a:buNone/>
-            </a:pPr>
-            <a:r>
-              <a:rPr lang="en-US" sz="1200" dirty="0">
-                <a:solidFill>
-                  <a:srgbClr val="404040"/>
-                </a:solidFill>
-                <a:latin typeface="Helvetica Neue" pitchFamily="34" charset="0"/>
-                <a:ea typeface="Helvetica Neue" pitchFamily="34" charset="-122"/>
-                <a:cs typeface="Helvetica Neue" pitchFamily="34" charset="-120"/>
-              </a:rPr>
-              <a:t>Reçoit la notification de livraison</a:t>
-            </a:r>
-            <a:endParaRPr lang="en-US" sz="1200" dirty="0"/>
-          </a:p>
-        </p:txBody>
-      </p:sp>
-      <p:sp>
-        <p:nvSpPr>
-          <p:cNvPr id="15" name="Shape 13"/>
-          <p:cNvSpPr/>
-          <p:nvPr/>
-        </p:nvSpPr>
-        <p:spPr>
-          <a:xfrm>
-            <a:off x="4389120" y="2743200"/>
-            <a:ext cx="3383280" cy="2926080"/>
-          </a:xfrm>
-          <a:prstGeom prst="rect">
-            <a:avLst/>
-          </a:prstGeom>
-          <a:solidFill>
-            <a:srgbClr val="FFFFFF"/>
-          </a:solidFill>
-          <a:ln w="12700">
-            <a:solidFill>
-              <a:srgbClr val="D8D8D5"/>
-            </a:solidFill>
-            <a:prstDash val="solid"/>
-          </a:ln>
-        </p:spPr>
-      </p:sp>
-      <p:sp>
-        <p:nvSpPr>
-          <p:cNvPr id="16" name="Shape 14"/>
-          <p:cNvSpPr/>
-          <p:nvPr/>
-        </p:nvSpPr>
-        <p:spPr>
-          <a:xfrm>
-            <a:off x="4389120" y="2743200"/>
-            <a:ext cx="3383280" cy="54864"/>
-          </a:xfrm>
-          <a:prstGeom prst="rect">
-            <a:avLst/>
-          </a:prstGeom>
-          <a:solidFill>
-            <a:srgbClr val="1A1A1A"/>
-          </a:solidFill>
-          <a:ln w="12700">
-            <a:solidFill>
-              <a:srgbClr val="1A1A1A"/>
-            </a:solidFill>
-            <a:prstDash val="solid"/>
-          </a:ln>
-        </p:spPr>
-      </p:sp>
-      <p:sp>
-        <p:nvSpPr>
-          <p:cNvPr id="17" name="Text 15"/>
-          <p:cNvSpPr/>
-          <p:nvPr/>
-        </p:nvSpPr>
-        <p:spPr>
-          <a:xfrm>
-            <a:off x="4617720" y="2944368"/>
-            <a:ext cx="2926080" cy="457200"/>
-          </a:xfrm>
-          <a:prstGeom prst="rect">
-            <a:avLst/>
-          </a:prstGeom>
-          <a:noFill/>
-          <a:ln/>
-        </p:spPr>
-        <p:txBody>
-          <a:bodyPr wrap="square" lIns="0" tIns="0" rIns="0" bIns="0" rtlCol="0" anchor="ctr"/>
-          <a:lstStyle/>
-          <a:p>
-            <a:pPr indent="0" marL="0">
-              <a:buNone/>
-            </a:pPr>
-            <a:r>
-              <a:rPr lang="en-US" sz="2200" b="1" dirty="0">
-                <a:solidFill>
-                  <a:srgbClr val="1A1A1A"/>
-                </a:solidFill>
-                <a:latin typeface="Helvetica Neue" pitchFamily="34" charset="0"/>
-                <a:ea typeface="Helvetica Neue" pitchFamily="34" charset="-122"/>
-                <a:cs typeface="Helvetica Neue" pitchFamily="34" charset="-120"/>
-              </a:rPr>
-              <a:t>Alice</a:t>
-            </a:r>
-            <a:endParaRPr lang="en-US" sz="2200" dirty="0"/>
-          </a:p>
-        </p:txBody>
-      </p:sp>
-      <p:sp>
-        <p:nvSpPr>
-          <p:cNvPr id="18" name="Text 16"/>
-          <p:cNvSpPr/>
-          <p:nvPr/>
-        </p:nvSpPr>
-        <p:spPr>
-          <a:xfrm>
-            <a:off x="4617720" y="3383280"/>
-            <a:ext cx="2926080" cy="320040"/>
-          </a:xfrm>
-          <a:prstGeom prst="rect">
-            <a:avLst/>
-          </a:prstGeom>
-          <a:noFill/>
-          <a:ln/>
-        </p:spPr>
-        <p:txBody>
-          <a:bodyPr wrap="square" lIns="0" tIns="0" rIns="0" bIns="0" rtlCol="0" anchor="ctr"/>
-          <a:lstStyle/>
-          <a:p>
-            <a:pPr indent="0" marL="0">
-              <a:buNone/>
-            </a:pPr>
-            <a:r>
-              <a:rPr lang="en-US" sz="1100" b="1" spc="300" kern="0" dirty="0">
-                <a:solidFill>
-                  <a:srgbClr val="8A8A8A"/>
-                </a:solidFill>
-                <a:latin typeface="Helvetica Neue" pitchFamily="34" charset="0"/>
-                <a:ea typeface="Helvetica Neue" pitchFamily="34" charset="-122"/>
-                <a:cs typeface="Helvetica Neue" pitchFamily="34" charset="-120"/>
-              </a:rPr>
-              <a:t>Admin produit</a:t>
-            </a:r>
-            <a:endParaRPr lang="en-US" sz="1100" dirty="0"/>
-          </a:p>
-        </p:txBody>
-      </p:sp>
-      <p:sp>
-        <p:nvSpPr>
-          <p:cNvPr id="19" name="Shape 17"/>
-          <p:cNvSpPr/>
-          <p:nvPr/>
-        </p:nvSpPr>
-        <p:spPr>
-          <a:xfrm>
-            <a:off x="4617720" y="3950208"/>
-            <a:ext cx="109728" cy="109728"/>
-          </a:xfrm>
-          <a:prstGeom prst="ellipse">
-            <a:avLst/>
-          </a:prstGeom>
-          <a:solidFill>
-            <a:srgbClr val="1A1A1A"/>
-          </a:solidFill>
-          <a:ln w="12700">
-            <a:solidFill>
-              <a:srgbClr val="1A1A1A"/>
-            </a:solidFill>
-            <a:prstDash val="solid"/>
-          </a:ln>
-        </p:spPr>
-      </p:sp>
-      <p:sp>
-        <p:nvSpPr>
-          <p:cNvPr id="20" name="Text 18"/>
-          <p:cNvSpPr/>
-          <p:nvPr/>
-        </p:nvSpPr>
-        <p:spPr>
-          <a:xfrm>
-            <a:off x="4846320" y="3840480"/>
-            <a:ext cx="2697480" cy="457200"/>
-          </a:xfrm>
-          <a:prstGeom prst="rect">
-            <a:avLst/>
-          </a:prstGeom>
-          <a:noFill/>
-          <a:ln/>
-        </p:spPr>
-        <p:txBody>
-          <a:bodyPr wrap="square" lIns="0" tIns="0" rIns="0" bIns="0" rtlCol="0" anchor="ctr"/>
-          <a:lstStyle/>
-          <a:p>
-            <a:pPr indent="0" marL="0">
-              <a:buNone/>
-            </a:pPr>
-            <a:r>
-              <a:rPr lang="en-US" sz="1200" dirty="0">
-                <a:solidFill>
-                  <a:srgbClr val="404040"/>
-                </a:solidFill>
-                <a:latin typeface="Helvetica Neue" pitchFamily="34" charset="0"/>
-                <a:ea typeface="Helvetica Neue" pitchFamily="34" charset="-122"/>
-                <a:cs typeface="Helvetica Neue" pitchFamily="34" charset="-120"/>
-              </a:rPr>
-              <a:t>Voit le tableau de bord (KPIs, charts)</a:t>
-            </a:r>
-            <a:endParaRPr lang="en-US" sz="1200" dirty="0"/>
-          </a:p>
-        </p:txBody>
-      </p:sp>
-      <p:sp>
-        <p:nvSpPr>
-          <p:cNvPr id="21" name="Shape 19"/>
-          <p:cNvSpPr/>
-          <p:nvPr/>
-        </p:nvSpPr>
-        <p:spPr>
-          <a:xfrm>
-            <a:off x="4617720" y="4453128"/>
-            <a:ext cx="109728" cy="109728"/>
-          </a:xfrm>
-          <a:prstGeom prst="ellipse">
-            <a:avLst/>
-          </a:prstGeom>
-          <a:solidFill>
-            <a:srgbClr val="1A1A1A"/>
-          </a:solidFill>
-          <a:ln w="12700">
-            <a:solidFill>
-              <a:srgbClr val="1A1A1A"/>
-            </a:solidFill>
-            <a:prstDash val="solid"/>
-          </a:ln>
-        </p:spPr>
-      </p:sp>
-      <p:sp>
-        <p:nvSpPr>
-          <p:cNvPr id="22" name="Text 20"/>
-          <p:cNvSpPr/>
-          <p:nvPr/>
-        </p:nvSpPr>
-        <p:spPr>
-          <a:xfrm>
-            <a:off x="4846320" y="4343400"/>
-            <a:ext cx="2697480" cy="457200"/>
-          </a:xfrm>
-          <a:prstGeom prst="rect">
-            <a:avLst/>
-          </a:prstGeom>
-          <a:noFill/>
-          <a:ln/>
-        </p:spPr>
-        <p:txBody>
-          <a:bodyPr wrap="square" lIns="0" tIns="0" rIns="0" bIns="0" rtlCol="0" anchor="ctr"/>
-          <a:lstStyle/>
-          <a:p>
-            <a:pPr indent="0" marL="0">
-              <a:buNone/>
-            </a:pPr>
-            <a:r>
-              <a:rPr lang="en-US" sz="1200" dirty="0">
-                <a:solidFill>
-                  <a:srgbClr val="404040"/>
-                </a:solidFill>
-                <a:latin typeface="Helvetica Neue" pitchFamily="34" charset="0"/>
-                <a:ea typeface="Helvetica Neue" pitchFamily="34" charset="-122"/>
-                <a:cs typeface="Helvetica Neue" pitchFamily="34" charset="-120"/>
-              </a:rPr>
-              <a:t>Identifie le top des votes</a:t>
-            </a:r>
-            <a:endParaRPr lang="en-US" sz="1200" dirty="0"/>
-          </a:p>
-        </p:txBody>
-      </p:sp>
-      <p:sp>
-        <p:nvSpPr>
-          <p:cNvPr id="23" name="Shape 21"/>
-          <p:cNvSpPr/>
-          <p:nvPr/>
-        </p:nvSpPr>
-        <p:spPr>
-          <a:xfrm>
-            <a:off x="4617720" y="4956048"/>
-            <a:ext cx="109728" cy="109728"/>
-          </a:xfrm>
-          <a:prstGeom prst="ellipse">
-            <a:avLst/>
-          </a:prstGeom>
-          <a:solidFill>
-            <a:srgbClr val="1A1A1A"/>
-          </a:solidFill>
-          <a:ln w="12700">
-            <a:solidFill>
-              <a:srgbClr val="1A1A1A"/>
-            </a:solidFill>
-            <a:prstDash val="solid"/>
-          </a:ln>
-        </p:spPr>
-      </p:sp>
-      <p:sp>
-        <p:nvSpPr>
-          <p:cNvPr id="24" name="Text 22"/>
-          <p:cNvSpPr/>
-          <p:nvPr/>
-        </p:nvSpPr>
-        <p:spPr>
-          <a:xfrm>
-            <a:off x="4846320" y="4846320"/>
-            <a:ext cx="2697480" cy="457200"/>
-          </a:xfrm>
-          <a:prstGeom prst="rect">
-            <a:avLst/>
-          </a:prstGeom>
-          <a:noFill/>
-          <a:ln/>
-        </p:spPr>
-        <p:txBody>
-          <a:bodyPr wrap="square" lIns="0" tIns="0" rIns="0" bIns="0" rtlCol="0" anchor="ctr"/>
-          <a:lstStyle/>
-          <a:p>
-            <a:pPr indent="0" marL="0">
-              <a:buNone/>
-            </a:pPr>
-            <a:r>
-              <a:rPr lang="en-US" sz="1200" dirty="0">
-                <a:solidFill>
-                  <a:srgbClr val="404040"/>
-                </a:solidFill>
-                <a:latin typeface="Helvetica Neue" pitchFamily="34" charset="0"/>
-                <a:ea typeface="Helvetica Neue" pitchFamily="34" charset="-122"/>
-                <a:cs typeface="Helvetica Neue" pitchFamily="34" charset="-120"/>
-              </a:rPr>
-              <a:t>Envoie l'idée au backlog dev</a:t>
-            </a:r>
-            <a:endParaRPr lang="en-US" sz="1200" dirty="0"/>
-          </a:p>
-        </p:txBody>
-      </p:sp>
-      <p:sp>
-        <p:nvSpPr>
-          <p:cNvPr id="25" name="Shape 23"/>
-          <p:cNvSpPr/>
-          <p:nvPr/>
-        </p:nvSpPr>
-        <p:spPr>
-          <a:xfrm>
-            <a:off x="8046720" y="2743200"/>
-            <a:ext cx="3383280" cy="2926080"/>
-          </a:xfrm>
-          <a:prstGeom prst="rect">
-            <a:avLst/>
-          </a:prstGeom>
-          <a:solidFill>
-            <a:srgbClr val="FFFFFF"/>
-          </a:solidFill>
-          <a:ln w="12700">
-            <a:solidFill>
-              <a:srgbClr val="D8D8D5"/>
-            </a:solidFill>
-            <a:prstDash val="solid"/>
-          </a:ln>
-        </p:spPr>
-      </p:sp>
-      <p:sp>
-        <p:nvSpPr>
-          <p:cNvPr id="26" name="Shape 24"/>
-          <p:cNvSpPr/>
-          <p:nvPr/>
-        </p:nvSpPr>
-        <p:spPr>
-          <a:xfrm>
-            <a:off x="8046720" y="2743200"/>
-            <a:ext cx="3383280" cy="54864"/>
-          </a:xfrm>
-          <a:prstGeom prst="rect">
-            <a:avLst/>
-          </a:prstGeom>
-          <a:solidFill>
-            <a:srgbClr val="1A1A1A"/>
-          </a:solidFill>
-          <a:ln w="12700">
-            <a:solidFill>
-              <a:srgbClr val="1A1A1A"/>
-            </a:solidFill>
-            <a:prstDash val="solid"/>
-          </a:ln>
-        </p:spPr>
-      </p:sp>
-      <p:sp>
-        <p:nvSpPr>
-          <p:cNvPr id="27" name="Text 25"/>
-          <p:cNvSpPr/>
-          <p:nvPr/>
-        </p:nvSpPr>
-        <p:spPr>
-          <a:xfrm>
-            <a:off x="8275320" y="2944368"/>
-            <a:ext cx="2926080" cy="457200"/>
-          </a:xfrm>
-          <a:prstGeom prst="rect">
-            <a:avLst/>
-          </a:prstGeom>
-          <a:noFill/>
-          <a:ln/>
-        </p:spPr>
-        <p:txBody>
-          <a:bodyPr wrap="square" lIns="0" tIns="0" rIns="0" bIns="0" rtlCol="0" anchor="ctr"/>
-          <a:lstStyle/>
-          <a:p>
-            <a:pPr indent="0" marL="0">
-              <a:buNone/>
-            </a:pPr>
-            <a:r>
-              <a:rPr lang="en-US" sz="2200" b="1" dirty="0">
-                <a:solidFill>
-                  <a:srgbClr val="1A1A1A"/>
-                </a:solidFill>
-                <a:latin typeface="Helvetica Neue" pitchFamily="34" charset="0"/>
-                <a:ea typeface="Helvetica Neue" pitchFamily="34" charset="-122"/>
-                <a:cs typeface="Helvetica Neue" pitchFamily="34" charset="-120"/>
-              </a:rPr>
-              <a:t>Yasmine</a:t>
-            </a:r>
-            <a:endParaRPr lang="en-US" sz="2200" dirty="0"/>
-          </a:p>
-        </p:txBody>
-      </p:sp>
-      <p:sp>
-        <p:nvSpPr>
-          <p:cNvPr id="28" name="Text 26"/>
-          <p:cNvSpPr/>
-          <p:nvPr/>
-        </p:nvSpPr>
-        <p:spPr>
-          <a:xfrm>
-            <a:off x="8275320" y="3383280"/>
-            <a:ext cx="2926080" cy="320040"/>
-          </a:xfrm>
-          <a:prstGeom prst="rect">
-            <a:avLst/>
-          </a:prstGeom>
-          <a:noFill/>
-          <a:ln/>
-        </p:spPr>
-        <p:txBody>
-          <a:bodyPr wrap="square" lIns="0" tIns="0" rIns="0" bIns="0" rtlCol="0" anchor="ctr"/>
-          <a:lstStyle/>
-          <a:p>
-            <a:pPr indent="0" marL="0">
-              <a:buNone/>
-            </a:pPr>
-            <a:r>
-              <a:rPr lang="en-US" sz="1100" b="1" spc="300" kern="0" dirty="0">
-                <a:solidFill>
-                  <a:srgbClr val="8A8A8A"/>
-                </a:solidFill>
-                <a:latin typeface="Helvetica Neue" pitchFamily="34" charset="0"/>
-                <a:ea typeface="Helvetica Neue" pitchFamily="34" charset="-122"/>
-                <a:cs typeface="Helvetica Neue" pitchFamily="34" charset="-120"/>
-              </a:rPr>
-              <a:t>Développeuse</a:t>
-            </a:r>
-            <a:endParaRPr lang="en-US" sz="1100" dirty="0"/>
-          </a:p>
-        </p:txBody>
-      </p:sp>
-      <p:sp>
-        <p:nvSpPr>
-          <p:cNvPr id="29" name="Shape 27"/>
-          <p:cNvSpPr/>
-          <p:nvPr/>
-        </p:nvSpPr>
-        <p:spPr>
-          <a:xfrm>
-            <a:off x="8275320" y="3950208"/>
-            <a:ext cx="109728" cy="109728"/>
-          </a:xfrm>
-          <a:prstGeom prst="ellipse">
-            <a:avLst/>
-          </a:prstGeom>
-          <a:solidFill>
-            <a:srgbClr val="1A1A1A"/>
-          </a:solidFill>
-          <a:ln w="12700">
-            <a:solidFill>
-              <a:srgbClr val="1A1A1A"/>
-            </a:solidFill>
-            <a:prstDash val="solid"/>
-          </a:ln>
-        </p:spPr>
-      </p:sp>
-      <p:sp>
-        <p:nvSpPr>
-          <p:cNvPr id="30" name="Text 28"/>
-          <p:cNvSpPr/>
-          <p:nvPr/>
-        </p:nvSpPr>
-        <p:spPr>
-          <a:xfrm>
-            <a:off x="8503920" y="3840480"/>
-            <a:ext cx="2697480" cy="457200"/>
-          </a:xfrm>
-          <a:prstGeom prst="rect">
-            <a:avLst/>
-          </a:prstGeom>
-          <a:noFill/>
-          <a:ln/>
-        </p:spPr>
-        <p:txBody>
-          <a:bodyPr wrap="square" lIns="0" tIns="0" rIns="0" bIns="0" rtlCol="0" anchor="ctr"/>
-          <a:lstStyle/>
-          <a:p>
-            <a:pPr indent="0" marL="0">
-              <a:buNone/>
-            </a:pPr>
-            <a:r>
-              <a:rPr lang="en-US" sz="1200" dirty="0">
-                <a:solidFill>
-                  <a:srgbClr val="404040"/>
-                </a:solidFill>
-                <a:latin typeface="Helvetica Neue" pitchFamily="34" charset="0"/>
-                <a:ea typeface="Helvetica Neue" pitchFamily="34" charset="-122"/>
-                <a:cs typeface="Helvetica Neue" pitchFamily="34" charset="-120"/>
-              </a:rPr>
-              <a:t>Prend le ticket dans le kanban</a:t>
-            </a:r>
-            <a:endParaRPr lang="en-US" sz="1200" dirty="0"/>
-          </a:p>
-        </p:txBody>
-      </p:sp>
-      <p:sp>
-        <p:nvSpPr>
-          <p:cNvPr id="31" name="Shape 29"/>
-          <p:cNvSpPr/>
-          <p:nvPr/>
-        </p:nvSpPr>
-        <p:spPr>
-          <a:xfrm>
-            <a:off x="8275320" y="4453128"/>
-            <a:ext cx="109728" cy="109728"/>
-          </a:xfrm>
-          <a:prstGeom prst="ellipse">
-            <a:avLst/>
-          </a:prstGeom>
-          <a:solidFill>
-            <a:srgbClr val="1A1A1A"/>
-          </a:solidFill>
-          <a:ln w="12700">
-            <a:solidFill>
-              <a:srgbClr val="1A1A1A"/>
-            </a:solidFill>
-            <a:prstDash val="solid"/>
-          </a:ln>
-        </p:spPr>
-      </p:sp>
-      <p:sp>
-        <p:nvSpPr>
-          <p:cNvPr id="32" name="Text 30"/>
-          <p:cNvSpPr/>
-          <p:nvPr/>
-        </p:nvSpPr>
-        <p:spPr>
-          <a:xfrm>
-            <a:off x="8503920" y="4343400"/>
-            <a:ext cx="2697480" cy="457200"/>
-          </a:xfrm>
-          <a:prstGeom prst="rect">
-            <a:avLst/>
-          </a:prstGeom>
-          <a:noFill/>
-          <a:ln/>
-        </p:spPr>
-        <p:txBody>
-          <a:bodyPr wrap="square" lIns="0" tIns="0" rIns="0" bIns="0" rtlCol="0" anchor="ctr"/>
-          <a:lstStyle/>
-          <a:p>
-            <a:pPr indent="0" marL="0">
-              <a:buNone/>
-            </a:pPr>
-            <a:r>
-              <a:rPr lang="en-US" sz="1200" dirty="0">
-                <a:solidFill>
-                  <a:srgbClr val="404040"/>
-                </a:solidFill>
-                <a:latin typeface="Helvetica Neue" pitchFamily="34" charset="0"/>
-                <a:ea typeface="Helvetica Neue" pitchFamily="34" charset="-122"/>
-                <a:cs typeface="Helvetica Neue" pitchFamily="34" charset="-120"/>
-              </a:rPr>
-              <a:t>Le déplace : à faire → en cours → review → livré</a:t>
-            </a:r>
-            <a:endParaRPr lang="en-US" sz="1200" dirty="0"/>
-          </a:p>
-        </p:txBody>
-      </p:sp>
-      <p:sp>
-        <p:nvSpPr>
-          <p:cNvPr id="33" name="Shape 31"/>
-          <p:cNvSpPr/>
-          <p:nvPr/>
-        </p:nvSpPr>
-        <p:spPr>
-          <a:xfrm>
-            <a:off x="8275320" y="4956048"/>
-            <a:ext cx="109728" cy="109728"/>
-          </a:xfrm>
-          <a:prstGeom prst="ellipse">
-            <a:avLst/>
-          </a:prstGeom>
-          <a:solidFill>
-            <a:srgbClr val="1A1A1A"/>
-          </a:solidFill>
-          <a:ln w="12700">
-            <a:solidFill>
-              <a:srgbClr val="1A1A1A"/>
-            </a:solidFill>
-            <a:prstDash val="solid"/>
-          </a:ln>
-        </p:spPr>
-      </p:sp>
-      <p:sp>
-        <p:nvSpPr>
-          <p:cNvPr id="34" name="Text 32"/>
-          <p:cNvSpPr/>
-          <p:nvPr/>
-        </p:nvSpPr>
-        <p:spPr>
-          <a:xfrm>
-            <a:off x="8503920" y="4846320"/>
-            <a:ext cx="2697480" cy="457200"/>
-          </a:xfrm>
-          <a:prstGeom prst="rect">
-            <a:avLst/>
-          </a:prstGeom>
-          <a:noFill/>
-          <a:ln/>
-        </p:spPr>
-        <p:txBody>
-          <a:bodyPr wrap="square" lIns="0" tIns="0" rIns="0" bIns="0" rtlCol="0" anchor="ctr"/>
-          <a:lstStyle/>
-          <a:p>
-            <a:pPr indent="0" marL="0">
-              <a:buNone/>
-            </a:pPr>
-            <a:r>
-              <a:rPr lang="en-US" sz="1200" dirty="0">
-                <a:solidFill>
-                  <a:srgbClr val="404040"/>
-                </a:solidFill>
-                <a:latin typeface="Helvetica Neue" pitchFamily="34" charset="0"/>
-                <a:ea typeface="Helvetica Neue" pitchFamily="34" charset="-122"/>
-                <a:cs typeface="Helvetica Neue" pitchFamily="34" charset="-120"/>
-              </a:rPr>
-              <a:t>🎉 Confetti quand c'est livré</a:t>
-            </a:r>
-            <a:endParaRPr lang="en-US" sz="1200" dirty="0"/>
-          </a:p>
-        </p:txBody>
-      </p:sp>
-      <p:sp>
-        <p:nvSpPr>
-          <p:cNvPr id="35" name="Text 33"/>
-          <p:cNvSpPr/>
-          <p:nvPr/>
-        </p:nvSpPr>
-        <p:spPr>
-          <a:xfrm>
-            <a:off x="640080" y="5943600"/>
-            <a:ext cx="10881360" cy="365760"/>
-          </a:xfrm>
-          <a:prstGeom prst="rect">
-            <a:avLst/>
-          </a:prstGeom>
-          <a:noFill/>
-          <a:ln/>
-        </p:spPr>
-        <p:txBody>
-          <a:bodyPr wrap="square" lIns="0" tIns="0" rIns="0" bIns="0" rtlCol="0" anchor="ctr"/>
-          <a:lstStyle/>
-          <a:p>
-            <a:pPr indent="0" marL="0">
-              <a:buNone/>
-            </a:pPr>
-            <a:r>
-              <a:rPr lang="en-US" sz="1300" b="1" i="1" dirty="0">
-                <a:solidFill>
-                  <a:srgbClr val="1A1A1A"/>
-                </a:solidFill>
-                <a:latin typeface="Helvetica Neue" pitchFamily="34" charset="0"/>
-                <a:ea typeface="Helvetica Neue" pitchFamily="34" charset="-122"/>
-                <a:cs typeface="Helvetica Neue" pitchFamily="34" charset="-120"/>
-              </a:rPr>
-              <a:t>Boucle complète : feedback → vote → priorisation → dev → notification.</a:t>
-            </a:r>
-            <a:endParaRPr lang="en-US" sz="1300" dirty="0"/>
-          </a:p>
-        </p:txBody>
-      </p:sp>
-      <p:sp>
-        <p:nvSpPr>
-          <p:cNvPr id="36" name="Text 34"/>
-          <p:cNvSpPr/>
-          <p:nvPr/>
-        </p:nvSpPr>
-        <p:spPr>
-          <a:xfrm>
-            <a:off x="10607040" y="6400800"/>
-            <a:ext cx="914400" cy="274320"/>
-          </a:xfrm>
-          <a:prstGeom prst="rect">
-            <a:avLst/>
-          </a:prstGeom>
-          <a:noFill/>
-          <a:ln/>
-        </p:spPr>
-        <p:txBody>
-          <a:bodyPr wrap="square" lIns="0" tIns="0" rIns="0" bIns="0" rtlCol="0" anchor="ctr"/>
-          <a:lstStyle/>
-          <a:p>
-            <a:pPr algn="r" indent="0" marL="0">
-              <a:buNone/>
-            </a:pPr>
-            <a:r>
-              <a:rPr lang="en-US" sz="900" dirty="0">
-                <a:solidFill>
-                  <a:srgbClr val="8A8A8A"/>
-                </a:solidFill>
-                <a:latin typeface="Helvetica Neue" pitchFamily="34" charset="0"/>
-                <a:ea typeface="Helvetica Neue" pitchFamily="34" charset="-122"/>
-                <a:cs typeface="Helvetica Neue" pitchFamily="34" charset="-120"/>
-              </a:rPr>
-              <a:t>12 / 14</a:t>
-            </a:r>
-            <a:endParaRPr lang="en-US" sz="900" dirty="0"/>
           </a:p>
         </p:txBody>
       </p:sp>
@@ -4061,7 +3541,7 @@
                 <a:ea typeface="Helvetica Neue" pitchFamily="34" charset="-122"/>
                 <a:cs typeface="Helvetica Neue" pitchFamily="34" charset="-120"/>
               </a:rPr>
-              <a:t>RETOUR D'EXPÉRIENCE</a:t>
+              <a:t>DÉMO · CASTING</a:t>
             </a:r>
             <a:endParaRPr lang="en-US" sz="900" dirty="0"/>
           </a:p>
@@ -4100,7 +3580,7 @@
                 <a:ea typeface="Helvetica Neue" pitchFamily="34" charset="-122"/>
                 <a:cs typeface="Helvetica Neue" pitchFamily="34" charset="-120"/>
               </a:rPr>
-              <a:t>Coder en direct vs Bubble — ce que j'ai appris</a:t>
+              <a:t>3 personas, 3 onglets</a:t>
             </a:r>
             <a:endParaRPr lang="en-US" sz="3600" dirty="0"/>
           </a:p>
@@ -4137,8 +3617,33 @@
         </p:nvSpPr>
         <p:spPr>
           <a:xfrm>
-            <a:off x="822960" y="2468880"/>
-            <a:ext cx="5120640" cy="3017520"/>
+            <a:off x="731520" y="2743200"/>
+            <a:ext cx="3383280" cy="2926080"/>
+          </a:xfrm>
+          <a:prstGeom prst="rect">
+            <a:avLst/>
+          </a:prstGeom>
+          <a:solidFill>
+            <a:srgbClr val="FFFFFF"/>
+          </a:solidFill>
+          <a:ln w="12700">
+            <a:solidFill>
+              <a:srgbClr val="D8D8D5"/>
+            </a:solidFill>
+            <a:prstDash val="solid"/>
+          </a:ln>
+        </p:spPr>
+      </p:sp>
+      <p:sp>
+        <p:nvSpPr>
+          <p:cNvPr id="6" name="Shape 4"/>
+          <p:cNvSpPr/>
+          <p:nvPr/>
+        </p:nvSpPr>
+        <p:spPr>
+          <a:xfrm>
+            <a:off x="731520" y="2743200"/>
+            <a:ext cx="3383280" cy="54864"/>
           </a:xfrm>
           <a:prstGeom prst="rect">
             <a:avLst/>
@@ -4156,67 +3661,42 @@
       </p:sp>
       <p:sp>
         <p:nvSpPr>
-          <p:cNvPr id="6" name="Text 4"/>
-          <p:cNvSpPr/>
-          <p:nvPr/>
-        </p:nvSpPr>
-        <p:spPr>
-          <a:xfrm>
-            <a:off x="1143000" y="2743200"/>
-            <a:ext cx="4480560" cy="457200"/>
-          </a:xfrm>
-          <a:prstGeom prst="rect">
-            <a:avLst/>
-          </a:prstGeom>
-          <a:noFill/>
-          <a:ln/>
-        </p:spPr>
-        <p:txBody>
-          <a:bodyPr wrap="square" lIns="0" tIns="0" rIns="0" bIns="0" rtlCol="0" anchor="ctr"/>
-          <a:lstStyle/>
-          <a:p>
-            <a:pPr indent="0" marL="0">
-              <a:buNone/>
-            </a:pPr>
-            <a:r>
-              <a:rPr lang="en-US" sz="1800" b="1" dirty="0">
-                <a:solidFill>
-                  <a:srgbClr val="FFFFFF"/>
-                </a:solidFill>
-                <a:latin typeface="Helvetica Neue" pitchFamily="34" charset="0"/>
-                <a:ea typeface="Helvetica Neue" pitchFamily="34" charset="-122"/>
-                <a:cs typeface="Helvetica Neue" pitchFamily="34" charset="-120"/>
-              </a:rPr>
-              <a:t>Avec le code direct</a:t>
-            </a:r>
-            <a:endParaRPr lang="en-US" sz="1800" dirty="0"/>
-          </a:p>
-        </p:txBody>
-      </p:sp>
-      <p:sp>
-        <p:nvSpPr>
-          <p:cNvPr id="7" name="Shape 5"/>
-          <p:cNvSpPr/>
-          <p:nvPr/>
-        </p:nvSpPr>
-        <p:spPr>
-          <a:xfrm>
-            <a:off x="1143000" y="3456432"/>
-            <a:ext cx="109728" cy="109728"/>
-          </a:xfrm>
-          <a:prstGeom prst="ellipse">
-            <a:avLst/>
-          </a:prstGeom>
-          <a:solidFill>
-            <a:srgbClr val="FFFFFF"/>
-          </a:solidFill>
-          <a:ln w="12700">
-            <a:solidFill>
-              <a:srgbClr val="FFFFFF"/>
-            </a:solidFill>
-            <a:prstDash val="solid"/>
-          </a:ln>
-        </p:spPr>
+          <p:cNvPr id="7" name="Text 5"/>
+          <p:cNvSpPr/>
+          <p:nvPr/>
+        </p:nvSpPr>
+        <p:spPr>
+          <a:xfrm>
+            <a:off x="960120" y="2944368"/>
+            <a:ext cx="2926080" cy="457200"/>
+          </a:xfrm>
+          <a:prstGeom prst="rect">
+            <a:avLst/>
+          </a:prstGeom>
+          <a:noFill/>
+          <a:ln/>
+        </p:spPr>
+        <p:txBody>
+          <a:bodyPr wrap="square" lIns="0" tIns="0" rIns="0" bIns="0" rtlCol="0" anchor="ctr"/>
+          <a:lstStyle/>
+          <a:p>
+            <a:pPr indent="0" marL="0">
+              <a:buNone/>
+            </a:pPr>
+            <a:r>
+              <a:rPr lang="en-US" sz="2200" b="1" dirty="0">
+                <a:solidFill>
+                  <a:srgbClr val="1A1A1A"/>
+                </a:solidFill>
+                <a:latin typeface="Helvetica Neue" pitchFamily="34" charset="0"/>
+                <a:ea typeface="Helvetica Neue" pitchFamily="34" charset="-122"/>
+                <a:cs typeface="Helvetica Neue" pitchFamily="34" charset="-120"/>
+              </a:rPr>
+              <a:t>Bob</a:t>
+            </a:r>
+            <a:endParaRPr lang="en-US" sz="2200" dirty="0"/>
+          </a:p>
+        </p:txBody>
       </p:sp>
       <p:sp>
         <p:nvSpPr>
@@ -4226,34 +3706,34 @@
         </p:nvSpPr>
         <p:spPr>
           <a:xfrm>
-            <a:off x="1371600" y="3337560"/>
-            <a:ext cx="4251960" cy="457200"/>
-          </a:xfrm>
-          <a:prstGeom prst="rect">
-            <a:avLst/>
-          </a:prstGeom>
-          <a:noFill/>
-          <a:ln/>
-        </p:spPr>
-        <p:txBody>
-          <a:bodyPr wrap="square" lIns="0" tIns="0" rIns="0" bIns="0" rtlCol="0" anchor="ctr"/>
-          <a:lstStyle/>
-          <a:p>
-            <a:pPr indent="0" marL="0">
-              <a:buNone/>
-            </a:pPr>
-            <a:r>
-              <a:rPr lang="en-US" sz="1300" dirty="0">
-                <a:solidFill>
-                  <a:srgbClr val="F0F0F0"/>
-                </a:solidFill>
-                <a:latin typeface="Helvetica Neue" pitchFamily="34" charset="0"/>
-                <a:ea typeface="Helvetica Neue" pitchFamily="34" charset="-122"/>
-                <a:cs typeface="Helvetica Neue" pitchFamily="34" charset="-120"/>
-              </a:rPr>
-              <a:t>Vrai git workflow : commits, PRs, CI</a:t>
-            </a:r>
-            <a:endParaRPr lang="en-US" sz="1300" dirty="0"/>
+            <a:off x="960120" y="3383280"/>
+            <a:ext cx="2926080" cy="320040"/>
+          </a:xfrm>
+          <a:prstGeom prst="rect">
+            <a:avLst/>
+          </a:prstGeom>
+          <a:noFill/>
+          <a:ln/>
+        </p:spPr>
+        <p:txBody>
+          <a:bodyPr wrap="square" lIns="0" tIns="0" rIns="0" bIns="0" rtlCol="0" anchor="ctr"/>
+          <a:lstStyle/>
+          <a:p>
+            <a:pPr indent="0" marL="0">
+              <a:buNone/>
+            </a:pPr>
+            <a:r>
+              <a:rPr lang="en-US" sz="1100" b="1" spc="300" kern="0" dirty="0">
+                <a:solidFill>
+                  <a:srgbClr val="8A8A8A"/>
+                </a:solidFill>
+                <a:latin typeface="Helvetica Neue" pitchFamily="34" charset="0"/>
+                <a:ea typeface="Helvetica Neue" pitchFamily="34" charset="-122"/>
+                <a:cs typeface="Helvetica Neue" pitchFamily="34" charset="-120"/>
+              </a:rPr>
+              <a:t>Utilisateur</a:t>
+            </a:r>
+            <a:endParaRPr lang="en-US" sz="1100" dirty="0"/>
           </a:p>
         </p:txBody>
       </p:sp>
@@ -4265,263 +3745,7 @@
         </p:nvSpPr>
         <p:spPr>
           <a:xfrm>
-            <a:off x="1143000" y="3913632"/>
-            <a:ext cx="109728" cy="109728"/>
-          </a:xfrm>
-          <a:prstGeom prst="ellipse">
-            <a:avLst/>
-          </a:prstGeom>
-          <a:solidFill>
-            <a:srgbClr val="FFFFFF"/>
-          </a:solidFill>
-          <a:ln w="12700">
-            <a:solidFill>
-              <a:srgbClr val="FFFFFF"/>
-            </a:solidFill>
-            <a:prstDash val="solid"/>
-          </a:ln>
-        </p:spPr>
-      </p:sp>
-      <p:sp>
-        <p:nvSpPr>
-          <p:cNvPr id="10" name="Text 8"/>
-          <p:cNvSpPr/>
-          <p:nvPr/>
-        </p:nvSpPr>
-        <p:spPr>
-          <a:xfrm>
-            <a:off x="1371600" y="3794760"/>
-            <a:ext cx="4251960" cy="457200"/>
-          </a:xfrm>
-          <a:prstGeom prst="rect">
-            <a:avLst/>
-          </a:prstGeom>
-          <a:noFill/>
-          <a:ln/>
-        </p:spPr>
-        <p:txBody>
-          <a:bodyPr wrap="square" lIns="0" tIns="0" rIns="0" bIns="0" rtlCol="0" anchor="ctr"/>
-          <a:lstStyle/>
-          <a:p>
-            <a:pPr indent="0" marL="0">
-              <a:buNone/>
-            </a:pPr>
-            <a:r>
-              <a:rPr lang="en-US" sz="1300" dirty="0">
-                <a:solidFill>
-                  <a:srgbClr val="F0F0F0"/>
-                </a:solidFill>
-                <a:latin typeface="Helvetica Neue" pitchFamily="34" charset="0"/>
-                <a:ea typeface="Helvetica Neue" pitchFamily="34" charset="-122"/>
-                <a:cs typeface="Helvetica Neue" pitchFamily="34" charset="-120"/>
-              </a:rPr>
-              <a:t>Sécurité serveur : cookies, JWT, rate limit</a:t>
-            </a:r>
-            <a:endParaRPr lang="en-US" sz="1300" dirty="0"/>
-          </a:p>
-        </p:txBody>
-      </p:sp>
-      <p:sp>
-        <p:nvSpPr>
-          <p:cNvPr id="11" name="Shape 9"/>
-          <p:cNvSpPr/>
-          <p:nvPr/>
-        </p:nvSpPr>
-        <p:spPr>
-          <a:xfrm>
-            <a:off x="1143000" y="4370832"/>
-            <a:ext cx="109728" cy="109728"/>
-          </a:xfrm>
-          <a:prstGeom prst="ellipse">
-            <a:avLst/>
-          </a:prstGeom>
-          <a:solidFill>
-            <a:srgbClr val="FFFFFF"/>
-          </a:solidFill>
-          <a:ln w="12700">
-            <a:solidFill>
-              <a:srgbClr val="FFFFFF"/>
-            </a:solidFill>
-            <a:prstDash val="solid"/>
-          </a:ln>
-        </p:spPr>
-      </p:sp>
-      <p:sp>
-        <p:nvSpPr>
-          <p:cNvPr id="12" name="Text 10"/>
-          <p:cNvSpPr/>
-          <p:nvPr/>
-        </p:nvSpPr>
-        <p:spPr>
-          <a:xfrm>
-            <a:off x="1371600" y="4251960"/>
-            <a:ext cx="4251960" cy="457200"/>
-          </a:xfrm>
-          <a:prstGeom prst="rect">
-            <a:avLst/>
-          </a:prstGeom>
-          <a:noFill/>
-          <a:ln/>
-        </p:spPr>
-        <p:txBody>
-          <a:bodyPr wrap="square" lIns="0" tIns="0" rIns="0" bIns="0" rtlCol="0" anchor="ctr"/>
-          <a:lstStyle/>
-          <a:p>
-            <a:pPr indent="0" marL="0">
-              <a:buNone/>
-            </a:pPr>
-            <a:r>
-              <a:rPr lang="en-US" sz="1300" dirty="0">
-                <a:solidFill>
-                  <a:srgbClr val="F0F0F0"/>
-                </a:solidFill>
-                <a:latin typeface="Helvetica Neue" pitchFamily="34" charset="0"/>
-                <a:ea typeface="Helvetica Neue" pitchFamily="34" charset="-122"/>
-                <a:cs typeface="Helvetica Neue" pitchFamily="34" charset="-120"/>
-              </a:rPr>
-              <a:t>Déploiement et monitoring prod</a:t>
-            </a:r>
-            <a:endParaRPr lang="en-US" sz="1300" dirty="0"/>
-          </a:p>
-        </p:txBody>
-      </p:sp>
-      <p:sp>
-        <p:nvSpPr>
-          <p:cNvPr id="13" name="Shape 11"/>
-          <p:cNvSpPr/>
-          <p:nvPr/>
-        </p:nvSpPr>
-        <p:spPr>
-          <a:xfrm>
-            <a:off x="1143000" y="4828032"/>
-            <a:ext cx="109728" cy="109728"/>
-          </a:xfrm>
-          <a:prstGeom prst="ellipse">
-            <a:avLst/>
-          </a:prstGeom>
-          <a:solidFill>
-            <a:srgbClr val="FFFFFF"/>
-          </a:solidFill>
-          <a:ln w="12700">
-            <a:solidFill>
-              <a:srgbClr val="FFFFFF"/>
-            </a:solidFill>
-            <a:prstDash val="solid"/>
-          </a:ln>
-        </p:spPr>
-      </p:sp>
-      <p:sp>
-        <p:nvSpPr>
-          <p:cNvPr id="14" name="Text 12"/>
-          <p:cNvSpPr/>
-          <p:nvPr/>
-        </p:nvSpPr>
-        <p:spPr>
-          <a:xfrm>
-            <a:off x="1371600" y="4709160"/>
-            <a:ext cx="4251960" cy="457200"/>
-          </a:xfrm>
-          <a:prstGeom prst="rect">
-            <a:avLst/>
-          </a:prstGeom>
-          <a:noFill/>
-          <a:ln/>
-        </p:spPr>
-        <p:txBody>
-          <a:bodyPr wrap="square" lIns="0" tIns="0" rIns="0" bIns="0" rtlCol="0" anchor="ctr"/>
-          <a:lstStyle/>
-          <a:p>
-            <a:pPr indent="0" marL="0">
-              <a:buNone/>
-            </a:pPr>
-            <a:r>
-              <a:rPr lang="en-US" sz="1300" dirty="0">
-                <a:solidFill>
-                  <a:srgbClr val="F0F0F0"/>
-                </a:solidFill>
-                <a:latin typeface="Helvetica Neue" pitchFamily="34" charset="0"/>
-                <a:ea typeface="Helvetica Neue" pitchFamily="34" charset="-122"/>
-                <a:cs typeface="Helvetica Neue" pitchFamily="34" charset="-120"/>
-              </a:rPr>
-              <a:t>Décisions d'architecture documentées</a:t>
-            </a:r>
-            <a:endParaRPr lang="en-US" sz="1300" dirty="0"/>
-          </a:p>
-        </p:txBody>
-      </p:sp>
-      <p:sp>
-        <p:nvSpPr>
-          <p:cNvPr id="15" name="Shape 13"/>
-          <p:cNvSpPr/>
-          <p:nvPr/>
-        </p:nvSpPr>
-        <p:spPr>
-          <a:xfrm>
-            <a:off x="6217920" y="2468880"/>
-            <a:ext cx="5120640" cy="3017520"/>
-          </a:xfrm>
-          <a:prstGeom prst="rect">
-            <a:avLst/>
-          </a:prstGeom>
-          <a:solidFill>
-            <a:srgbClr val="F7F7F5"/>
-          </a:solidFill>
-          <a:ln w="12700">
-            <a:solidFill>
-              <a:srgbClr val="D8D8D5"/>
-            </a:solidFill>
-            <a:prstDash val="solid"/>
-          </a:ln>
-        </p:spPr>
-      </p:sp>
-      <p:sp>
-        <p:nvSpPr>
-          <p:cNvPr id="16" name="Text 14"/>
-          <p:cNvSpPr/>
-          <p:nvPr/>
-        </p:nvSpPr>
-        <p:spPr>
-          <a:xfrm>
-            <a:off x="6537960" y="2743200"/>
-            <a:ext cx="4480560" cy="457200"/>
-          </a:xfrm>
-          <a:prstGeom prst="rect">
-            <a:avLst/>
-          </a:prstGeom>
-          <a:noFill/>
-          <a:ln/>
-        </p:spPr>
-        <p:txBody>
-          <a:bodyPr wrap="square" lIns="0" tIns="0" rIns="0" bIns="0" rtlCol="0" anchor="ctr"/>
-          <a:lstStyle/>
-          <a:p>
-            <a:pPr indent="0" marL="0">
-              <a:buNone/>
-            </a:pPr>
-            <a:r>
-              <a:rPr lang="en-US" sz="1800" b="1" dirty="0">
-                <a:solidFill>
-                  <a:srgbClr val="1A1A1A"/>
-                </a:solidFill>
-                <a:latin typeface="Helvetica Neue" pitchFamily="34" charset="0"/>
-                <a:ea typeface="Helvetica Neue" pitchFamily="34" charset="-122"/>
-                <a:cs typeface="Helvetica Neue" pitchFamily="34" charset="-120"/>
-              </a:rPr>
-              <a:t>Mais Bubble m'aurait épargné</a:t>
-            </a:r>
-            <a:endParaRPr lang="en-US" sz="1800" dirty="0"/>
-          </a:p>
-        </p:txBody>
-      </p:sp>
-      <p:sp>
-        <p:nvSpPr>
-          <p:cNvPr id="17" name="Shape 15"/>
-          <p:cNvSpPr/>
-          <p:nvPr/>
-        </p:nvSpPr>
-        <p:spPr>
-          <a:xfrm>
-            <a:off x="6537960" y="3456432"/>
+            <a:off x="960120" y="3950208"/>
             <a:ext cx="109728" cy="109728"/>
           </a:xfrm>
           <a:prstGeom prst="ellipse">
@@ -4540,30 +3764,30 @@
       </p:sp>
       <p:sp>
         <p:nvSpPr>
-          <p:cNvPr id="18" name="Text 16"/>
-          <p:cNvSpPr/>
-          <p:nvPr/>
-        </p:nvSpPr>
-        <p:spPr>
-          <a:xfrm>
-            <a:off x="6766560" y="3337560"/>
-            <a:ext cx="4251960" cy="457200"/>
-          </a:xfrm>
-          <a:prstGeom prst="rect">
-            <a:avLst/>
-          </a:prstGeom>
-          <a:noFill/>
-          <a:ln/>
-        </p:spPr>
-        <p:txBody>
-          <a:bodyPr wrap="square" lIns="0" tIns="0" rIns="0" bIns="0" rtlCol="0" anchor="ctr"/>
-          <a:lstStyle/>
-          <a:p>
-            <a:pPr indent="0" marL="0">
-              <a:buNone/>
-            </a:pPr>
-            <a:r>
-              <a:rPr lang="en-US" sz="1300" dirty="0">
+          <p:cNvPr id="10" name="Text 8"/>
+          <p:cNvSpPr/>
+          <p:nvPr/>
+        </p:nvSpPr>
+        <p:spPr>
+          <a:xfrm>
+            <a:off x="1188720" y="3840480"/>
+            <a:ext cx="2697480" cy="457200"/>
+          </a:xfrm>
+          <a:prstGeom prst="rect">
+            <a:avLst/>
+          </a:prstGeom>
+          <a:noFill/>
+          <a:ln/>
+        </p:spPr>
+        <p:txBody>
+          <a:bodyPr wrap="square" lIns="0" tIns="0" rIns="0" bIns="0" rtlCol="0" anchor="ctr"/>
+          <a:lstStyle/>
+          <a:p>
+            <a:pPr indent="0" marL="0">
+              <a:buNone/>
+            </a:pPr>
+            <a:r>
+              <a:rPr lang="en-US" sz="1200" dirty="0">
                 <a:solidFill>
                   <a:srgbClr val="404040"/>
                 </a:solidFill>
@@ -4571,21 +3795,21 @@
                 <a:ea typeface="Helvetica Neue" pitchFamily="34" charset="-122"/>
                 <a:cs typeface="Helvetica Neue" pitchFamily="34" charset="-120"/>
               </a:rPr>
-              <a:t>L'authentification à la main</a:t>
-            </a:r>
-            <a:endParaRPr lang="en-US" sz="1300" dirty="0"/>
-          </a:p>
-        </p:txBody>
-      </p:sp>
-      <p:sp>
-        <p:nvSpPr>
-          <p:cNvPr id="19" name="Shape 17"/>
-          <p:cNvSpPr/>
-          <p:nvPr/>
-        </p:nvSpPr>
-        <p:spPr>
-          <a:xfrm>
-            <a:off x="6537960" y="3913632"/>
+              <a:t>Soumet une idée : “mode sombre”</a:t>
+            </a:r>
+            <a:endParaRPr lang="en-US" sz="1200" dirty="0"/>
+          </a:p>
+        </p:txBody>
+      </p:sp>
+      <p:sp>
+        <p:nvSpPr>
+          <p:cNvPr id="11" name="Shape 9"/>
+          <p:cNvSpPr/>
+          <p:nvPr/>
+        </p:nvSpPr>
+        <p:spPr>
+          <a:xfrm>
+            <a:off x="960120" y="4453128"/>
             <a:ext cx="109728" cy="109728"/>
           </a:xfrm>
           <a:prstGeom prst="ellipse">
@@ -4604,30 +3828,30 @@
       </p:sp>
       <p:sp>
         <p:nvSpPr>
-          <p:cNvPr id="20" name="Text 18"/>
-          <p:cNvSpPr/>
-          <p:nvPr/>
-        </p:nvSpPr>
-        <p:spPr>
-          <a:xfrm>
-            <a:off x="6766560" y="3794760"/>
-            <a:ext cx="4251960" cy="457200"/>
-          </a:xfrm>
-          <a:prstGeom prst="rect">
-            <a:avLst/>
-          </a:prstGeom>
-          <a:noFill/>
-          <a:ln/>
-        </p:spPr>
-        <p:txBody>
-          <a:bodyPr wrap="square" lIns="0" tIns="0" rIns="0" bIns="0" rtlCol="0" anchor="ctr"/>
-          <a:lstStyle/>
-          <a:p>
-            <a:pPr indent="0" marL="0">
-              <a:buNone/>
-            </a:pPr>
-            <a:r>
-              <a:rPr lang="en-US" sz="1300" dirty="0">
+          <p:cNvPr id="12" name="Text 10"/>
+          <p:cNvSpPr/>
+          <p:nvPr/>
+        </p:nvSpPr>
+        <p:spPr>
+          <a:xfrm>
+            <a:off x="1188720" y="4343400"/>
+            <a:ext cx="2697480" cy="457200"/>
+          </a:xfrm>
+          <a:prstGeom prst="rect">
+            <a:avLst/>
+          </a:prstGeom>
+          <a:noFill/>
+          <a:ln/>
+        </p:spPr>
+        <p:txBody>
+          <a:bodyPr wrap="square" lIns="0" tIns="0" rIns="0" bIns="0" rtlCol="0" anchor="ctr"/>
+          <a:lstStyle/>
+          <a:p>
+            <a:pPr indent="0" marL="0">
+              <a:buNone/>
+            </a:pPr>
+            <a:r>
+              <a:rPr lang="en-US" sz="1200" dirty="0">
                 <a:solidFill>
                   <a:srgbClr val="404040"/>
                 </a:solidFill>
@@ -4635,21 +3859,21 @@
                 <a:ea typeface="Helvetica Neue" pitchFamily="34" charset="-122"/>
                 <a:cs typeface="Helvetica Neue" pitchFamily="34" charset="-120"/>
               </a:rPr>
-              <a:t>La configuration du CI/CD</a:t>
-            </a:r>
-            <a:endParaRPr lang="en-US" sz="1300" dirty="0"/>
-          </a:p>
-        </p:txBody>
-      </p:sp>
-      <p:sp>
-        <p:nvSpPr>
-          <p:cNvPr id="21" name="Shape 19"/>
-          <p:cNvSpPr/>
-          <p:nvPr/>
-        </p:nvSpPr>
-        <p:spPr>
-          <a:xfrm>
-            <a:off x="6537960" y="4370832"/>
+              <a:t>Vote sur un autre feedback</a:t>
+            </a:r>
+            <a:endParaRPr lang="en-US" sz="1200" dirty="0"/>
+          </a:p>
+        </p:txBody>
+      </p:sp>
+      <p:sp>
+        <p:nvSpPr>
+          <p:cNvPr id="13" name="Shape 11"/>
+          <p:cNvSpPr/>
+          <p:nvPr/>
+        </p:nvSpPr>
+        <p:spPr>
+          <a:xfrm>
+            <a:off x="960120" y="4956048"/>
             <a:ext cx="109728" cy="109728"/>
           </a:xfrm>
           <a:prstGeom prst="ellipse">
@@ -4668,30 +3892,30 @@
       </p:sp>
       <p:sp>
         <p:nvSpPr>
-          <p:cNvPr id="22" name="Text 20"/>
-          <p:cNvSpPr/>
-          <p:nvPr/>
-        </p:nvSpPr>
-        <p:spPr>
-          <a:xfrm>
-            <a:off x="6766560" y="4251960"/>
-            <a:ext cx="4251960" cy="457200"/>
-          </a:xfrm>
-          <a:prstGeom prst="rect">
-            <a:avLst/>
-          </a:prstGeom>
-          <a:noFill/>
-          <a:ln/>
-        </p:spPr>
-        <p:txBody>
-          <a:bodyPr wrap="square" lIns="0" tIns="0" rIns="0" bIns="0" rtlCol="0" anchor="ctr"/>
-          <a:lstStyle/>
-          <a:p>
-            <a:pPr indent="0" marL="0">
-              <a:buNone/>
-            </a:pPr>
-            <a:r>
-              <a:rPr lang="en-US" sz="1300" dirty="0">
+          <p:cNvPr id="14" name="Text 12"/>
+          <p:cNvSpPr/>
+          <p:nvPr/>
+        </p:nvSpPr>
+        <p:spPr>
+          <a:xfrm>
+            <a:off x="1188720" y="4846320"/>
+            <a:ext cx="2697480" cy="457200"/>
+          </a:xfrm>
+          <a:prstGeom prst="rect">
+            <a:avLst/>
+          </a:prstGeom>
+          <a:noFill/>
+          <a:ln/>
+        </p:spPr>
+        <p:txBody>
+          <a:bodyPr wrap="square" lIns="0" tIns="0" rIns="0" bIns="0" rtlCol="0" anchor="ctr"/>
+          <a:lstStyle/>
+          <a:p>
+            <a:pPr indent="0" marL="0">
+              <a:buNone/>
+            </a:pPr>
+            <a:r>
+              <a:rPr lang="en-US" sz="1200" dirty="0">
                 <a:solidFill>
                   <a:srgbClr val="404040"/>
                 </a:solidFill>
@@ -4699,24 +3923,49 @@
                 <a:ea typeface="Helvetica Neue" pitchFamily="34" charset="-122"/>
                 <a:cs typeface="Helvetica Neue" pitchFamily="34" charset="-120"/>
               </a:rPr>
-              <a:t>Le debug à l'aveugle quand ça plante</a:t>
-            </a:r>
-            <a:endParaRPr lang="en-US" sz="1300" dirty="0"/>
-          </a:p>
-        </p:txBody>
-      </p:sp>
-      <p:sp>
-        <p:nvSpPr>
-          <p:cNvPr id="23" name="Shape 21"/>
-          <p:cNvSpPr/>
-          <p:nvPr/>
-        </p:nvSpPr>
-        <p:spPr>
-          <a:xfrm>
-            <a:off x="6537960" y="4828032"/>
-            <a:ext cx="109728" cy="109728"/>
-          </a:xfrm>
-          <a:prstGeom prst="ellipse">
+              <a:t>Reçoit la notification de livraison</a:t>
+            </a:r>
+            <a:endParaRPr lang="en-US" sz="1200" dirty="0"/>
+          </a:p>
+        </p:txBody>
+      </p:sp>
+      <p:sp>
+        <p:nvSpPr>
+          <p:cNvPr id="15" name="Shape 13"/>
+          <p:cNvSpPr/>
+          <p:nvPr/>
+        </p:nvSpPr>
+        <p:spPr>
+          <a:xfrm>
+            <a:off x="4389120" y="2743200"/>
+            <a:ext cx="3383280" cy="2926080"/>
+          </a:xfrm>
+          <a:prstGeom prst="rect">
+            <a:avLst/>
+          </a:prstGeom>
+          <a:solidFill>
+            <a:srgbClr val="FFFFFF"/>
+          </a:solidFill>
+          <a:ln w="12700">
+            <a:solidFill>
+              <a:srgbClr val="D8D8D5"/>
+            </a:solidFill>
+            <a:prstDash val="solid"/>
+          </a:ln>
+        </p:spPr>
+      </p:sp>
+      <p:sp>
+        <p:nvSpPr>
+          <p:cNvPr id="16" name="Shape 14"/>
+          <p:cNvSpPr/>
+          <p:nvPr/>
+        </p:nvSpPr>
+        <p:spPr>
+          <a:xfrm>
+            <a:off x="4389120" y="2743200"/>
+            <a:ext cx="3383280" cy="54864"/>
+          </a:xfrm>
+          <a:prstGeom prst="rect">
             <a:avLst/>
           </a:prstGeom>
           <a:solidFill>
@@ -4732,30 +3981,261 @@
       </p:sp>
       <p:sp>
         <p:nvSpPr>
+          <p:cNvPr id="17" name="Text 15"/>
+          <p:cNvSpPr/>
+          <p:nvPr/>
+        </p:nvSpPr>
+        <p:spPr>
+          <a:xfrm>
+            <a:off x="4617720" y="2944368"/>
+            <a:ext cx="2926080" cy="457200"/>
+          </a:xfrm>
+          <a:prstGeom prst="rect">
+            <a:avLst/>
+          </a:prstGeom>
+          <a:noFill/>
+          <a:ln/>
+        </p:spPr>
+        <p:txBody>
+          <a:bodyPr wrap="square" lIns="0" tIns="0" rIns="0" bIns="0" rtlCol="0" anchor="ctr"/>
+          <a:lstStyle/>
+          <a:p>
+            <a:pPr indent="0" marL="0">
+              <a:buNone/>
+            </a:pPr>
+            <a:r>
+              <a:rPr lang="en-US" sz="2200" b="1" dirty="0">
+                <a:solidFill>
+                  <a:srgbClr val="1A1A1A"/>
+                </a:solidFill>
+                <a:latin typeface="Helvetica Neue" pitchFamily="34" charset="0"/>
+                <a:ea typeface="Helvetica Neue" pitchFamily="34" charset="-122"/>
+                <a:cs typeface="Helvetica Neue" pitchFamily="34" charset="-120"/>
+              </a:rPr>
+              <a:t>Alice</a:t>
+            </a:r>
+            <a:endParaRPr lang="en-US" sz="2200" dirty="0"/>
+          </a:p>
+        </p:txBody>
+      </p:sp>
+      <p:sp>
+        <p:nvSpPr>
+          <p:cNvPr id="18" name="Text 16"/>
+          <p:cNvSpPr/>
+          <p:nvPr/>
+        </p:nvSpPr>
+        <p:spPr>
+          <a:xfrm>
+            <a:off x="4617720" y="3383280"/>
+            <a:ext cx="2926080" cy="320040"/>
+          </a:xfrm>
+          <a:prstGeom prst="rect">
+            <a:avLst/>
+          </a:prstGeom>
+          <a:noFill/>
+          <a:ln/>
+        </p:spPr>
+        <p:txBody>
+          <a:bodyPr wrap="square" lIns="0" tIns="0" rIns="0" bIns="0" rtlCol="0" anchor="ctr"/>
+          <a:lstStyle/>
+          <a:p>
+            <a:pPr indent="0" marL="0">
+              <a:buNone/>
+            </a:pPr>
+            <a:r>
+              <a:rPr lang="en-US" sz="1100" b="1" spc="300" kern="0" dirty="0">
+                <a:solidFill>
+                  <a:srgbClr val="8A8A8A"/>
+                </a:solidFill>
+                <a:latin typeface="Helvetica Neue" pitchFamily="34" charset="0"/>
+                <a:ea typeface="Helvetica Neue" pitchFamily="34" charset="-122"/>
+                <a:cs typeface="Helvetica Neue" pitchFamily="34" charset="-120"/>
+              </a:rPr>
+              <a:t>Admin produit</a:t>
+            </a:r>
+            <a:endParaRPr lang="en-US" sz="1100" dirty="0"/>
+          </a:p>
+        </p:txBody>
+      </p:sp>
+      <p:sp>
+        <p:nvSpPr>
+          <p:cNvPr id="19" name="Shape 17"/>
+          <p:cNvSpPr/>
+          <p:nvPr/>
+        </p:nvSpPr>
+        <p:spPr>
+          <a:xfrm>
+            <a:off x="4617720" y="3950208"/>
+            <a:ext cx="109728" cy="109728"/>
+          </a:xfrm>
+          <a:prstGeom prst="ellipse">
+            <a:avLst/>
+          </a:prstGeom>
+          <a:solidFill>
+            <a:srgbClr val="1A1A1A"/>
+          </a:solidFill>
+          <a:ln w="12700">
+            <a:solidFill>
+              <a:srgbClr val="1A1A1A"/>
+            </a:solidFill>
+            <a:prstDash val="solid"/>
+          </a:ln>
+        </p:spPr>
+      </p:sp>
+      <p:sp>
+        <p:nvSpPr>
+          <p:cNvPr id="20" name="Text 18"/>
+          <p:cNvSpPr/>
+          <p:nvPr/>
+        </p:nvSpPr>
+        <p:spPr>
+          <a:xfrm>
+            <a:off x="4846320" y="3840480"/>
+            <a:ext cx="2697480" cy="457200"/>
+          </a:xfrm>
+          <a:prstGeom prst="rect">
+            <a:avLst/>
+          </a:prstGeom>
+          <a:noFill/>
+          <a:ln/>
+        </p:spPr>
+        <p:txBody>
+          <a:bodyPr wrap="square" lIns="0" tIns="0" rIns="0" bIns="0" rtlCol="0" anchor="ctr"/>
+          <a:lstStyle/>
+          <a:p>
+            <a:pPr indent="0" marL="0">
+              <a:buNone/>
+            </a:pPr>
+            <a:r>
+              <a:rPr lang="en-US" sz="1200" dirty="0">
+                <a:solidFill>
+                  <a:srgbClr val="404040"/>
+                </a:solidFill>
+                <a:latin typeface="Helvetica Neue" pitchFamily="34" charset="0"/>
+                <a:ea typeface="Helvetica Neue" pitchFamily="34" charset="-122"/>
+                <a:cs typeface="Helvetica Neue" pitchFamily="34" charset="-120"/>
+              </a:rPr>
+              <a:t>Voit le tableau de bord (KPIs, charts)</a:t>
+            </a:r>
+            <a:endParaRPr lang="en-US" sz="1200" dirty="0"/>
+          </a:p>
+        </p:txBody>
+      </p:sp>
+      <p:sp>
+        <p:nvSpPr>
+          <p:cNvPr id="21" name="Shape 19"/>
+          <p:cNvSpPr/>
+          <p:nvPr/>
+        </p:nvSpPr>
+        <p:spPr>
+          <a:xfrm>
+            <a:off x="4617720" y="4453128"/>
+            <a:ext cx="109728" cy="109728"/>
+          </a:xfrm>
+          <a:prstGeom prst="ellipse">
+            <a:avLst/>
+          </a:prstGeom>
+          <a:solidFill>
+            <a:srgbClr val="1A1A1A"/>
+          </a:solidFill>
+          <a:ln w="12700">
+            <a:solidFill>
+              <a:srgbClr val="1A1A1A"/>
+            </a:solidFill>
+            <a:prstDash val="solid"/>
+          </a:ln>
+        </p:spPr>
+      </p:sp>
+      <p:sp>
+        <p:nvSpPr>
+          <p:cNvPr id="22" name="Text 20"/>
+          <p:cNvSpPr/>
+          <p:nvPr/>
+        </p:nvSpPr>
+        <p:spPr>
+          <a:xfrm>
+            <a:off x="4846320" y="4343400"/>
+            <a:ext cx="2697480" cy="457200"/>
+          </a:xfrm>
+          <a:prstGeom prst="rect">
+            <a:avLst/>
+          </a:prstGeom>
+          <a:noFill/>
+          <a:ln/>
+        </p:spPr>
+        <p:txBody>
+          <a:bodyPr wrap="square" lIns="0" tIns="0" rIns="0" bIns="0" rtlCol="0" anchor="ctr"/>
+          <a:lstStyle/>
+          <a:p>
+            <a:pPr indent="0" marL="0">
+              <a:buNone/>
+            </a:pPr>
+            <a:r>
+              <a:rPr lang="en-US" sz="1200" dirty="0">
+                <a:solidFill>
+                  <a:srgbClr val="404040"/>
+                </a:solidFill>
+                <a:latin typeface="Helvetica Neue" pitchFamily="34" charset="0"/>
+                <a:ea typeface="Helvetica Neue" pitchFamily="34" charset="-122"/>
+                <a:cs typeface="Helvetica Neue" pitchFamily="34" charset="-120"/>
+              </a:rPr>
+              <a:t>Identifie le top des votes</a:t>
+            </a:r>
+            <a:endParaRPr lang="en-US" sz="1200" dirty="0"/>
+          </a:p>
+        </p:txBody>
+      </p:sp>
+      <p:sp>
+        <p:nvSpPr>
+          <p:cNvPr id="23" name="Shape 21"/>
+          <p:cNvSpPr/>
+          <p:nvPr/>
+        </p:nvSpPr>
+        <p:spPr>
+          <a:xfrm>
+            <a:off x="4617720" y="4956048"/>
+            <a:ext cx="109728" cy="109728"/>
+          </a:xfrm>
+          <a:prstGeom prst="ellipse">
+            <a:avLst/>
+          </a:prstGeom>
+          <a:solidFill>
+            <a:srgbClr val="1A1A1A"/>
+          </a:solidFill>
+          <a:ln w="12700">
+            <a:solidFill>
+              <a:srgbClr val="1A1A1A"/>
+            </a:solidFill>
+            <a:prstDash val="solid"/>
+          </a:ln>
+        </p:spPr>
+      </p:sp>
+      <p:sp>
+        <p:nvSpPr>
           <p:cNvPr id="24" name="Text 22"/>
           <p:cNvSpPr/>
           <p:nvPr/>
         </p:nvSpPr>
         <p:spPr>
           <a:xfrm>
-            <a:off x="6766560" y="4709160"/>
-            <a:ext cx="4251960" cy="457200"/>
-          </a:xfrm>
-          <a:prstGeom prst="rect">
-            <a:avLst/>
-          </a:prstGeom>
-          <a:noFill/>
-          <a:ln/>
-        </p:spPr>
-        <p:txBody>
-          <a:bodyPr wrap="square" lIns="0" tIns="0" rIns="0" bIns="0" rtlCol="0" anchor="ctr"/>
-          <a:lstStyle/>
-          <a:p>
-            <a:pPr indent="0" marL="0">
-              <a:buNone/>
-            </a:pPr>
-            <a:r>
-              <a:rPr lang="en-US" sz="1300" dirty="0">
+            <a:off x="4846320" y="4846320"/>
+            <a:ext cx="2697480" cy="457200"/>
+          </a:xfrm>
+          <a:prstGeom prst="rect">
+            <a:avLst/>
+          </a:prstGeom>
+          <a:noFill/>
+          <a:ln/>
+        </p:spPr>
+        <p:txBody>
+          <a:bodyPr wrap="square" lIns="0" tIns="0" rIns="0" bIns="0" rtlCol="0" anchor="ctr"/>
+          <a:lstStyle/>
+          <a:p>
+            <a:pPr indent="0" marL="0">
+              <a:buNone/>
+            </a:pPr>
+            <a:r>
+              <a:rPr lang="en-US" sz="1200" dirty="0">
                 <a:solidFill>
                   <a:srgbClr val="404040"/>
                 </a:solidFill>
@@ -4763,15 +4243,335 @@
                 <a:ea typeface="Helvetica Neue" pitchFamily="34" charset="-122"/>
                 <a:cs typeface="Helvetica Neue" pitchFamily="34" charset="-120"/>
               </a:rPr>
-              <a:t>Le maintien d'un schéma de base à jour</a:t>
-            </a:r>
-            <a:endParaRPr lang="en-US" sz="1300" dirty="0"/>
-          </a:p>
-        </p:txBody>
-      </p:sp>
-      <p:sp>
-        <p:nvSpPr>
-          <p:cNvPr id="25" name="Text 23"/>
+              <a:t>Envoie l'idée au backlog dev</a:t>
+            </a:r>
+            <a:endParaRPr lang="en-US" sz="1200" dirty="0"/>
+          </a:p>
+        </p:txBody>
+      </p:sp>
+      <p:sp>
+        <p:nvSpPr>
+          <p:cNvPr id="25" name="Shape 23"/>
+          <p:cNvSpPr/>
+          <p:nvPr/>
+        </p:nvSpPr>
+        <p:spPr>
+          <a:xfrm>
+            <a:off x="8046720" y="2743200"/>
+            <a:ext cx="3383280" cy="2926080"/>
+          </a:xfrm>
+          <a:prstGeom prst="rect">
+            <a:avLst/>
+          </a:prstGeom>
+          <a:solidFill>
+            <a:srgbClr val="FFFFFF"/>
+          </a:solidFill>
+          <a:ln w="12700">
+            <a:solidFill>
+              <a:srgbClr val="D8D8D5"/>
+            </a:solidFill>
+            <a:prstDash val="solid"/>
+          </a:ln>
+        </p:spPr>
+      </p:sp>
+      <p:sp>
+        <p:nvSpPr>
+          <p:cNvPr id="26" name="Shape 24"/>
+          <p:cNvSpPr/>
+          <p:nvPr/>
+        </p:nvSpPr>
+        <p:spPr>
+          <a:xfrm>
+            <a:off x="8046720" y="2743200"/>
+            <a:ext cx="3383280" cy="54864"/>
+          </a:xfrm>
+          <a:prstGeom prst="rect">
+            <a:avLst/>
+          </a:prstGeom>
+          <a:solidFill>
+            <a:srgbClr val="1A1A1A"/>
+          </a:solidFill>
+          <a:ln w="12700">
+            <a:solidFill>
+              <a:srgbClr val="1A1A1A"/>
+            </a:solidFill>
+            <a:prstDash val="solid"/>
+          </a:ln>
+        </p:spPr>
+      </p:sp>
+      <p:sp>
+        <p:nvSpPr>
+          <p:cNvPr id="27" name="Text 25"/>
+          <p:cNvSpPr/>
+          <p:nvPr/>
+        </p:nvSpPr>
+        <p:spPr>
+          <a:xfrm>
+            <a:off x="8275320" y="2944368"/>
+            <a:ext cx="2926080" cy="457200"/>
+          </a:xfrm>
+          <a:prstGeom prst="rect">
+            <a:avLst/>
+          </a:prstGeom>
+          <a:noFill/>
+          <a:ln/>
+        </p:spPr>
+        <p:txBody>
+          <a:bodyPr wrap="square" lIns="0" tIns="0" rIns="0" bIns="0" rtlCol="0" anchor="ctr"/>
+          <a:lstStyle/>
+          <a:p>
+            <a:pPr indent="0" marL="0">
+              <a:buNone/>
+            </a:pPr>
+            <a:r>
+              <a:rPr lang="en-US" sz="2200" b="1" dirty="0">
+                <a:solidFill>
+                  <a:srgbClr val="1A1A1A"/>
+                </a:solidFill>
+                <a:latin typeface="Helvetica Neue" pitchFamily="34" charset="0"/>
+                <a:ea typeface="Helvetica Neue" pitchFamily="34" charset="-122"/>
+                <a:cs typeface="Helvetica Neue" pitchFamily="34" charset="-120"/>
+              </a:rPr>
+              <a:t>Yasmine</a:t>
+            </a:r>
+            <a:endParaRPr lang="en-US" sz="2200" dirty="0"/>
+          </a:p>
+        </p:txBody>
+      </p:sp>
+      <p:sp>
+        <p:nvSpPr>
+          <p:cNvPr id="28" name="Text 26"/>
+          <p:cNvSpPr/>
+          <p:nvPr/>
+        </p:nvSpPr>
+        <p:spPr>
+          <a:xfrm>
+            <a:off x="8275320" y="3383280"/>
+            <a:ext cx="2926080" cy="320040"/>
+          </a:xfrm>
+          <a:prstGeom prst="rect">
+            <a:avLst/>
+          </a:prstGeom>
+          <a:noFill/>
+          <a:ln/>
+        </p:spPr>
+        <p:txBody>
+          <a:bodyPr wrap="square" lIns="0" tIns="0" rIns="0" bIns="0" rtlCol="0" anchor="ctr"/>
+          <a:lstStyle/>
+          <a:p>
+            <a:pPr indent="0" marL="0">
+              <a:buNone/>
+            </a:pPr>
+            <a:r>
+              <a:rPr lang="en-US" sz="1100" b="1" spc="300" kern="0" dirty="0">
+                <a:solidFill>
+                  <a:srgbClr val="8A8A8A"/>
+                </a:solidFill>
+                <a:latin typeface="Helvetica Neue" pitchFamily="34" charset="0"/>
+                <a:ea typeface="Helvetica Neue" pitchFamily="34" charset="-122"/>
+                <a:cs typeface="Helvetica Neue" pitchFamily="34" charset="-120"/>
+              </a:rPr>
+              <a:t>Développeuse</a:t>
+            </a:r>
+            <a:endParaRPr lang="en-US" sz="1100" dirty="0"/>
+          </a:p>
+        </p:txBody>
+      </p:sp>
+      <p:sp>
+        <p:nvSpPr>
+          <p:cNvPr id="29" name="Shape 27"/>
+          <p:cNvSpPr/>
+          <p:nvPr/>
+        </p:nvSpPr>
+        <p:spPr>
+          <a:xfrm>
+            <a:off x="8275320" y="3950208"/>
+            <a:ext cx="109728" cy="109728"/>
+          </a:xfrm>
+          <a:prstGeom prst="ellipse">
+            <a:avLst/>
+          </a:prstGeom>
+          <a:solidFill>
+            <a:srgbClr val="1A1A1A"/>
+          </a:solidFill>
+          <a:ln w="12700">
+            <a:solidFill>
+              <a:srgbClr val="1A1A1A"/>
+            </a:solidFill>
+            <a:prstDash val="solid"/>
+          </a:ln>
+        </p:spPr>
+      </p:sp>
+      <p:sp>
+        <p:nvSpPr>
+          <p:cNvPr id="30" name="Text 28"/>
+          <p:cNvSpPr/>
+          <p:nvPr/>
+        </p:nvSpPr>
+        <p:spPr>
+          <a:xfrm>
+            <a:off x="8503920" y="3840480"/>
+            <a:ext cx="2697480" cy="457200"/>
+          </a:xfrm>
+          <a:prstGeom prst="rect">
+            <a:avLst/>
+          </a:prstGeom>
+          <a:noFill/>
+          <a:ln/>
+        </p:spPr>
+        <p:txBody>
+          <a:bodyPr wrap="square" lIns="0" tIns="0" rIns="0" bIns="0" rtlCol="0" anchor="ctr"/>
+          <a:lstStyle/>
+          <a:p>
+            <a:pPr indent="0" marL="0">
+              <a:buNone/>
+            </a:pPr>
+            <a:r>
+              <a:rPr lang="en-US" sz="1200" dirty="0">
+                <a:solidFill>
+                  <a:srgbClr val="404040"/>
+                </a:solidFill>
+                <a:latin typeface="Helvetica Neue" pitchFamily="34" charset="0"/>
+                <a:ea typeface="Helvetica Neue" pitchFamily="34" charset="-122"/>
+                <a:cs typeface="Helvetica Neue" pitchFamily="34" charset="-120"/>
+              </a:rPr>
+              <a:t>Prend le ticket dans le kanban</a:t>
+            </a:r>
+            <a:endParaRPr lang="en-US" sz="1200" dirty="0"/>
+          </a:p>
+        </p:txBody>
+      </p:sp>
+      <p:sp>
+        <p:nvSpPr>
+          <p:cNvPr id="31" name="Shape 29"/>
+          <p:cNvSpPr/>
+          <p:nvPr/>
+        </p:nvSpPr>
+        <p:spPr>
+          <a:xfrm>
+            <a:off x="8275320" y="4453128"/>
+            <a:ext cx="109728" cy="109728"/>
+          </a:xfrm>
+          <a:prstGeom prst="ellipse">
+            <a:avLst/>
+          </a:prstGeom>
+          <a:solidFill>
+            <a:srgbClr val="1A1A1A"/>
+          </a:solidFill>
+          <a:ln w="12700">
+            <a:solidFill>
+              <a:srgbClr val="1A1A1A"/>
+            </a:solidFill>
+            <a:prstDash val="solid"/>
+          </a:ln>
+        </p:spPr>
+      </p:sp>
+      <p:sp>
+        <p:nvSpPr>
+          <p:cNvPr id="32" name="Text 30"/>
+          <p:cNvSpPr/>
+          <p:nvPr/>
+        </p:nvSpPr>
+        <p:spPr>
+          <a:xfrm>
+            <a:off x="8503920" y="4343400"/>
+            <a:ext cx="2697480" cy="457200"/>
+          </a:xfrm>
+          <a:prstGeom prst="rect">
+            <a:avLst/>
+          </a:prstGeom>
+          <a:noFill/>
+          <a:ln/>
+        </p:spPr>
+        <p:txBody>
+          <a:bodyPr wrap="square" lIns="0" tIns="0" rIns="0" bIns="0" rtlCol="0" anchor="ctr"/>
+          <a:lstStyle/>
+          <a:p>
+            <a:pPr indent="0" marL="0">
+              <a:buNone/>
+            </a:pPr>
+            <a:r>
+              <a:rPr lang="en-US" sz="1200" dirty="0">
+                <a:solidFill>
+                  <a:srgbClr val="404040"/>
+                </a:solidFill>
+                <a:latin typeface="Helvetica Neue" pitchFamily="34" charset="0"/>
+                <a:ea typeface="Helvetica Neue" pitchFamily="34" charset="-122"/>
+                <a:cs typeface="Helvetica Neue" pitchFamily="34" charset="-120"/>
+              </a:rPr>
+              <a:t>Le déplace : à faire → en cours → review → livré</a:t>
+            </a:r>
+            <a:endParaRPr lang="en-US" sz="1200" dirty="0"/>
+          </a:p>
+        </p:txBody>
+      </p:sp>
+      <p:sp>
+        <p:nvSpPr>
+          <p:cNvPr id="33" name="Shape 31"/>
+          <p:cNvSpPr/>
+          <p:nvPr/>
+        </p:nvSpPr>
+        <p:spPr>
+          <a:xfrm>
+            <a:off x="8275320" y="4956048"/>
+            <a:ext cx="109728" cy="109728"/>
+          </a:xfrm>
+          <a:prstGeom prst="ellipse">
+            <a:avLst/>
+          </a:prstGeom>
+          <a:solidFill>
+            <a:srgbClr val="1A1A1A"/>
+          </a:solidFill>
+          <a:ln w="12700">
+            <a:solidFill>
+              <a:srgbClr val="1A1A1A"/>
+            </a:solidFill>
+            <a:prstDash val="solid"/>
+          </a:ln>
+        </p:spPr>
+      </p:sp>
+      <p:sp>
+        <p:nvSpPr>
+          <p:cNvPr id="34" name="Text 32"/>
+          <p:cNvSpPr/>
+          <p:nvPr/>
+        </p:nvSpPr>
+        <p:spPr>
+          <a:xfrm>
+            <a:off x="8503920" y="4846320"/>
+            <a:ext cx="2697480" cy="457200"/>
+          </a:xfrm>
+          <a:prstGeom prst="rect">
+            <a:avLst/>
+          </a:prstGeom>
+          <a:noFill/>
+          <a:ln/>
+        </p:spPr>
+        <p:txBody>
+          <a:bodyPr wrap="square" lIns="0" tIns="0" rIns="0" bIns="0" rtlCol="0" anchor="ctr"/>
+          <a:lstStyle/>
+          <a:p>
+            <a:pPr indent="0" marL="0">
+              <a:buNone/>
+            </a:pPr>
+            <a:r>
+              <a:rPr lang="en-US" sz="1200" dirty="0">
+                <a:solidFill>
+                  <a:srgbClr val="404040"/>
+                </a:solidFill>
+                <a:latin typeface="Helvetica Neue" pitchFamily="34" charset="0"/>
+                <a:ea typeface="Helvetica Neue" pitchFamily="34" charset="-122"/>
+                <a:cs typeface="Helvetica Neue" pitchFamily="34" charset="-120"/>
+              </a:rPr>
+              <a:t>🎉 Confetti quand c'est livré</a:t>
+            </a:r>
+            <a:endParaRPr lang="en-US" sz="1200" dirty="0"/>
+          </a:p>
+        </p:txBody>
+      </p:sp>
+      <p:sp>
+        <p:nvSpPr>
+          <p:cNvPr id="35" name="Text 33"/>
           <p:cNvSpPr/>
           <p:nvPr/>
         </p:nvSpPr>
@@ -4790,11 +4590,11 @@
           <a:bodyPr wrap="square" lIns="0" tIns="0" rIns="0" bIns="0" rtlCol="0" anchor="ctr"/>
           <a:lstStyle/>
           <a:p>
-            <a:pPr algn="ctr" indent="0" marL="0">
-              <a:buNone/>
-            </a:pPr>
-            <a:r>
-              <a:rPr lang="en-US" sz="1400" b="1" i="1" dirty="0">
+            <a:pPr indent="0" marL="0">
+              <a:buNone/>
+            </a:pPr>
+            <a:r>
+              <a:rPr lang="en-US" sz="1300" b="1" i="1" dirty="0">
                 <a:solidFill>
                   <a:srgbClr val="1A1A1A"/>
                 </a:solidFill>
@@ -4802,15 +4602,15 @@
                 <a:ea typeface="Helvetica Neue" pitchFamily="34" charset="-122"/>
                 <a:cs typeface="Helvetica Neue" pitchFamily="34" charset="-120"/>
               </a:rPr>
-              <a:t>Le bon outil dépend du contexte.</a:t>
-            </a:r>
-            <a:endParaRPr lang="en-US" sz="1400" dirty="0"/>
-          </a:p>
-        </p:txBody>
-      </p:sp>
-      <p:sp>
-        <p:nvSpPr>
-          <p:cNvPr id="26" name="Text 24"/>
+              <a:t>Boucle complète : feedback → vote → priorisation → dev → notification.</a:t>
+            </a:r>
+            <a:endParaRPr lang="en-US" sz="1300" dirty="0"/>
+          </a:p>
+        </p:txBody>
+      </p:sp>
+      <p:sp>
+        <p:nvSpPr>
+          <p:cNvPr id="36" name="Text 34"/>
           <p:cNvSpPr/>
           <p:nvPr/>
         </p:nvSpPr>
@@ -4841,7 +4641,7 @@
                 <a:ea typeface="Helvetica Neue" pitchFamily="34" charset="-122"/>
                 <a:cs typeface="Helvetica Neue" pitchFamily="34" charset="-120"/>
               </a:rPr>
-              <a:t>13 / 14</a:t>
+              <a:t>13 / 15</a:t>
             </a:r>
             <a:endParaRPr lang="en-US" sz="900" dirty="0"/>
           </a:p>
@@ -4887,6 +4687,857 @@
         </p:nvSpPr>
         <p:spPr>
           <a:xfrm>
+            <a:off x="640080" y="411480"/>
+            <a:ext cx="7315200" cy="274320"/>
+          </a:xfrm>
+          <a:prstGeom prst="rect">
+            <a:avLst/>
+          </a:prstGeom>
+          <a:noFill/>
+          <a:ln/>
+        </p:spPr>
+        <p:txBody>
+          <a:bodyPr wrap="square" lIns="0" tIns="0" rIns="0" bIns="0" rtlCol="0" anchor="ctr"/>
+          <a:lstStyle/>
+          <a:p>
+            <a:pPr indent="0" marL="0">
+              <a:buNone/>
+            </a:pPr>
+            <a:r>
+              <a:rPr lang="en-US" sz="900" spc="400" kern="0" dirty="0">
+                <a:solidFill>
+                  <a:srgbClr val="8A8A8A"/>
+                </a:solidFill>
+                <a:latin typeface="Helvetica Neue" pitchFamily="34" charset="0"/>
+                <a:ea typeface="Helvetica Neue" pitchFamily="34" charset="-122"/>
+                <a:cs typeface="Helvetica Neue" pitchFamily="34" charset="-120"/>
+              </a:rPr>
+              <a:t>RETOUR D'EXPÉRIENCE</a:t>
+            </a:r>
+            <a:endParaRPr lang="en-US" sz="900" dirty="0"/>
+          </a:p>
+        </p:txBody>
+      </p:sp>
+      <p:sp>
+        <p:nvSpPr>
+          <p:cNvPr id="3" name="Text 1"/>
+          <p:cNvSpPr/>
+          <p:nvPr/>
+        </p:nvSpPr>
+        <p:spPr>
+          <a:xfrm>
+            <a:off x="640080" y="1005840"/>
+            <a:ext cx="10881360" cy="914400"/>
+          </a:xfrm>
+          <a:prstGeom prst="rect">
+            <a:avLst/>
+          </a:prstGeom>
+          <a:noFill/>
+          <a:ln/>
+        </p:spPr>
+        <p:txBody>
+          <a:bodyPr wrap="square" lIns="0" tIns="0" rIns="0" bIns="0" rtlCol="0" anchor="ctr"/>
+          <a:lstStyle/>
+          <a:p>
+            <a:pPr indent="0" marL="0">
+              <a:buNone/>
+            </a:pPr>
+            <a:r>
+              <a:rPr lang="en-US" sz="3600" b="1" dirty="0">
+                <a:solidFill>
+                  <a:srgbClr val="1A1A1A"/>
+                </a:solidFill>
+                <a:latin typeface="Helvetica Neue" pitchFamily="34" charset="0"/>
+                <a:ea typeface="Helvetica Neue" pitchFamily="34" charset="-122"/>
+                <a:cs typeface="Helvetica Neue" pitchFamily="34" charset="-120"/>
+              </a:rPr>
+              <a:t>Coder en direct vs Bubble — ce que j'ai appris</a:t>
+            </a:r>
+            <a:endParaRPr lang="en-US" sz="3600" dirty="0"/>
+          </a:p>
+        </p:txBody>
+      </p:sp>
+      <p:sp>
+        <p:nvSpPr>
+          <p:cNvPr id="4" name="Shape 2"/>
+          <p:cNvSpPr/>
+          <p:nvPr/>
+        </p:nvSpPr>
+        <p:spPr>
+          <a:xfrm>
+            <a:off x="640080" y="1874520"/>
+            <a:ext cx="548640" cy="0"/>
+          </a:xfrm>
+          <a:prstGeom prst="line">
+            <a:avLst/>
+          </a:prstGeom>
+          <a:noFill/>
+          <a:ln w="19050">
+            <a:solidFill>
+              <a:srgbClr val="1A1A1A"/>
+            </a:solidFill>
+            <a:prstDash val="solid"/>
+          </a:ln>
+        </p:spPr>
+      </p:sp>
+      <p:sp>
+        <p:nvSpPr>
+          <p:cNvPr id="5" name="Shape 3"/>
+          <p:cNvSpPr/>
+          <p:nvPr/>
+        </p:nvSpPr>
+        <p:spPr>
+          <a:xfrm>
+            <a:off x="822960" y="2468880"/>
+            <a:ext cx="5120640" cy="3017520"/>
+          </a:xfrm>
+          <a:prstGeom prst="rect">
+            <a:avLst/>
+          </a:prstGeom>
+          <a:solidFill>
+            <a:srgbClr val="1A1A1A"/>
+          </a:solidFill>
+          <a:ln w="12700">
+            <a:solidFill>
+              <a:srgbClr val="1A1A1A"/>
+            </a:solidFill>
+            <a:prstDash val="solid"/>
+          </a:ln>
+        </p:spPr>
+      </p:sp>
+      <p:sp>
+        <p:nvSpPr>
+          <p:cNvPr id="6" name="Text 4"/>
+          <p:cNvSpPr/>
+          <p:nvPr/>
+        </p:nvSpPr>
+        <p:spPr>
+          <a:xfrm>
+            <a:off x="1143000" y="2743200"/>
+            <a:ext cx="4480560" cy="457200"/>
+          </a:xfrm>
+          <a:prstGeom prst="rect">
+            <a:avLst/>
+          </a:prstGeom>
+          <a:noFill/>
+          <a:ln/>
+        </p:spPr>
+        <p:txBody>
+          <a:bodyPr wrap="square" lIns="0" tIns="0" rIns="0" bIns="0" rtlCol="0" anchor="ctr"/>
+          <a:lstStyle/>
+          <a:p>
+            <a:pPr indent="0" marL="0">
+              <a:buNone/>
+            </a:pPr>
+            <a:r>
+              <a:rPr lang="en-US" sz="1800" b="1" dirty="0">
+                <a:solidFill>
+                  <a:srgbClr val="FFFFFF"/>
+                </a:solidFill>
+                <a:latin typeface="Helvetica Neue" pitchFamily="34" charset="0"/>
+                <a:ea typeface="Helvetica Neue" pitchFamily="34" charset="-122"/>
+                <a:cs typeface="Helvetica Neue" pitchFamily="34" charset="-120"/>
+              </a:rPr>
+              <a:t>Avec le code direct</a:t>
+            </a:r>
+            <a:endParaRPr lang="en-US" sz="1800" dirty="0"/>
+          </a:p>
+        </p:txBody>
+      </p:sp>
+      <p:sp>
+        <p:nvSpPr>
+          <p:cNvPr id="7" name="Shape 5"/>
+          <p:cNvSpPr/>
+          <p:nvPr/>
+        </p:nvSpPr>
+        <p:spPr>
+          <a:xfrm>
+            <a:off x="1143000" y="3456432"/>
+            <a:ext cx="109728" cy="109728"/>
+          </a:xfrm>
+          <a:prstGeom prst="ellipse">
+            <a:avLst/>
+          </a:prstGeom>
+          <a:solidFill>
+            <a:srgbClr val="FFFFFF"/>
+          </a:solidFill>
+          <a:ln w="12700">
+            <a:solidFill>
+              <a:srgbClr val="FFFFFF"/>
+            </a:solidFill>
+            <a:prstDash val="solid"/>
+          </a:ln>
+        </p:spPr>
+      </p:sp>
+      <p:sp>
+        <p:nvSpPr>
+          <p:cNvPr id="8" name="Text 6"/>
+          <p:cNvSpPr/>
+          <p:nvPr/>
+        </p:nvSpPr>
+        <p:spPr>
+          <a:xfrm>
+            <a:off x="1371600" y="3337560"/>
+            <a:ext cx="4251960" cy="457200"/>
+          </a:xfrm>
+          <a:prstGeom prst="rect">
+            <a:avLst/>
+          </a:prstGeom>
+          <a:noFill/>
+          <a:ln/>
+        </p:spPr>
+        <p:txBody>
+          <a:bodyPr wrap="square" lIns="0" tIns="0" rIns="0" bIns="0" rtlCol="0" anchor="ctr"/>
+          <a:lstStyle/>
+          <a:p>
+            <a:pPr indent="0" marL="0">
+              <a:buNone/>
+            </a:pPr>
+            <a:r>
+              <a:rPr lang="en-US" sz="1300" dirty="0">
+                <a:solidFill>
+                  <a:srgbClr val="F0F0F0"/>
+                </a:solidFill>
+                <a:latin typeface="Helvetica Neue" pitchFamily="34" charset="0"/>
+                <a:ea typeface="Helvetica Neue" pitchFamily="34" charset="-122"/>
+                <a:cs typeface="Helvetica Neue" pitchFamily="34" charset="-120"/>
+              </a:rPr>
+              <a:t>Vrai git workflow : commits, PRs, CI</a:t>
+            </a:r>
+            <a:endParaRPr lang="en-US" sz="1300" dirty="0"/>
+          </a:p>
+        </p:txBody>
+      </p:sp>
+      <p:sp>
+        <p:nvSpPr>
+          <p:cNvPr id="9" name="Shape 7"/>
+          <p:cNvSpPr/>
+          <p:nvPr/>
+        </p:nvSpPr>
+        <p:spPr>
+          <a:xfrm>
+            <a:off x="1143000" y="3913632"/>
+            <a:ext cx="109728" cy="109728"/>
+          </a:xfrm>
+          <a:prstGeom prst="ellipse">
+            <a:avLst/>
+          </a:prstGeom>
+          <a:solidFill>
+            <a:srgbClr val="FFFFFF"/>
+          </a:solidFill>
+          <a:ln w="12700">
+            <a:solidFill>
+              <a:srgbClr val="FFFFFF"/>
+            </a:solidFill>
+            <a:prstDash val="solid"/>
+          </a:ln>
+        </p:spPr>
+      </p:sp>
+      <p:sp>
+        <p:nvSpPr>
+          <p:cNvPr id="10" name="Text 8"/>
+          <p:cNvSpPr/>
+          <p:nvPr/>
+        </p:nvSpPr>
+        <p:spPr>
+          <a:xfrm>
+            <a:off x="1371600" y="3794760"/>
+            <a:ext cx="4251960" cy="457200"/>
+          </a:xfrm>
+          <a:prstGeom prst="rect">
+            <a:avLst/>
+          </a:prstGeom>
+          <a:noFill/>
+          <a:ln/>
+        </p:spPr>
+        <p:txBody>
+          <a:bodyPr wrap="square" lIns="0" tIns="0" rIns="0" bIns="0" rtlCol="0" anchor="ctr"/>
+          <a:lstStyle/>
+          <a:p>
+            <a:pPr indent="0" marL="0">
+              <a:buNone/>
+            </a:pPr>
+            <a:r>
+              <a:rPr lang="en-US" sz="1300" dirty="0">
+                <a:solidFill>
+                  <a:srgbClr val="F0F0F0"/>
+                </a:solidFill>
+                <a:latin typeface="Helvetica Neue" pitchFamily="34" charset="0"/>
+                <a:ea typeface="Helvetica Neue" pitchFamily="34" charset="-122"/>
+                <a:cs typeface="Helvetica Neue" pitchFamily="34" charset="-120"/>
+              </a:rPr>
+              <a:t>Sécurité serveur : cookies, JWT, rate limit</a:t>
+            </a:r>
+            <a:endParaRPr lang="en-US" sz="1300" dirty="0"/>
+          </a:p>
+        </p:txBody>
+      </p:sp>
+      <p:sp>
+        <p:nvSpPr>
+          <p:cNvPr id="11" name="Shape 9"/>
+          <p:cNvSpPr/>
+          <p:nvPr/>
+        </p:nvSpPr>
+        <p:spPr>
+          <a:xfrm>
+            <a:off x="1143000" y="4370832"/>
+            <a:ext cx="109728" cy="109728"/>
+          </a:xfrm>
+          <a:prstGeom prst="ellipse">
+            <a:avLst/>
+          </a:prstGeom>
+          <a:solidFill>
+            <a:srgbClr val="FFFFFF"/>
+          </a:solidFill>
+          <a:ln w="12700">
+            <a:solidFill>
+              <a:srgbClr val="FFFFFF"/>
+            </a:solidFill>
+            <a:prstDash val="solid"/>
+          </a:ln>
+        </p:spPr>
+      </p:sp>
+      <p:sp>
+        <p:nvSpPr>
+          <p:cNvPr id="12" name="Text 10"/>
+          <p:cNvSpPr/>
+          <p:nvPr/>
+        </p:nvSpPr>
+        <p:spPr>
+          <a:xfrm>
+            <a:off x="1371600" y="4251960"/>
+            <a:ext cx="4251960" cy="457200"/>
+          </a:xfrm>
+          <a:prstGeom prst="rect">
+            <a:avLst/>
+          </a:prstGeom>
+          <a:noFill/>
+          <a:ln/>
+        </p:spPr>
+        <p:txBody>
+          <a:bodyPr wrap="square" lIns="0" tIns="0" rIns="0" bIns="0" rtlCol="0" anchor="ctr"/>
+          <a:lstStyle/>
+          <a:p>
+            <a:pPr indent="0" marL="0">
+              <a:buNone/>
+            </a:pPr>
+            <a:r>
+              <a:rPr lang="en-US" sz="1300" dirty="0">
+                <a:solidFill>
+                  <a:srgbClr val="F0F0F0"/>
+                </a:solidFill>
+                <a:latin typeface="Helvetica Neue" pitchFamily="34" charset="0"/>
+                <a:ea typeface="Helvetica Neue" pitchFamily="34" charset="-122"/>
+                <a:cs typeface="Helvetica Neue" pitchFamily="34" charset="-120"/>
+              </a:rPr>
+              <a:t>Déploiement et monitoring prod</a:t>
+            </a:r>
+            <a:endParaRPr lang="en-US" sz="1300" dirty="0"/>
+          </a:p>
+        </p:txBody>
+      </p:sp>
+      <p:sp>
+        <p:nvSpPr>
+          <p:cNvPr id="13" name="Shape 11"/>
+          <p:cNvSpPr/>
+          <p:nvPr/>
+        </p:nvSpPr>
+        <p:spPr>
+          <a:xfrm>
+            <a:off x="1143000" y="4828032"/>
+            <a:ext cx="109728" cy="109728"/>
+          </a:xfrm>
+          <a:prstGeom prst="ellipse">
+            <a:avLst/>
+          </a:prstGeom>
+          <a:solidFill>
+            <a:srgbClr val="FFFFFF"/>
+          </a:solidFill>
+          <a:ln w="12700">
+            <a:solidFill>
+              <a:srgbClr val="FFFFFF"/>
+            </a:solidFill>
+            <a:prstDash val="solid"/>
+          </a:ln>
+        </p:spPr>
+      </p:sp>
+      <p:sp>
+        <p:nvSpPr>
+          <p:cNvPr id="14" name="Text 12"/>
+          <p:cNvSpPr/>
+          <p:nvPr/>
+        </p:nvSpPr>
+        <p:spPr>
+          <a:xfrm>
+            <a:off x="1371600" y="4709160"/>
+            <a:ext cx="4251960" cy="457200"/>
+          </a:xfrm>
+          <a:prstGeom prst="rect">
+            <a:avLst/>
+          </a:prstGeom>
+          <a:noFill/>
+          <a:ln/>
+        </p:spPr>
+        <p:txBody>
+          <a:bodyPr wrap="square" lIns="0" tIns="0" rIns="0" bIns="0" rtlCol="0" anchor="ctr"/>
+          <a:lstStyle/>
+          <a:p>
+            <a:pPr indent="0" marL="0">
+              <a:buNone/>
+            </a:pPr>
+            <a:r>
+              <a:rPr lang="en-US" sz="1300" dirty="0">
+                <a:solidFill>
+                  <a:srgbClr val="F0F0F0"/>
+                </a:solidFill>
+                <a:latin typeface="Helvetica Neue" pitchFamily="34" charset="0"/>
+                <a:ea typeface="Helvetica Neue" pitchFamily="34" charset="-122"/>
+                <a:cs typeface="Helvetica Neue" pitchFamily="34" charset="-120"/>
+              </a:rPr>
+              <a:t>Décisions d'architecture documentées</a:t>
+            </a:r>
+            <a:endParaRPr lang="en-US" sz="1300" dirty="0"/>
+          </a:p>
+        </p:txBody>
+      </p:sp>
+      <p:sp>
+        <p:nvSpPr>
+          <p:cNvPr id="15" name="Shape 13"/>
+          <p:cNvSpPr/>
+          <p:nvPr/>
+        </p:nvSpPr>
+        <p:spPr>
+          <a:xfrm>
+            <a:off x="6217920" y="2468880"/>
+            <a:ext cx="5120640" cy="3017520"/>
+          </a:xfrm>
+          <a:prstGeom prst="rect">
+            <a:avLst/>
+          </a:prstGeom>
+          <a:solidFill>
+            <a:srgbClr val="F7F7F5"/>
+          </a:solidFill>
+          <a:ln w="12700">
+            <a:solidFill>
+              <a:srgbClr val="D8D8D5"/>
+            </a:solidFill>
+            <a:prstDash val="solid"/>
+          </a:ln>
+        </p:spPr>
+      </p:sp>
+      <p:sp>
+        <p:nvSpPr>
+          <p:cNvPr id="16" name="Text 14"/>
+          <p:cNvSpPr/>
+          <p:nvPr/>
+        </p:nvSpPr>
+        <p:spPr>
+          <a:xfrm>
+            <a:off x="6537960" y="2743200"/>
+            <a:ext cx="4480560" cy="457200"/>
+          </a:xfrm>
+          <a:prstGeom prst="rect">
+            <a:avLst/>
+          </a:prstGeom>
+          <a:noFill/>
+          <a:ln/>
+        </p:spPr>
+        <p:txBody>
+          <a:bodyPr wrap="square" lIns="0" tIns="0" rIns="0" bIns="0" rtlCol="0" anchor="ctr"/>
+          <a:lstStyle/>
+          <a:p>
+            <a:pPr indent="0" marL="0">
+              <a:buNone/>
+            </a:pPr>
+            <a:r>
+              <a:rPr lang="en-US" sz="1800" b="1" dirty="0">
+                <a:solidFill>
+                  <a:srgbClr val="1A1A1A"/>
+                </a:solidFill>
+                <a:latin typeface="Helvetica Neue" pitchFamily="34" charset="0"/>
+                <a:ea typeface="Helvetica Neue" pitchFamily="34" charset="-122"/>
+                <a:cs typeface="Helvetica Neue" pitchFamily="34" charset="-120"/>
+              </a:rPr>
+              <a:t>Mais Bubble m'aurait épargné</a:t>
+            </a:r>
+            <a:endParaRPr lang="en-US" sz="1800" dirty="0"/>
+          </a:p>
+        </p:txBody>
+      </p:sp>
+      <p:sp>
+        <p:nvSpPr>
+          <p:cNvPr id="17" name="Shape 15"/>
+          <p:cNvSpPr/>
+          <p:nvPr/>
+        </p:nvSpPr>
+        <p:spPr>
+          <a:xfrm>
+            <a:off x="6537960" y="3456432"/>
+            <a:ext cx="109728" cy="109728"/>
+          </a:xfrm>
+          <a:prstGeom prst="ellipse">
+            <a:avLst/>
+          </a:prstGeom>
+          <a:solidFill>
+            <a:srgbClr val="1A1A1A"/>
+          </a:solidFill>
+          <a:ln w="12700">
+            <a:solidFill>
+              <a:srgbClr val="1A1A1A"/>
+            </a:solidFill>
+            <a:prstDash val="solid"/>
+          </a:ln>
+        </p:spPr>
+      </p:sp>
+      <p:sp>
+        <p:nvSpPr>
+          <p:cNvPr id="18" name="Text 16"/>
+          <p:cNvSpPr/>
+          <p:nvPr/>
+        </p:nvSpPr>
+        <p:spPr>
+          <a:xfrm>
+            <a:off x="6766560" y="3337560"/>
+            <a:ext cx="4251960" cy="457200"/>
+          </a:xfrm>
+          <a:prstGeom prst="rect">
+            <a:avLst/>
+          </a:prstGeom>
+          <a:noFill/>
+          <a:ln/>
+        </p:spPr>
+        <p:txBody>
+          <a:bodyPr wrap="square" lIns="0" tIns="0" rIns="0" bIns="0" rtlCol="0" anchor="ctr"/>
+          <a:lstStyle/>
+          <a:p>
+            <a:pPr indent="0" marL="0">
+              <a:buNone/>
+            </a:pPr>
+            <a:r>
+              <a:rPr lang="en-US" sz="1300" dirty="0">
+                <a:solidFill>
+                  <a:srgbClr val="404040"/>
+                </a:solidFill>
+                <a:latin typeface="Helvetica Neue" pitchFamily="34" charset="0"/>
+                <a:ea typeface="Helvetica Neue" pitchFamily="34" charset="-122"/>
+                <a:cs typeface="Helvetica Neue" pitchFamily="34" charset="-120"/>
+              </a:rPr>
+              <a:t>L'authentification à la main</a:t>
+            </a:r>
+            <a:endParaRPr lang="en-US" sz="1300" dirty="0"/>
+          </a:p>
+        </p:txBody>
+      </p:sp>
+      <p:sp>
+        <p:nvSpPr>
+          <p:cNvPr id="19" name="Shape 17"/>
+          <p:cNvSpPr/>
+          <p:nvPr/>
+        </p:nvSpPr>
+        <p:spPr>
+          <a:xfrm>
+            <a:off x="6537960" y="3913632"/>
+            <a:ext cx="109728" cy="109728"/>
+          </a:xfrm>
+          <a:prstGeom prst="ellipse">
+            <a:avLst/>
+          </a:prstGeom>
+          <a:solidFill>
+            <a:srgbClr val="1A1A1A"/>
+          </a:solidFill>
+          <a:ln w="12700">
+            <a:solidFill>
+              <a:srgbClr val="1A1A1A"/>
+            </a:solidFill>
+            <a:prstDash val="solid"/>
+          </a:ln>
+        </p:spPr>
+      </p:sp>
+      <p:sp>
+        <p:nvSpPr>
+          <p:cNvPr id="20" name="Text 18"/>
+          <p:cNvSpPr/>
+          <p:nvPr/>
+        </p:nvSpPr>
+        <p:spPr>
+          <a:xfrm>
+            <a:off x="6766560" y="3794760"/>
+            <a:ext cx="4251960" cy="457200"/>
+          </a:xfrm>
+          <a:prstGeom prst="rect">
+            <a:avLst/>
+          </a:prstGeom>
+          <a:noFill/>
+          <a:ln/>
+        </p:spPr>
+        <p:txBody>
+          <a:bodyPr wrap="square" lIns="0" tIns="0" rIns="0" bIns="0" rtlCol="0" anchor="ctr"/>
+          <a:lstStyle/>
+          <a:p>
+            <a:pPr indent="0" marL="0">
+              <a:buNone/>
+            </a:pPr>
+            <a:r>
+              <a:rPr lang="en-US" sz="1300" dirty="0">
+                <a:solidFill>
+                  <a:srgbClr val="404040"/>
+                </a:solidFill>
+                <a:latin typeface="Helvetica Neue" pitchFamily="34" charset="0"/>
+                <a:ea typeface="Helvetica Neue" pitchFamily="34" charset="-122"/>
+                <a:cs typeface="Helvetica Neue" pitchFamily="34" charset="-120"/>
+              </a:rPr>
+              <a:t>La configuration du CI/CD</a:t>
+            </a:r>
+            <a:endParaRPr lang="en-US" sz="1300" dirty="0"/>
+          </a:p>
+        </p:txBody>
+      </p:sp>
+      <p:sp>
+        <p:nvSpPr>
+          <p:cNvPr id="21" name="Shape 19"/>
+          <p:cNvSpPr/>
+          <p:nvPr/>
+        </p:nvSpPr>
+        <p:spPr>
+          <a:xfrm>
+            <a:off x="6537960" y="4370832"/>
+            <a:ext cx="109728" cy="109728"/>
+          </a:xfrm>
+          <a:prstGeom prst="ellipse">
+            <a:avLst/>
+          </a:prstGeom>
+          <a:solidFill>
+            <a:srgbClr val="1A1A1A"/>
+          </a:solidFill>
+          <a:ln w="12700">
+            <a:solidFill>
+              <a:srgbClr val="1A1A1A"/>
+            </a:solidFill>
+            <a:prstDash val="solid"/>
+          </a:ln>
+        </p:spPr>
+      </p:sp>
+      <p:sp>
+        <p:nvSpPr>
+          <p:cNvPr id="22" name="Text 20"/>
+          <p:cNvSpPr/>
+          <p:nvPr/>
+        </p:nvSpPr>
+        <p:spPr>
+          <a:xfrm>
+            <a:off x="6766560" y="4251960"/>
+            <a:ext cx="4251960" cy="457200"/>
+          </a:xfrm>
+          <a:prstGeom prst="rect">
+            <a:avLst/>
+          </a:prstGeom>
+          <a:noFill/>
+          <a:ln/>
+        </p:spPr>
+        <p:txBody>
+          <a:bodyPr wrap="square" lIns="0" tIns="0" rIns="0" bIns="0" rtlCol="0" anchor="ctr"/>
+          <a:lstStyle/>
+          <a:p>
+            <a:pPr indent="0" marL="0">
+              <a:buNone/>
+            </a:pPr>
+            <a:r>
+              <a:rPr lang="en-US" sz="1300" dirty="0">
+                <a:solidFill>
+                  <a:srgbClr val="404040"/>
+                </a:solidFill>
+                <a:latin typeface="Helvetica Neue" pitchFamily="34" charset="0"/>
+                <a:ea typeface="Helvetica Neue" pitchFamily="34" charset="-122"/>
+                <a:cs typeface="Helvetica Neue" pitchFamily="34" charset="-120"/>
+              </a:rPr>
+              <a:t>Le debug à l'aveugle quand ça plante</a:t>
+            </a:r>
+            <a:endParaRPr lang="en-US" sz="1300" dirty="0"/>
+          </a:p>
+        </p:txBody>
+      </p:sp>
+      <p:sp>
+        <p:nvSpPr>
+          <p:cNvPr id="23" name="Shape 21"/>
+          <p:cNvSpPr/>
+          <p:nvPr/>
+        </p:nvSpPr>
+        <p:spPr>
+          <a:xfrm>
+            <a:off x="6537960" y="4828032"/>
+            <a:ext cx="109728" cy="109728"/>
+          </a:xfrm>
+          <a:prstGeom prst="ellipse">
+            <a:avLst/>
+          </a:prstGeom>
+          <a:solidFill>
+            <a:srgbClr val="1A1A1A"/>
+          </a:solidFill>
+          <a:ln w="12700">
+            <a:solidFill>
+              <a:srgbClr val="1A1A1A"/>
+            </a:solidFill>
+            <a:prstDash val="solid"/>
+          </a:ln>
+        </p:spPr>
+      </p:sp>
+      <p:sp>
+        <p:nvSpPr>
+          <p:cNvPr id="24" name="Text 22"/>
+          <p:cNvSpPr/>
+          <p:nvPr/>
+        </p:nvSpPr>
+        <p:spPr>
+          <a:xfrm>
+            <a:off x="6766560" y="4709160"/>
+            <a:ext cx="4251960" cy="457200"/>
+          </a:xfrm>
+          <a:prstGeom prst="rect">
+            <a:avLst/>
+          </a:prstGeom>
+          <a:noFill/>
+          <a:ln/>
+        </p:spPr>
+        <p:txBody>
+          <a:bodyPr wrap="square" lIns="0" tIns="0" rIns="0" bIns="0" rtlCol="0" anchor="ctr"/>
+          <a:lstStyle/>
+          <a:p>
+            <a:pPr indent="0" marL="0">
+              <a:buNone/>
+            </a:pPr>
+            <a:r>
+              <a:rPr lang="en-US" sz="1300" dirty="0">
+                <a:solidFill>
+                  <a:srgbClr val="404040"/>
+                </a:solidFill>
+                <a:latin typeface="Helvetica Neue" pitchFamily="34" charset="0"/>
+                <a:ea typeface="Helvetica Neue" pitchFamily="34" charset="-122"/>
+                <a:cs typeface="Helvetica Neue" pitchFamily="34" charset="-120"/>
+              </a:rPr>
+              <a:t>Le maintien d'un schéma de base à jour</a:t>
+            </a:r>
+            <a:endParaRPr lang="en-US" sz="1300" dirty="0"/>
+          </a:p>
+        </p:txBody>
+      </p:sp>
+      <p:sp>
+        <p:nvSpPr>
+          <p:cNvPr id="25" name="Text 23"/>
+          <p:cNvSpPr/>
+          <p:nvPr/>
+        </p:nvSpPr>
+        <p:spPr>
+          <a:xfrm>
+            <a:off x="640080" y="5943600"/>
+            <a:ext cx="10881360" cy="365760"/>
+          </a:xfrm>
+          <a:prstGeom prst="rect">
+            <a:avLst/>
+          </a:prstGeom>
+          <a:noFill/>
+          <a:ln/>
+        </p:spPr>
+        <p:txBody>
+          <a:bodyPr wrap="square" lIns="0" tIns="0" rIns="0" bIns="0" rtlCol="0" anchor="ctr"/>
+          <a:lstStyle/>
+          <a:p>
+            <a:pPr algn="ctr" indent="0" marL="0">
+              <a:buNone/>
+            </a:pPr>
+            <a:r>
+              <a:rPr lang="en-US" sz="1400" b="1" i="1" dirty="0">
+                <a:solidFill>
+                  <a:srgbClr val="1A1A1A"/>
+                </a:solidFill>
+                <a:latin typeface="Helvetica Neue" pitchFamily="34" charset="0"/>
+                <a:ea typeface="Helvetica Neue" pitchFamily="34" charset="-122"/>
+                <a:cs typeface="Helvetica Neue" pitchFamily="34" charset="-120"/>
+              </a:rPr>
+              <a:t>Le bon outil dépend du contexte.</a:t>
+            </a:r>
+            <a:endParaRPr lang="en-US" sz="1400" dirty="0"/>
+          </a:p>
+        </p:txBody>
+      </p:sp>
+      <p:sp>
+        <p:nvSpPr>
+          <p:cNvPr id="26" name="Text 24"/>
+          <p:cNvSpPr/>
+          <p:nvPr/>
+        </p:nvSpPr>
+        <p:spPr>
+          <a:xfrm>
+            <a:off x="10607040" y="6400800"/>
+            <a:ext cx="914400" cy="274320"/>
+          </a:xfrm>
+          <a:prstGeom prst="rect">
+            <a:avLst/>
+          </a:prstGeom>
+          <a:noFill/>
+          <a:ln/>
+        </p:spPr>
+        <p:txBody>
+          <a:bodyPr wrap="square" lIns="0" tIns="0" rIns="0" bIns="0" rtlCol="0" anchor="ctr"/>
+          <a:lstStyle/>
+          <a:p>
+            <a:pPr algn="r" indent="0" marL="0">
+              <a:buNone/>
+            </a:pPr>
+            <a:r>
+              <a:rPr lang="en-US" sz="900" dirty="0">
+                <a:solidFill>
+                  <a:srgbClr val="8A8A8A"/>
+                </a:solidFill>
+                <a:latin typeface="Helvetica Neue" pitchFamily="34" charset="0"/>
+                <a:ea typeface="Helvetica Neue" pitchFamily="34" charset="-122"/>
+                <a:cs typeface="Helvetica Neue" pitchFamily="34" charset="-120"/>
+              </a:rPr>
+              <a:t>14 / 15</a:t>
+            </a:r>
+            <a:endParaRPr lang="en-US" sz="900" dirty="0"/>
+          </a:p>
+        </p:txBody>
+      </p:sp>
+    </p:spTree>
+  </p:cSld>
+  <p:clrMapOvr>
+    <a:masterClrMapping/>
+  </p:clrMapOvr>
+</p:sld>
+</file>
+
+<file path=ppt/slides/slide15.xml><?xml version="1.0" encoding="utf-8"?>
+<p:sld xmlns:a="http://schemas.openxmlformats.org/drawingml/2006/main" xmlns:r="http://schemas.openxmlformats.org/officeDocument/2006/relationships" xmlns:p="http://schemas.openxmlformats.org/presentationml/2006/main">
+  <p:cSld name="Slide 15">
+    <p:bg>
+      <p:bgPr>
+        <a:solidFill>
+          <a:srgbClr val="FFFFFF"/>
+        </a:solidFill>
+      </p:bgPr>
+    </p:bg>
+    <p:spTree>
+      <p:nvGrpSpPr>
+        <p:cNvPr id="1" name=""/>
+        <p:cNvGrpSpPr/>
+        <p:nvPr/>
+      </p:nvGrpSpPr>
+      <p:grpSpPr>
+        <a:xfrm>
+          <a:off x="0" y="0"/>
+          <a:ext cx="0" cy="0"/>
+          <a:chOff x="0" y="0"/>
+          <a:chExt cx="0" cy="0"/>
+        </a:xfrm>
+      </p:grpSpPr>
+      <p:sp>
+        <p:nvSpPr>
+          <p:cNvPr id="2" name="Text 0"/>
+          <p:cNvSpPr/>
+          <p:nvPr/>
+        </p:nvSpPr>
+        <p:spPr>
+          <a:xfrm>
             <a:off x="0" y="2377440"/>
             <a:ext cx="12161520" cy="1463040"/>
           </a:xfrm>
@@ -5480,7 +6131,7 @@
                 <a:ea typeface="Helvetica Neue" pitchFamily="34" charset="-122"/>
                 <a:cs typeface="Helvetica Neue" pitchFamily="34" charset="-120"/>
               </a:rPr>
-              <a:t>02 / 14</a:t>
+              <a:t>02 / 15</a:t>
             </a:r>
             <a:endParaRPr lang="en-US" sz="900" dirty="0"/>
           </a:p>
@@ -6756,7 +7407,7 @@
                 <a:ea typeface="Helvetica Neue" pitchFamily="34" charset="-122"/>
                 <a:cs typeface="Helvetica Neue" pitchFamily="34" charset="-120"/>
               </a:rPr>
-              <a:t>04 / 14</a:t>
+              <a:t>04 / 15</a:t>
             </a:r>
             <a:endParaRPr lang="en-US" sz="900" dirty="0"/>
           </a:p>
@@ -7240,7 +7891,7 @@
                 <a:ea typeface="Helvetica Neue" pitchFamily="34" charset="-122"/>
                 <a:cs typeface="Helvetica Neue" pitchFamily="34" charset="-120"/>
               </a:rPr>
-              <a:t>05 / 14</a:t>
+              <a:t>05 / 15</a:t>
             </a:r>
             <a:endParaRPr lang="en-US" sz="900" dirty="0"/>
           </a:p>
@@ -7724,7 +8375,7 @@
                 <a:ea typeface="Helvetica Neue" pitchFamily="34" charset="-122"/>
                 <a:cs typeface="Helvetica Neue" pitchFamily="34" charset="-120"/>
               </a:rPr>
-              <a:t>06 / 14</a:t>
+              <a:t>06 / 15</a:t>
             </a:r>
             <a:endParaRPr lang="en-US" sz="900" dirty="0"/>
           </a:p>
@@ -8208,7 +8859,7 @@
                 <a:ea typeface="Helvetica Neue" pitchFamily="34" charset="-122"/>
                 <a:cs typeface="Helvetica Neue" pitchFamily="34" charset="-120"/>
               </a:rPr>
-              <a:t>07 / 14</a:t>
+              <a:t>07 / 15</a:t>
             </a:r>
             <a:endParaRPr lang="en-US" sz="900" dirty="0"/>
           </a:p>
@@ -8692,7 +9343,7 @@
                 <a:ea typeface="Helvetica Neue" pitchFamily="34" charset="-122"/>
                 <a:cs typeface="Helvetica Neue" pitchFamily="34" charset="-120"/>
               </a:rPr>
-              <a:t>08 / 14</a:t>
+              <a:t>08 / 15</a:t>
             </a:r>
             <a:endParaRPr lang="en-US" sz="900" dirty="0"/>
           </a:p>
@@ -9443,7 +10094,7 @@
                 <a:ea typeface="Helvetica Neue" pitchFamily="34" charset="-122"/>
                 <a:cs typeface="Helvetica Neue" pitchFamily="34" charset="-120"/>
               </a:rPr>
-              <a:t>09 / 14</a:t>
+              <a:t>09 / 15</a:t>
             </a:r>
             <a:endParaRPr lang="en-US" sz="900" dirty="0"/>
           </a:p>

</xml_diff>